<commit_message>
fix: remove pitch deck template placeholders
</commit_message>
<xml_diff>
--- a/PITCH DECK - MEMORY WITH A RECEIPT - FINAL.pptx
+++ b/PITCH DECK - MEMORY WITH A RECEIPT - FINAL.pptx
@@ -19643,62 +19643,6 @@
       </p:pic>
       <p:sp>
         <p:nvSpPr>
-          <p:cNvPr id="7" name="Title 6">
-            <a:extLst>
-              <a:ext uri="{FF2B5EF4-FFF2-40B4-BE49-F238E27FC236}">
-                <a16:creationId xmlns:a16="http://schemas.microsoft.com/office/drawing/2014/main" id="{9C522CE7-8601-4799-A188-72F4C128D33A}"/>
-              </a:ext>
-            </a:extLst>
-          </p:cNvPr>
-          <p:cNvSpPr>
-            <a:spLocks noGrp="1"/>
-          </p:cNvSpPr>
-          <p:nvPr>
-            <p:ph type="ctrTitle"/>
-          </p:nvPr>
-        </p:nvSpPr>
-        <p:spPr>
-          <a:xfrm>
-            <a:off x="838200" y="4636008"/>
-            <a:ext cx="9144000" cy="1107959"/>
-          </a:xfrm>
-        </p:spPr>
-        <p:txBody>
-          <a:bodyPr anchor="b"/>
-          <a:lstStyle/>
-          <a:p/>
-        </p:txBody>
-      </p:sp>
-      <p:sp>
-        <p:nvSpPr>
-          <p:cNvPr id="5" name="Text Placeholder 4">
-            <a:extLst>
-              <a:ext uri="{FF2B5EF4-FFF2-40B4-BE49-F238E27FC236}">
-                <a16:creationId xmlns:a16="http://schemas.microsoft.com/office/drawing/2014/main" id="{3B95A575-4944-44FE-8343-886F3F62894C}"/>
-              </a:ext>
-            </a:extLst>
-          </p:cNvPr>
-          <p:cNvSpPr>
-            <a:spLocks noGrp="1"/>
-          </p:cNvSpPr>
-          <p:nvPr>
-            <p:ph type="body" sz="quarter" idx="13"/>
-          </p:nvPr>
-        </p:nvSpPr>
-        <p:spPr>
-          <a:xfrm>
-            <a:off x="841248" y="5742432"/>
-            <a:ext cx="7953375" cy="457200"/>
-          </a:xfrm>
-        </p:spPr>
-        <p:txBody>
-          <a:bodyPr/>
-          <a:lstStyle/>
-          <a:p/>
-        </p:txBody>
-      </p:sp>
-      <p:sp>
-        <p:nvSpPr>
           <p:cNvPr id="9" name="TextBox 8"/>
           <p:cNvSpPr txBox="1"/>
           <p:nvPr/>
@@ -19903,232 +19847,6 @@
       </p:pic>
       <p:sp>
         <p:nvSpPr>
-          <p:cNvPr id="4" name="Title 3">
-            <a:extLst>
-              <a:ext uri="{FF2B5EF4-FFF2-40B4-BE49-F238E27FC236}">
-                <a16:creationId xmlns:a16="http://schemas.microsoft.com/office/drawing/2014/main" id="{FAD2AE59-5630-4D5C-83A9-4CDEF4D7DCFB}"/>
-              </a:ext>
-            </a:extLst>
-          </p:cNvPr>
-          <p:cNvSpPr>
-            <a:spLocks noGrp="1"/>
-          </p:cNvSpPr>
-          <p:nvPr>
-            <p:ph type="title"/>
-          </p:nvPr>
-        </p:nvSpPr>
-        <p:spPr>
-          <a:xfrm>
-            <a:off x="3383280" y="365125"/>
-            <a:ext cx="7894320" cy="1325563"/>
-          </a:xfrm>
-        </p:spPr>
-        <p:txBody>
-          <a:bodyPr/>
-          <a:lstStyle/>
-          <a:p/>
-        </p:txBody>
-      </p:sp>
-      <p:sp>
-        <p:nvSpPr>
-          <p:cNvPr id="5" name="Text Placeholder 4">
-            <a:extLst>
-              <a:ext uri="{FF2B5EF4-FFF2-40B4-BE49-F238E27FC236}">
-                <a16:creationId xmlns:a16="http://schemas.microsoft.com/office/drawing/2014/main" id="{F8657664-A458-4DDD-ACC2-1D87FCD6FCA9}"/>
-              </a:ext>
-            </a:extLst>
-          </p:cNvPr>
-          <p:cNvSpPr>
-            <a:spLocks noGrp="1"/>
-          </p:cNvSpPr>
-          <p:nvPr>
-            <p:ph type="body" sz="quarter" idx="25"/>
-          </p:nvPr>
-        </p:nvSpPr>
-        <p:spPr>
-          <a:xfrm>
-            <a:off x="3048000" y="1690688"/>
-            <a:ext cx="9144000" cy="3886200"/>
-          </a:xfrm>
-        </p:spPr>
-        <p:txBody>
-          <a:bodyPr/>
-          <a:lstStyle/>
-          <a:p/>
-        </p:txBody>
-      </p:sp>
-      <p:sp>
-        <p:nvSpPr>
-          <p:cNvPr id="10" name="Content Placeholder 9">
-            <a:extLst>
-              <a:ext uri="{FF2B5EF4-FFF2-40B4-BE49-F238E27FC236}">
-                <a16:creationId xmlns:a16="http://schemas.microsoft.com/office/drawing/2014/main" id="{14671EBE-B721-4278-A276-75F44D556D20}"/>
-              </a:ext>
-            </a:extLst>
-          </p:cNvPr>
-          <p:cNvSpPr>
-            <a:spLocks noGrp="1"/>
-          </p:cNvSpPr>
-          <p:nvPr>
-            <p:ph sz="half" idx="2"/>
-          </p:nvPr>
-        </p:nvSpPr>
-        <p:spPr>
-          <a:xfrm>
-            <a:off x="3392488" y="2686050"/>
-            <a:ext cx="3657600" cy="2743200"/>
-          </a:xfrm>
-        </p:spPr>
-        <p:txBody>
-          <a:bodyPr/>
-          <a:lstStyle/>
-          <a:p/>
-        </p:txBody>
-      </p:sp>
-      <p:sp>
-        <p:nvSpPr>
-          <p:cNvPr id="7" name="Text Placeholder 6">
-            <a:extLst>
-              <a:ext uri="{FF2B5EF4-FFF2-40B4-BE49-F238E27FC236}">
-                <a16:creationId xmlns:a16="http://schemas.microsoft.com/office/drawing/2014/main" id="{578017FE-712E-4E95-B483-B700F1AA4B2A}"/>
-              </a:ext>
-            </a:extLst>
-          </p:cNvPr>
-          <p:cNvSpPr>
-            <a:spLocks noGrp="1"/>
-          </p:cNvSpPr>
-          <p:nvPr>
-            <p:ph type="body" sz="quarter" idx="3"/>
-          </p:nvPr>
-        </p:nvSpPr>
-        <p:spPr>
-          <a:xfrm>
-            <a:off x="7629525" y="1919288"/>
-            <a:ext cx="3657600" cy="640080"/>
-          </a:xfrm>
-        </p:spPr>
-        <p:txBody>
-          <a:bodyPr/>
-          <a:lstStyle/>
-          <a:p/>
-        </p:txBody>
-      </p:sp>
-      <p:sp>
-        <p:nvSpPr>
-          <p:cNvPr id="2" name="Content Placeholder 1">
-            <a:extLst>
-              <a:ext uri="{FF2B5EF4-FFF2-40B4-BE49-F238E27FC236}">
-                <a16:creationId xmlns:a16="http://schemas.microsoft.com/office/drawing/2014/main" id="{2972E633-D3D4-4B6D-909F-937FED844C4A}"/>
-              </a:ext>
-            </a:extLst>
-          </p:cNvPr>
-          <p:cNvSpPr>
-            <a:spLocks noGrp="1"/>
-          </p:cNvSpPr>
-          <p:nvPr>
-            <p:ph sz="quarter" idx="4"/>
-          </p:nvPr>
-        </p:nvSpPr>
-        <p:spPr>
-          <a:xfrm>
-            <a:off x="7629525" y="2686050"/>
-            <a:ext cx="3657600" cy="2743200"/>
-          </a:xfrm>
-        </p:spPr>
-        <p:txBody>
-          <a:bodyPr/>
-          <a:lstStyle/>
-          <a:p/>
-        </p:txBody>
-      </p:sp>
-      <p:sp>
-        <p:nvSpPr>
-          <p:cNvPr id="22" name="Date Placeholder 21">
-            <a:extLst>
-              <a:ext uri="{FF2B5EF4-FFF2-40B4-BE49-F238E27FC236}">
-                <a16:creationId xmlns:a16="http://schemas.microsoft.com/office/drawing/2014/main" id="{0892EE2B-E8C5-4129-9850-04151ED0A218}"/>
-              </a:ext>
-            </a:extLst>
-          </p:cNvPr>
-          <p:cNvSpPr>
-            <a:spLocks noGrp="1"/>
-          </p:cNvSpPr>
-          <p:nvPr>
-            <p:ph type="dt" sz="half" idx="10"/>
-          </p:nvPr>
-        </p:nvSpPr>
-        <p:spPr>
-          <a:xfrm>
-            <a:off x="838200" y="6356350"/>
-            <a:ext cx="2743200" cy="365125"/>
-          </a:xfrm>
-        </p:spPr>
-        <p:txBody>
-          <a:bodyPr/>
-          <a:lstStyle/>
-          <a:p/>
-        </p:txBody>
-      </p:sp>
-      <p:sp>
-        <p:nvSpPr>
-          <p:cNvPr id="23" name="Footer Placeholder 22">
-            <a:extLst>
-              <a:ext uri="{FF2B5EF4-FFF2-40B4-BE49-F238E27FC236}">
-                <a16:creationId xmlns:a16="http://schemas.microsoft.com/office/drawing/2014/main" id="{B5D1873B-E191-492D-8A88-5BC543251AA4}"/>
-              </a:ext>
-            </a:extLst>
-          </p:cNvPr>
-          <p:cNvSpPr>
-            <a:spLocks noGrp="1"/>
-          </p:cNvSpPr>
-          <p:nvPr>
-            <p:ph type="ftr" sz="quarter" idx="11"/>
-          </p:nvPr>
-        </p:nvSpPr>
-        <p:spPr>
-          <a:xfrm>
-            <a:off x="4038600" y="6356350"/>
-            <a:ext cx="4114800" cy="365125"/>
-          </a:xfrm>
-        </p:spPr>
-        <p:txBody>
-          <a:bodyPr/>
-          <a:lstStyle/>
-          <a:p/>
-        </p:txBody>
-      </p:sp>
-      <p:sp>
-        <p:nvSpPr>
-          <p:cNvPr id="24" name="Slide Number Placeholder 23">
-            <a:extLst>
-              <a:ext uri="{FF2B5EF4-FFF2-40B4-BE49-F238E27FC236}">
-                <a16:creationId xmlns:a16="http://schemas.microsoft.com/office/drawing/2014/main" id="{4D55AB81-8A4D-4B4A-8B0F-A7407C695E33}"/>
-              </a:ext>
-            </a:extLst>
-          </p:cNvPr>
-          <p:cNvSpPr>
-            <a:spLocks noGrp="1"/>
-          </p:cNvSpPr>
-          <p:nvPr>
-            <p:ph type="sldNum" sz="quarter" idx="12"/>
-          </p:nvPr>
-        </p:nvSpPr>
-        <p:spPr>
-          <a:xfrm>
-            <a:off x="8610600" y="6356350"/>
-            <a:ext cx="2743200" cy="365125"/>
-          </a:xfrm>
-        </p:spPr>
-        <p:txBody>
-          <a:bodyPr/>
-          <a:lstStyle/>
-          <a:p>
-            <a:endParaRPr lang="en-US" dirty="0"/>
-          </a:p>
-        </p:txBody>
-      </p:sp>
-      <p:sp>
-        <p:nvSpPr>
           <p:cNvPr id="15" name="Rectangle 14">
             <a:extLst>
               <a:ext uri="{FF2B5EF4-FFF2-40B4-BE49-F238E27FC236}">
@@ -20184,7 +19902,7 @@
       </p:sp>
       <p:sp>
         <p:nvSpPr>
-          <p:cNvPr id="25" name="TextBox 24"/>
+          <p:cNvPr id="16" name="TextBox 15"/>
           <p:cNvSpPr txBox="1"/>
           <p:nvPr/>
         </p:nvSpPr>
@@ -20219,7 +19937,7 @@
       </p:sp>
       <p:sp>
         <p:nvSpPr>
-          <p:cNvPr id="26" name="TextBox 25"/>
+          <p:cNvPr id="17" name="TextBox 16"/>
           <p:cNvSpPr txBox="1"/>
           <p:nvPr/>
         </p:nvSpPr>
@@ -20254,7 +19972,7 @@
       </p:sp>
       <p:sp>
         <p:nvSpPr>
-          <p:cNvPr id="27" name="TextBox 26"/>
+          <p:cNvPr id="18" name="TextBox 17"/>
           <p:cNvSpPr txBox="1"/>
           <p:nvPr/>
         </p:nvSpPr>
@@ -20289,7 +20007,7 @@
       </p:sp>
       <p:sp>
         <p:nvSpPr>
-          <p:cNvPr id="28" name="TextBox 27"/>
+          <p:cNvPr id="19" name="TextBox 18"/>
           <p:cNvSpPr txBox="1"/>
           <p:nvPr/>
         </p:nvSpPr>
@@ -20324,7 +20042,7 @@
       </p:sp>
       <p:sp>
         <p:nvSpPr>
-          <p:cNvPr id="29" name="TextBox 28"/>
+          <p:cNvPr id="20" name="TextBox 19"/>
           <p:cNvSpPr txBox="1"/>
           <p:nvPr/>
         </p:nvSpPr>
@@ -20359,7 +20077,7 @@
       </p:sp>
       <p:sp>
         <p:nvSpPr>
-          <p:cNvPr id="30" name="TextBox 29"/>
+          <p:cNvPr id="21" name="TextBox 20"/>
           <p:cNvSpPr txBox="1"/>
           <p:nvPr/>
         </p:nvSpPr>
@@ -20394,7 +20112,7 @@
       </p:sp>
       <p:cxnSp>
         <p:nvCxnSpPr>
-          <p:cNvPr id="31" name="Connector 30"/>
+          <p:cNvPr id="22" name="Connector 21"/>
           <p:cNvCxnSpPr/>
           <p:nvPr/>
         </p:nvCxnSpPr>
@@ -20429,7 +20147,7 @@
       </p:cxnSp>
       <p:sp>
         <p:nvSpPr>
-          <p:cNvPr id="32" name="TextBox 31"/>
+          <p:cNvPr id="23" name="TextBox 22"/>
           <p:cNvSpPr txBox="1"/>
           <p:nvPr/>
         </p:nvSpPr>
@@ -20464,7 +20182,7 @@
       </p:sp>
       <p:sp>
         <p:nvSpPr>
-          <p:cNvPr id="33" name="TextBox 32"/>
+          <p:cNvPr id="24" name="TextBox 23"/>
           <p:cNvSpPr txBox="1"/>
           <p:nvPr/>
         </p:nvSpPr>
@@ -20499,7 +20217,7 @@
       </p:sp>
       <p:cxnSp>
         <p:nvCxnSpPr>
-          <p:cNvPr id="34" name="Connector 33"/>
+          <p:cNvPr id="25" name="Connector 24"/>
           <p:cNvCxnSpPr/>
           <p:nvPr/>
         </p:nvCxnSpPr>
@@ -20534,7 +20252,7 @@
       </p:cxnSp>
       <p:sp>
         <p:nvSpPr>
-          <p:cNvPr id="35" name="TextBox 34"/>
+          <p:cNvPr id="26" name="TextBox 25"/>
           <p:cNvSpPr txBox="1"/>
           <p:nvPr/>
         </p:nvSpPr>
@@ -20569,7 +20287,7 @@
       </p:sp>
       <p:sp>
         <p:nvSpPr>
-          <p:cNvPr id="36" name="TextBox 35"/>
+          <p:cNvPr id="27" name="TextBox 26"/>
           <p:cNvSpPr txBox="1"/>
           <p:nvPr/>
         </p:nvSpPr>
@@ -20604,7 +20322,7 @@
       </p:sp>
       <p:cxnSp>
         <p:nvCxnSpPr>
-          <p:cNvPr id="37" name="Connector 36"/>
+          <p:cNvPr id="28" name="Connector 27"/>
           <p:cNvCxnSpPr/>
           <p:nvPr/>
         </p:nvCxnSpPr>
@@ -20639,7 +20357,7 @@
       </p:cxnSp>
       <p:sp>
         <p:nvSpPr>
-          <p:cNvPr id="38" name="TextBox 37"/>
+          <p:cNvPr id="29" name="TextBox 28"/>
           <p:cNvSpPr txBox="1"/>
           <p:nvPr/>
         </p:nvSpPr>
@@ -20674,7 +20392,7 @@
       </p:sp>
       <p:sp>
         <p:nvSpPr>
-          <p:cNvPr id="39" name="TextBox 38"/>
+          <p:cNvPr id="30" name="TextBox 29"/>
           <p:cNvSpPr txBox="1"/>
           <p:nvPr/>
         </p:nvSpPr>
@@ -20709,7 +20427,7 @@
       </p:sp>
       <p:cxnSp>
         <p:nvCxnSpPr>
-          <p:cNvPr id="40" name="Connector 39"/>
+          <p:cNvPr id="31" name="Connector 30"/>
           <p:cNvCxnSpPr/>
           <p:nvPr/>
         </p:nvCxnSpPr>
@@ -20744,7 +20462,7 @@
       </p:cxnSp>
       <p:sp>
         <p:nvSpPr>
-          <p:cNvPr id="41" name="TextBox 40"/>
+          <p:cNvPr id="32" name="TextBox 31"/>
           <p:cNvSpPr txBox="1"/>
           <p:nvPr/>
         </p:nvSpPr>
@@ -20779,7 +20497,7 @@
       </p:sp>
       <p:sp>
         <p:nvSpPr>
-          <p:cNvPr id="42" name="TextBox 41"/>
+          <p:cNvPr id="33" name="TextBox 32"/>
           <p:cNvSpPr txBox="1"/>
           <p:nvPr/>
         </p:nvSpPr>
@@ -20814,7 +20532,7 @@
       </p:sp>
       <p:cxnSp>
         <p:nvCxnSpPr>
-          <p:cNvPr id="43" name="Connector 42"/>
+          <p:cNvPr id="34" name="Connector 33"/>
           <p:cNvCxnSpPr/>
           <p:nvPr/>
         </p:nvCxnSpPr>
@@ -20849,7 +20567,7 @@
       </p:cxnSp>
       <p:sp>
         <p:nvSpPr>
-          <p:cNvPr id="44" name="TextBox 43"/>
+          <p:cNvPr id="35" name="TextBox 34"/>
           <p:cNvSpPr txBox="1"/>
           <p:nvPr/>
         </p:nvSpPr>
@@ -20884,7 +20602,7 @@
       </p:sp>
       <p:sp>
         <p:nvSpPr>
-          <p:cNvPr id="45" name="TextBox 44"/>
+          <p:cNvPr id="36" name="TextBox 35"/>
           <p:cNvSpPr txBox="1"/>
           <p:nvPr/>
         </p:nvSpPr>
@@ -20919,7 +20637,7 @@
       </p:sp>
       <p:sp>
         <p:nvSpPr>
-          <p:cNvPr id="46" name="TextBox 45"/>
+          <p:cNvPr id="37" name="TextBox 36"/>
           <p:cNvSpPr txBox="1"/>
           <p:nvPr/>
         </p:nvSpPr>
@@ -20954,7 +20672,7 @@
       </p:sp>
       <p:sp>
         <p:nvSpPr>
-          <p:cNvPr id="47" name="TextBox 46"/>
+          <p:cNvPr id="38" name="TextBox 37"/>
           <p:cNvSpPr txBox="1"/>
           <p:nvPr/>
         </p:nvSpPr>
@@ -21053,320 +20771,7 @@
       </p:pic>
       <p:sp>
         <p:nvSpPr>
-          <p:cNvPr id="2" name="Title 1">
-            <a:extLst>
-              <a:ext uri="{FF2B5EF4-FFF2-40B4-BE49-F238E27FC236}">
-                <a16:creationId xmlns:a16="http://schemas.microsoft.com/office/drawing/2014/main" id="{39605AF1-623C-4E09-AB5D-8DD0571489F6}"/>
-              </a:ext>
-            </a:extLst>
-          </p:cNvPr>
-          <p:cNvSpPr>
-            <a:spLocks noGrp="1"/>
-          </p:cNvSpPr>
-          <p:nvPr>
-            <p:ph type="title"/>
-          </p:nvPr>
-        </p:nvSpPr>
-        <p:spPr>
-          <a:xfrm>
-            <a:off x="838200" y="365125"/>
-            <a:ext cx="10515600" cy="1325563"/>
-          </a:xfrm>
-        </p:spPr>
-        <p:txBody>
-          <a:bodyPr/>
-          <a:lstStyle/>
-          <a:p/>
-        </p:txBody>
-      </p:sp>
-      <p:sp>
-        <p:nvSpPr>
-          <p:cNvPr id="16" name="Text Placeholder 15">
-            <a:extLst>
-              <a:ext uri="{FF2B5EF4-FFF2-40B4-BE49-F238E27FC236}">
-                <a16:creationId xmlns:a16="http://schemas.microsoft.com/office/drawing/2014/main" id="{7A222B6F-BB67-4A4C-8885-56E895268E02}"/>
-              </a:ext>
-            </a:extLst>
-          </p:cNvPr>
-          <p:cNvSpPr>
-            <a:spLocks noGrp="1"/>
-          </p:cNvSpPr>
-          <p:nvPr>
-            <p:ph type="body" sz="quarter" idx="39"/>
-          </p:nvPr>
-        </p:nvSpPr>
-        <p:spPr>
-          <a:xfrm>
-            <a:off x="1066800" y="1525143"/>
-            <a:ext cx="10058400" cy="548640"/>
-          </a:xfrm>
-        </p:spPr>
-        <p:txBody>
-          <a:bodyPr>
-            <a:normAutofit/>
-          </a:bodyPr>
-          <a:lstStyle/>
-          <a:p/>
-        </p:txBody>
-      </p:sp>
-      <p:sp>
-        <p:nvSpPr>
-          <p:cNvPr id="79" name="Text Placeholder 78">
-            <a:extLst>
-              <a:ext uri="{FF2B5EF4-FFF2-40B4-BE49-F238E27FC236}">
-                <a16:creationId xmlns:a16="http://schemas.microsoft.com/office/drawing/2014/main" id="{A7DD34AA-E48A-47B4-BD20-EA3CBB161EDB}"/>
-              </a:ext>
-            </a:extLst>
-          </p:cNvPr>
-          <p:cNvSpPr>
-            <a:spLocks noGrp="1"/>
-          </p:cNvSpPr>
-          <p:nvPr>
-            <p:ph type="body" sz="quarter" idx="41"/>
-          </p:nvPr>
-        </p:nvSpPr>
-        <p:spPr/>
-        <p:txBody>
-          <a:bodyPr/>
-          <a:lstStyle/>
-          <a:p/>
-        </p:txBody>
-      </p:sp>
-      <p:sp>
-        <p:nvSpPr>
-          <p:cNvPr id="10" name="Text Placeholder 9">
-            <a:extLst>
-              <a:ext uri="{FF2B5EF4-FFF2-40B4-BE49-F238E27FC236}">
-                <a16:creationId xmlns:a16="http://schemas.microsoft.com/office/drawing/2014/main" id="{BAD4C9E1-F442-4E77-AD43-98B4169C160C}"/>
-              </a:ext>
-            </a:extLst>
-          </p:cNvPr>
-          <p:cNvSpPr>
-            <a:spLocks noGrp="1"/>
-          </p:cNvSpPr>
-          <p:nvPr>
-            <p:ph type="body" sz="quarter" idx="34"/>
-          </p:nvPr>
-        </p:nvSpPr>
-        <p:spPr>
-          <a:xfrm>
-            <a:off x="1673352" y="3584448"/>
-            <a:ext cx="2468880" cy="1371600"/>
-          </a:xfrm>
-        </p:spPr>
-        <p:txBody>
-          <a:bodyPr>
-            <a:normAutofit/>
-          </a:bodyPr>
-          <a:lstStyle/>
-          <a:p/>
-        </p:txBody>
-      </p:sp>
-      <p:sp>
-        <p:nvSpPr>
-          <p:cNvPr id="11" name="Text Placeholder 10">
-            <a:extLst>
-              <a:ext uri="{FF2B5EF4-FFF2-40B4-BE49-F238E27FC236}">
-                <a16:creationId xmlns:a16="http://schemas.microsoft.com/office/drawing/2014/main" id="{BC314248-E087-48C3-891A-BF11C1EE1F0B}"/>
-              </a:ext>
-            </a:extLst>
-          </p:cNvPr>
-          <p:cNvSpPr>
-            <a:spLocks noGrp="1"/>
-          </p:cNvSpPr>
-          <p:nvPr>
-            <p:ph type="body" sz="quarter" idx="42"/>
-          </p:nvPr>
-        </p:nvSpPr>
-        <p:spPr>
-          <a:xfrm>
-            <a:off x="4636008" y="2697587"/>
-            <a:ext cx="2926080" cy="2505345"/>
-          </a:xfrm>
-        </p:spPr>
-        <p:txBody>
-          <a:bodyPr/>
-          <a:lstStyle/>
-          <a:p/>
-        </p:txBody>
-      </p:sp>
-      <p:sp>
-        <p:nvSpPr>
-          <p:cNvPr id="12" name="Text Placeholder 11">
-            <a:extLst>
-              <a:ext uri="{FF2B5EF4-FFF2-40B4-BE49-F238E27FC236}">
-                <a16:creationId xmlns:a16="http://schemas.microsoft.com/office/drawing/2014/main" id="{16D8C892-AFAE-46DF-8A54-B8C979482F0F}"/>
-              </a:ext>
-            </a:extLst>
-          </p:cNvPr>
-          <p:cNvSpPr>
-            <a:spLocks noGrp="1"/>
-          </p:cNvSpPr>
-          <p:nvPr>
-            <p:ph type="body" sz="quarter" idx="36"/>
-          </p:nvPr>
-        </p:nvSpPr>
-        <p:spPr>
-          <a:xfrm>
-            <a:off x="4873775" y="3584448"/>
-            <a:ext cx="2468880" cy="1371600"/>
-          </a:xfrm>
-        </p:spPr>
-        <p:txBody>
-          <a:bodyPr>
-            <a:normAutofit/>
-          </a:bodyPr>
-          <a:lstStyle/>
-          <a:p/>
-        </p:txBody>
-      </p:sp>
-      <p:sp>
-        <p:nvSpPr>
-          <p:cNvPr id="13" name="Text Placeholder 12">
-            <a:extLst>
-              <a:ext uri="{FF2B5EF4-FFF2-40B4-BE49-F238E27FC236}">
-                <a16:creationId xmlns:a16="http://schemas.microsoft.com/office/drawing/2014/main" id="{41BDCA60-2625-4B36-96B1-2B050A7C734F}"/>
-              </a:ext>
-            </a:extLst>
-          </p:cNvPr>
-          <p:cNvSpPr>
-            <a:spLocks noGrp="1"/>
-          </p:cNvSpPr>
-          <p:nvPr>
-            <p:ph type="body" sz="quarter" idx="43"/>
-          </p:nvPr>
-        </p:nvSpPr>
-        <p:spPr>
-          <a:xfrm>
-            <a:off x="7790688" y="2697587"/>
-            <a:ext cx="2926080" cy="2505345"/>
-          </a:xfrm>
-        </p:spPr>
-        <p:txBody>
-          <a:bodyPr/>
-          <a:lstStyle/>
-          <a:p/>
-        </p:txBody>
-      </p:sp>
-      <p:sp>
-        <p:nvSpPr>
-          <p:cNvPr id="14" name="Text Placeholder 13">
-            <a:extLst>
-              <a:ext uri="{FF2B5EF4-FFF2-40B4-BE49-F238E27FC236}">
-                <a16:creationId xmlns:a16="http://schemas.microsoft.com/office/drawing/2014/main" id="{96255A71-CEF2-4F63-A0C4-DC367B56213B}"/>
-              </a:ext>
-            </a:extLst>
-          </p:cNvPr>
-          <p:cNvSpPr>
-            <a:spLocks noGrp="1"/>
-          </p:cNvSpPr>
-          <p:nvPr>
-            <p:ph type="body" sz="quarter" idx="38"/>
-          </p:nvPr>
-        </p:nvSpPr>
-        <p:spPr>
-          <a:xfrm>
-            <a:off x="8019288" y="3584448"/>
-            <a:ext cx="2468880" cy="1371600"/>
-          </a:xfrm>
-        </p:spPr>
-        <p:txBody>
-          <a:bodyPr>
-            <a:normAutofit/>
-          </a:bodyPr>
-          <a:lstStyle/>
-          <a:p/>
-        </p:txBody>
-      </p:sp>
-      <p:sp>
-        <p:nvSpPr>
-          <p:cNvPr id="4" name="Date Placeholder 3">
-            <a:extLst>
-              <a:ext uri="{FF2B5EF4-FFF2-40B4-BE49-F238E27FC236}">
-                <a16:creationId xmlns:a16="http://schemas.microsoft.com/office/drawing/2014/main" id="{0F96062A-F97D-488B-9454-8BCCA36C6DA0}"/>
-              </a:ext>
-            </a:extLst>
-          </p:cNvPr>
-          <p:cNvSpPr>
-            <a:spLocks noGrp="1"/>
-          </p:cNvSpPr>
-          <p:nvPr>
-            <p:ph type="dt" sz="half" idx="40"/>
-          </p:nvPr>
-        </p:nvSpPr>
-        <p:spPr>
-          <a:xfrm>
-            <a:off x="838200" y="6356350"/>
-            <a:ext cx="2743200" cy="365125"/>
-          </a:xfrm>
-        </p:spPr>
-        <p:txBody>
-          <a:bodyPr/>
-          <a:lstStyle/>
-          <a:p/>
-        </p:txBody>
-      </p:sp>
-      <p:sp>
-        <p:nvSpPr>
-          <p:cNvPr id="67" name="Footer Placeholder 66">
-            <a:extLst>
-              <a:ext uri="{FF2B5EF4-FFF2-40B4-BE49-F238E27FC236}">
-                <a16:creationId xmlns:a16="http://schemas.microsoft.com/office/drawing/2014/main" id="{354056BA-2CCC-4DA8-BF1E-8AE4C8114410}"/>
-              </a:ext>
-            </a:extLst>
-          </p:cNvPr>
-          <p:cNvSpPr>
-            <a:spLocks noGrp="1"/>
-          </p:cNvSpPr>
-          <p:nvPr>
-            <p:ph type="ftr" sz="quarter" idx="10"/>
-          </p:nvPr>
-        </p:nvSpPr>
-        <p:spPr>
-          <a:xfrm>
-            <a:off x="4038600" y="6356350"/>
-            <a:ext cx="4114800" cy="365125"/>
-          </a:xfrm>
-        </p:spPr>
-        <p:txBody>
-          <a:bodyPr/>
-          <a:lstStyle/>
-          <a:p/>
-        </p:txBody>
-      </p:sp>
-      <p:sp>
-        <p:nvSpPr>
-          <p:cNvPr id="68" name="Slide Number Placeholder 67">
-            <a:extLst>
-              <a:ext uri="{FF2B5EF4-FFF2-40B4-BE49-F238E27FC236}">
-                <a16:creationId xmlns:a16="http://schemas.microsoft.com/office/drawing/2014/main" id="{8CA60395-A3D9-469E-B191-FCFC5F5EE0B1}"/>
-              </a:ext>
-            </a:extLst>
-          </p:cNvPr>
-          <p:cNvSpPr>
-            <a:spLocks noGrp="1"/>
-          </p:cNvSpPr>
-          <p:nvPr>
-            <p:ph type="sldNum" sz="quarter" idx="11"/>
-          </p:nvPr>
-        </p:nvSpPr>
-        <p:spPr>
-          <a:xfrm>
-            <a:off x="8610600" y="6356350"/>
-            <a:ext cx="2743200" cy="365125"/>
-          </a:xfrm>
-        </p:spPr>
-        <p:txBody>
-          <a:bodyPr/>
-          <a:lstStyle/>
-          <a:p>
-            <a:endParaRPr lang="en-ZA" dirty="0"/>
-          </a:p>
-        </p:txBody>
-      </p:sp>
-      <p:sp>
-        <p:nvSpPr>
-          <p:cNvPr id="80" name="TextBox 79"/>
+          <p:cNvPr id="48" name="TextBox 47"/>
           <p:cNvSpPr txBox="1"/>
           <p:nvPr/>
         </p:nvSpPr>
@@ -21401,7 +20806,7 @@
       </p:sp>
       <p:sp>
         <p:nvSpPr>
-          <p:cNvPr id="81" name="TextBox 80"/>
+          <p:cNvPr id="49" name="TextBox 48"/>
           <p:cNvSpPr txBox="1"/>
           <p:nvPr/>
         </p:nvSpPr>
@@ -21436,7 +20841,7 @@
       </p:sp>
       <p:sp>
         <p:nvSpPr>
-          <p:cNvPr id="82" name="Rounded Rectangle 81"/>
+          <p:cNvPr id="50" name="Rounded Rectangle 49"/>
           <p:cNvSpPr/>
           <p:nvPr/>
         </p:nvSpPr>
@@ -21481,7 +20886,7 @@
       </p:sp>
       <p:sp>
         <p:nvSpPr>
-          <p:cNvPr id="83" name="Rectangle 82"/>
+          <p:cNvPr id="51" name="Rectangle 50"/>
           <p:cNvSpPr/>
           <p:nvPr/>
         </p:nvSpPr>
@@ -21526,7 +20931,7 @@
       </p:sp>
       <p:sp>
         <p:nvSpPr>
-          <p:cNvPr id="84" name="TextBox 83"/>
+          <p:cNvPr id="52" name="TextBox 51"/>
           <p:cNvSpPr txBox="1"/>
           <p:nvPr/>
         </p:nvSpPr>
@@ -21561,7 +20966,7 @@
       </p:sp>
       <p:sp>
         <p:nvSpPr>
-          <p:cNvPr id="85" name="TextBox 84"/>
+          <p:cNvPr id="53" name="TextBox 52"/>
           <p:cNvSpPr txBox="1"/>
           <p:nvPr/>
         </p:nvSpPr>
@@ -21598,7 +21003,7 @@
       </p:sp>
       <p:sp>
         <p:nvSpPr>
-          <p:cNvPr id="86" name="Rounded Rectangle 85"/>
+          <p:cNvPr id="54" name="Rounded Rectangle 53"/>
           <p:cNvSpPr/>
           <p:nvPr/>
         </p:nvSpPr>
@@ -21643,7 +21048,7 @@
       </p:sp>
       <p:sp>
         <p:nvSpPr>
-          <p:cNvPr id="87" name="Rectangle 86"/>
+          <p:cNvPr id="55" name="Rectangle 54"/>
           <p:cNvSpPr/>
           <p:nvPr/>
         </p:nvSpPr>
@@ -21688,7 +21093,7 @@
       </p:sp>
       <p:sp>
         <p:nvSpPr>
-          <p:cNvPr id="88" name="TextBox 87"/>
+          <p:cNvPr id="56" name="TextBox 55"/>
           <p:cNvSpPr txBox="1"/>
           <p:nvPr/>
         </p:nvSpPr>
@@ -21723,7 +21128,7 @@
       </p:sp>
       <p:sp>
         <p:nvSpPr>
-          <p:cNvPr id="89" name="TextBox 88"/>
+          <p:cNvPr id="57" name="TextBox 56"/>
           <p:cNvSpPr txBox="1"/>
           <p:nvPr/>
         </p:nvSpPr>
@@ -21761,7 +21166,7 @@
       </p:sp>
       <p:sp>
         <p:nvSpPr>
-          <p:cNvPr id="90" name="Rounded Rectangle 89"/>
+          <p:cNvPr id="58" name="Rounded Rectangle 57"/>
           <p:cNvSpPr/>
           <p:nvPr/>
         </p:nvSpPr>
@@ -21806,7 +21211,7 @@
       </p:sp>
       <p:sp>
         <p:nvSpPr>
-          <p:cNvPr id="91" name="Rectangle 90"/>
+          <p:cNvPr id="59" name="Rectangle 58"/>
           <p:cNvSpPr/>
           <p:nvPr/>
         </p:nvSpPr>
@@ -21851,7 +21256,7 @@
       </p:sp>
       <p:sp>
         <p:nvSpPr>
-          <p:cNvPr id="92" name="TextBox 91"/>
+          <p:cNvPr id="60" name="TextBox 59"/>
           <p:cNvSpPr txBox="1"/>
           <p:nvPr/>
         </p:nvSpPr>
@@ -21886,7 +21291,7 @@
       </p:sp>
       <p:sp>
         <p:nvSpPr>
-          <p:cNvPr id="93" name="TextBox 92"/>
+          <p:cNvPr id="61" name="TextBox 60"/>
           <p:cNvSpPr txBox="1"/>
           <p:nvPr/>
         </p:nvSpPr>
@@ -21923,7 +21328,7 @@
       </p:sp>
       <p:sp>
         <p:nvSpPr>
-          <p:cNvPr id="94" name="TextBox 93"/>
+          <p:cNvPr id="62" name="TextBox 61"/>
           <p:cNvSpPr txBox="1"/>
           <p:nvPr/>
         </p:nvSpPr>
@@ -21958,7 +21363,7 @@
       </p:sp>
       <p:sp>
         <p:nvSpPr>
-          <p:cNvPr id="95" name="TextBox 94"/>
+          <p:cNvPr id="63" name="TextBox 62"/>
           <p:cNvSpPr txBox="1"/>
           <p:nvPr/>
         </p:nvSpPr>
@@ -21993,7 +21398,7 @@
       </p:sp>
       <p:sp>
         <p:nvSpPr>
-          <p:cNvPr id="96" name="TextBox 95"/>
+          <p:cNvPr id="64" name="TextBox 63"/>
           <p:cNvSpPr txBox="1"/>
           <p:nvPr/>
         </p:nvSpPr>
@@ -22028,7 +21433,7 @@
       </p:sp>
       <p:sp>
         <p:nvSpPr>
-          <p:cNvPr id="97" name="TextBox 96"/>
+          <p:cNvPr id="65" name="TextBox 64"/>
           <p:cNvSpPr txBox="1"/>
           <p:nvPr/>
         </p:nvSpPr>
@@ -22063,7 +21468,7 @@
       </p:sp>
       <p:sp>
         <p:nvSpPr>
-          <p:cNvPr id="98" name="TextBox 97"/>
+          <p:cNvPr id="66" name="TextBox 65"/>
           <p:cNvSpPr txBox="1"/>
           <p:nvPr/>
         </p:nvSpPr>
@@ -22128,64 +21533,6 @@
       </p:grpSpPr>
       <p:sp>
         <p:nvSpPr>
-          <p:cNvPr id="2" name="Title 1">
-            <a:extLst>
-              <a:ext uri="{FF2B5EF4-FFF2-40B4-BE49-F238E27FC236}">
-                <a16:creationId xmlns:a16="http://schemas.microsoft.com/office/drawing/2014/main" id="{935C0770-A36E-4500-AA2E-F3DE8416AD1E}"/>
-              </a:ext>
-            </a:extLst>
-          </p:cNvPr>
-          <p:cNvSpPr>
-            <a:spLocks noGrp="1"/>
-          </p:cNvSpPr>
-          <p:nvPr>
-            <p:ph type="title"/>
-          </p:nvPr>
-        </p:nvSpPr>
-        <p:spPr>
-          <a:xfrm>
-            <a:off x="838200" y="365125"/>
-            <a:ext cx="10515600" cy="1325563"/>
-          </a:xfrm>
-        </p:spPr>
-        <p:txBody>
-          <a:bodyPr/>
-          <a:lstStyle/>
-          <a:p/>
-        </p:txBody>
-      </p:sp>
-      <p:sp>
-        <p:nvSpPr>
-          <p:cNvPr id="5" name="Text Placeholder 4">
-            <a:extLst>
-              <a:ext uri="{FF2B5EF4-FFF2-40B4-BE49-F238E27FC236}">
-                <a16:creationId xmlns:a16="http://schemas.microsoft.com/office/drawing/2014/main" id="{AB97FAAF-FD5C-4EDE-A2D8-148266453488}"/>
-              </a:ext>
-            </a:extLst>
-          </p:cNvPr>
-          <p:cNvSpPr>
-            <a:spLocks noGrp="1"/>
-          </p:cNvSpPr>
-          <p:nvPr>
-            <p:ph type="body" sz="quarter" idx="12"/>
-          </p:nvPr>
-        </p:nvSpPr>
-        <p:spPr>
-          <a:xfrm>
-            <a:off x="5109000" y="2130552"/>
-            <a:ext cx="2011680" cy="274320"/>
-          </a:xfrm>
-        </p:spPr>
-        <p:txBody>
-          <a:bodyPr>
-            <a:noAutofit/>
-          </a:bodyPr>
-          <a:lstStyle/>
-          <a:p/>
-        </p:txBody>
-      </p:sp>
-      <p:sp>
-        <p:nvSpPr>
           <p:cNvPr id="40" name="TextBox 39">
             <a:extLst>
               <a:ext uri="{FF2B5EF4-FFF2-40B4-BE49-F238E27FC236}">
@@ -22250,66 +21597,6 @@
       </p:sp>
       <p:sp>
         <p:nvSpPr>
-          <p:cNvPr id="7" name="Text Placeholder 6">
-            <a:extLst>
-              <a:ext uri="{FF2B5EF4-FFF2-40B4-BE49-F238E27FC236}">
-                <a16:creationId xmlns:a16="http://schemas.microsoft.com/office/drawing/2014/main" id="{E9C0C8B1-2DBC-40B1-BBA7-7B3D396478A1}"/>
-              </a:ext>
-            </a:extLst>
-          </p:cNvPr>
-          <p:cNvSpPr>
-            <a:spLocks noGrp="1"/>
-          </p:cNvSpPr>
-          <p:nvPr>
-            <p:ph type="body" sz="quarter" idx="14"/>
-          </p:nvPr>
-        </p:nvSpPr>
-        <p:spPr>
-          <a:xfrm>
-            <a:off x="841375" y="3252207"/>
-            <a:ext cx="2011363" cy="274638"/>
-          </a:xfrm>
-        </p:spPr>
-        <p:txBody>
-          <a:bodyPr>
-            <a:noAutofit/>
-          </a:bodyPr>
-          <a:lstStyle/>
-          <a:p/>
-        </p:txBody>
-      </p:sp>
-      <p:sp>
-        <p:nvSpPr>
-          <p:cNvPr id="8" name="Text Placeholder 7">
-            <a:extLst>
-              <a:ext uri="{FF2B5EF4-FFF2-40B4-BE49-F238E27FC236}">
-                <a16:creationId xmlns:a16="http://schemas.microsoft.com/office/drawing/2014/main" id="{B2F06784-6A30-4941-B70A-A58B611950D4}"/>
-              </a:ext>
-            </a:extLst>
-          </p:cNvPr>
-          <p:cNvSpPr>
-            <a:spLocks noGrp="1"/>
-          </p:cNvSpPr>
-          <p:nvPr>
-            <p:ph type="body" sz="quarter" idx="15"/>
-          </p:nvPr>
-        </p:nvSpPr>
-        <p:spPr>
-          <a:xfrm>
-            <a:off x="9345168" y="3273552"/>
-            <a:ext cx="2011680" cy="274320"/>
-          </a:xfrm>
-        </p:spPr>
-        <p:txBody>
-          <a:bodyPr>
-            <a:normAutofit lnSpcReduction="10000"/>
-          </a:bodyPr>
-          <a:lstStyle/>
-          <a:p/>
-        </p:txBody>
-      </p:sp>
-      <p:sp>
-        <p:nvSpPr>
           <p:cNvPr id="20" name="TextBox 19">
             <a:extLst>
               <a:ext uri="{FF2B5EF4-FFF2-40B4-BE49-F238E27FC236}">
@@ -22434,36 +21721,6 @@
           <a:p>
             <a:pPr algn="ctr"/>
           </a:p>
-        </p:txBody>
-      </p:sp>
-      <p:sp>
-        <p:nvSpPr>
-          <p:cNvPr id="6" name="Text Placeholder 5">
-            <a:extLst>
-              <a:ext uri="{FF2B5EF4-FFF2-40B4-BE49-F238E27FC236}">
-                <a16:creationId xmlns:a16="http://schemas.microsoft.com/office/drawing/2014/main" id="{7F0BD43D-EBFD-48E7-A1D3-EB9228D4C58B}"/>
-              </a:ext>
-            </a:extLst>
-          </p:cNvPr>
-          <p:cNvSpPr>
-            <a:spLocks noGrp="1"/>
-          </p:cNvSpPr>
-          <p:nvPr>
-            <p:ph type="body" sz="quarter" idx="13"/>
-          </p:nvPr>
-        </p:nvSpPr>
-        <p:spPr>
-          <a:xfrm>
-            <a:off x="5109000" y="5184648"/>
-            <a:ext cx="2011680" cy="274320"/>
-          </a:xfrm>
-        </p:spPr>
-        <p:txBody>
-          <a:bodyPr>
-            <a:normAutofit lnSpcReduction="10000"/>
-          </a:bodyPr>
-          <a:lstStyle/>
-          <a:p/>
         </p:txBody>
       </p:sp>
       <p:sp>
@@ -22818,93 +22075,7 @@
       </p:sp>
       <p:sp>
         <p:nvSpPr>
-          <p:cNvPr id="41" name="Date Placeholder 40">
-            <a:extLst>
-              <a:ext uri="{FF2B5EF4-FFF2-40B4-BE49-F238E27FC236}">
-                <a16:creationId xmlns:a16="http://schemas.microsoft.com/office/drawing/2014/main" id="{4AE1D161-46F9-4A99-81FE-3AA72B026138}"/>
-              </a:ext>
-            </a:extLst>
-          </p:cNvPr>
-          <p:cNvSpPr>
-            <a:spLocks noGrp="1"/>
-          </p:cNvSpPr>
-          <p:nvPr>
-            <p:ph type="dt" sz="half" idx="16"/>
-          </p:nvPr>
-        </p:nvSpPr>
-        <p:spPr>
-          <a:xfrm>
-            <a:off x="838200" y="6356350"/>
-            <a:ext cx="2743200" cy="365125"/>
-          </a:xfrm>
-        </p:spPr>
-        <p:txBody>
-          <a:bodyPr/>
-          <a:lstStyle/>
-          <a:p/>
-        </p:txBody>
-      </p:sp>
-      <p:sp>
-        <p:nvSpPr>
-          <p:cNvPr id="3" name="Footer Placeholder 2">
-            <a:extLst>
-              <a:ext uri="{FF2B5EF4-FFF2-40B4-BE49-F238E27FC236}">
-                <a16:creationId xmlns:a16="http://schemas.microsoft.com/office/drawing/2014/main" id="{2CC7E0A4-FE8E-4F7B-8370-1FA3484B6144}"/>
-              </a:ext>
-            </a:extLst>
-          </p:cNvPr>
-          <p:cNvSpPr>
-            <a:spLocks noGrp="1"/>
-          </p:cNvSpPr>
-          <p:nvPr>
-            <p:ph type="ftr" sz="quarter" idx="10"/>
-          </p:nvPr>
-        </p:nvSpPr>
-        <p:spPr>
-          <a:xfrm>
-            <a:off x="4038600" y="6356350"/>
-            <a:ext cx="4114800" cy="365125"/>
-          </a:xfrm>
-        </p:spPr>
-        <p:txBody>
-          <a:bodyPr/>
-          <a:lstStyle/>
-          <a:p/>
-        </p:txBody>
-      </p:sp>
-      <p:sp>
-        <p:nvSpPr>
-          <p:cNvPr id="4" name="Slide Number Placeholder 3">
-            <a:extLst>
-              <a:ext uri="{FF2B5EF4-FFF2-40B4-BE49-F238E27FC236}">
-                <a16:creationId xmlns:a16="http://schemas.microsoft.com/office/drawing/2014/main" id="{5CE495FC-7E0A-4342-A40D-3B65DCA780C6}"/>
-              </a:ext>
-            </a:extLst>
-          </p:cNvPr>
-          <p:cNvSpPr>
-            <a:spLocks noGrp="1"/>
-          </p:cNvSpPr>
-          <p:nvPr>
-            <p:ph type="sldNum" sz="quarter" idx="11"/>
-          </p:nvPr>
-        </p:nvSpPr>
-        <p:spPr>
-          <a:xfrm>
-            <a:off x="8610600" y="6356350"/>
-            <a:ext cx="2743200" cy="365125"/>
-          </a:xfrm>
-        </p:spPr>
-        <p:txBody>
-          <a:bodyPr/>
-          <a:lstStyle/>
-          <a:p>
-            <a:endParaRPr lang="en-ZA" dirty="0"/>
-          </a:p>
-        </p:txBody>
-      </p:sp>
-      <p:sp>
-        <p:nvSpPr>
-          <p:cNvPr id="42" name="Rectangle 41"/>
+          <p:cNvPr id="41" name="Rectangle 40"/>
           <p:cNvSpPr/>
           <p:nvPr/>
         </p:nvSpPr>
@@ -22949,7 +22120,7 @@
       </p:sp>
       <p:sp>
         <p:nvSpPr>
-          <p:cNvPr id="43" name="TextBox 42"/>
+          <p:cNvPr id="42" name="TextBox 41"/>
           <p:cNvSpPr txBox="1"/>
           <p:nvPr/>
         </p:nvSpPr>
@@ -22984,7 +22155,7 @@
       </p:sp>
       <p:sp>
         <p:nvSpPr>
-          <p:cNvPr id="44" name="TextBox 43"/>
+          <p:cNvPr id="43" name="TextBox 42"/>
           <p:cNvSpPr txBox="1"/>
           <p:nvPr/>
         </p:nvSpPr>
@@ -23019,7 +22190,7 @@
       </p:sp>
       <p:sp>
         <p:nvSpPr>
-          <p:cNvPr id="45" name="Oval 44"/>
+          <p:cNvPr id="44" name="Oval 43"/>
           <p:cNvSpPr/>
           <p:nvPr/>
         </p:nvSpPr>
@@ -23064,7 +22235,7 @@
       </p:sp>
       <p:sp>
         <p:nvSpPr>
-          <p:cNvPr id="46" name="TextBox 45"/>
+          <p:cNvPr id="45" name="TextBox 44"/>
           <p:cNvSpPr txBox="1"/>
           <p:nvPr/>
         </p:nvSpPr>
@@ -23100,7 +22271,7 @@
       </p:sp>
       <p:sp>
         <p:nvSpPr>
-          <p:cNvPr id="47" name="TextBox 46"/>
+          <p:cNvPr id="46" name="TextBox 45"/>
           <p:cNvSpPr txBox="1"/>
           <p:nvPr/>
         </p:nvSpPr>
@@ -23135,7 +22306,7 @@
       </p:sp>
       <p:sp>
         <p:nvSpPr>
-          <p:cNvPr id="48" name="Oval 47"/>
+          <p:cNvPr id="47" name="Oval 46"/>
           <p:cNvSpPr/>
           <p:nvPr/>
         </p:nvSpPr>
@@ -23180,7 +22351,7 @@
       </p:sp>
       <p:sp>
         <p:nvSpPr>
-          <p:cNvPr id="49" name="TextBox 48"/>
+          <p:cNvPr id="48" name="TextBox 47"/>
           <p:cNvSpPr txBox="1"/>
           <p:nvPr/>
         </p:nvSpPr>
@@ -23216,7 +22387,7 @@
       </p:sp>
       <p:sp>
         <p:nvSpPr>
-          <p:cNvPr id="50" name="TextBox 49"/>
+          <p:cNvPr id="49" name="TextBox 48"/>
           <p:cNvSpPr txBox="1"/>
           <p:nvPr/>
         </p:nvSpPr>
@@ -23251,7 +22422,7 @@
       </p:sp>
       <p:sp>
         <p:nvSpPr>
-          <p:cNvPr id="51" name="Oval 50"/>
+          <p:cNvPr id="50" name="Oval 49"/>
           <p:cNvSpPr/>
           <p:nvPr/>
         </p:nvSpPr>
@@ -23296,7 +22467,7 @@
       </p:sp>
       <p:sp>
         <p:nvSpPr>
-          <p:cNvPr id="52" name="TextBox 51"/>
+          <p:cNvPr id="51" name="TextBox 50"/>
           <p:cNvSpPr txBox="1"/>
           <p:nvPr/>
         </p:nvSpPr>
@@ -23332,7 +22503,7 @@
       </p:sp>
       <p:sp>
         <p:nvSpPr>
-          <p:cNvPr id="53" name="TextBox 52"/>
+          <p:cNvPr id="52" name="TextBox 51"/>
           <p:cNvSpPr txBox="1"/>
           <p:nvPr/>
         </p:nvSpPr>
@@ -23367,7 +22538,7 @@
       </p:sp>
       <p:sp>
         <p:nvSpPr>
-          <p:cNvPr id="54" name="Oval 53"/>
+          <p:cNvPr id="53" name="Oval 52"/>
           <p:cNvSpPr/>
           <p:nvPr/>
         </p:nvSpPr>
@@ -23412,7 +22583,7 @@
       </p:sp>
       <p:sp>
         <p:nvSpPr>
-          <p:cNvPr id="55" name="TextBox 54"/>
+          <p:cNvPr id="54" name="TextBox 53"/>
           <p:cNvSpPr txBox="1"/>
           <p:nvPr/>
         </p:nvSpPr>
@@ -23448,7 +22619,7 @@
       </p:sp>
       <p:sp>
         <p:nvSpPr>
-          <p:cNvPr id="56" name="TextBox 55"/>
+          <p:cNvPr id="55" name="TextBox 54"/>
           <p:cNvSpPr txBox="1"/>
           <p:nvPr/>
         </p:nvSpPr>
@@ -23481,6 +22652,41 @@
           </a:p>
         </p:txBody>
       </p:sp>
+      <p:cxnSp>
+        <p:nvCxnSpPr>
+          <p:cNvPr id="56" name="Connector 55"/>
+          <p:cNvCxnSpPr/>
+          <p:nvPr/>
+        </p:nvCxnSpPr>
+        <p:spPr>
+          <a:xfrm>
+            <a:off x="1874519" y="2322576"/>
+            <a:ext cx="1801368" cy="0"/>
+          </a:xfrm>
+          <a:prstGeom prst="line">
+            <a:avLst/>
+          </a:prstGeom>
+          <a:ln w="31750">
+            <a:solidFill>
+              <a:srgbClr val="0995A9"/>
+            </a:solidFill>
+          </a:ln>
+        </p:spPr>
+        <p:style>
+          <a:lnRef idx="2">
+            <a:schemeClr val="accent1"/>
+          </a:lnRef>
+          <a:fillRef idx="0">
+            <a:schemeClr val="accent1"/>
+          </a:fillRef>
+          <a:effectRef idx="1">
+            <a:schemeClr val="accent1"/>
+          </a:effectRef>
+          <a:fontRef idx="minor">
+            <a:schemeClr val="tx1"/>
+          </a:fontRef>
+        </p:style>
+      </p:cxnSp>
       <p:cxnSp>
         <p:nvCxnSpPr>
           <p:cNvPr id="57" name="Connector 56"/>
@@ -23489,7 +22695,7 @@
         </p:nvCxnSpPr>
         <p:spPr>
           <a:xfrm>
-            <a:off x="1874519" y="2322576"/>
+            <a:off x="4526280" y="2322576"/>
             <a:ext cx="1801368" cy="0"/>
           </a:xfrm>
           <a:prstGeom prst="line">
@@ -23524,7 +22730,7 @@
         </p:nvCxnSpPr>
         <p:spPr>
           <a:xfrm>
-            <a:off x="4526280" y="2322576"/>
+            <a:off x="7178040" y="2322576"/>
             <a:ext cx="1801368" cy="0"/>
           </a:xfrm>
           <a:prstGeom prst="line">
@@ -23551,44 +22757,9 @@
           </a:fontRef>
         </p:style>
       </p:cxnSp>
-      <p:cxnSp>
-        <p:nvCxnSpPr>
-          <p:cNvPr id="59" name="Connector 58"/>
-          <p:cNvCxnSpPr/>
-          <p:nvPr/>
-        </p:nvCxnSpPr>
-        <p:spPr>
-          <a:xfrm>
-            <a:off x="7178040" y="2322576"/>
-            <a:ext cx="1801368" cy="0"/>
-          </a:xfrm>
-          <a:prstGeom prst="line">
-            <a:avLst/>
-          </a:prstGeom>
-          <a:ln w="31750">
-            <a:solidFill>
-              <a:srgbClr val="0995A9"/>
-            </a:solidFill>
-          </a:ln>
-        </p:spPr>
-        <p:style>
-          <a:lnRef idx="2">
-            <a:schemeClr val="accent1"/>
-          </a:lnRef>
-          <a:fillRef idx="0">
-            <a:schemeClr val="accent1"/>
-          </a:fillRef>
-          <a:effectRef idx="1">
-            <a:schemeClr val="accent1"/>
-          </a:effectRef>
-          <a:fontRef idx="minor">
-            <a:schemeClr val="tx1"/>
-          </a:fontRef>
-        </p:style>
-      </p:cxnSp>
-      <p:sp>
-        <p:nvSpPr>
-          <p:cNvPr id="60" name="Rounded Rectangle 59"/>
+      <p:sp>
+        <p:nvSpPr>
+          <p:cNvPr id="59" name="Rounded Rectangle 58"/>
           <p:cNvSpPr/>
           <p:nvPr/>
         </p:nvSpPr>
@@ -23633,7 +22804,7 @@
       </p:sp>
       <p:sp>
         <p:nvSpPr>
-          <p:cNvPr id="61" name="TextBox 60"/>
+          <p:cNvPr id="60" name="TextBox 59"/>
           <p:cNvSpPr txBox="1"/>
           <p:nvPr/>
         </p:nvSpPr>
@@ -23668,7 +22839,7 @@
       </p:sp>
       <p:sp>
         <p:nvSpPr>
-          <p:cNvPr id="62" name="TextBox 61"/>
+          <p:cNvPr id="61" name="TextBox 60"/>
           <p:cNvSpPr txBox="1"/>
           <p:nvPr/>
         </p:nvSpPr>
@@ -23703,7 +22874,7 @@
       </p:sp>
       <p:sp>
         <p:nvSpPr>
-          <p:cNvPr id="63" name="TextBox 62"/>
+          <p:cNvPr id="62" name="TextBox 61"/>
           <p:cNvSpPr txBox="1"/>
           <p:nvPr/>
         </p:nvSpPr>
@@ -23738,7 +22909,7 @@
       </p:sp>
       <p:sp>
         <p:nvSpPr>
-          <p:cNvPr id="64" name="TextBox 63"/>
+          <p:cNvPr id="63" name="TextBox 62"/>
           <p:cNvSpPr txBox="1"/>
           <p:nvPr/>
         </p:nvSpPr>
@@ -23773,7 +22944,7 @@
       </p:sp>
       <p:sp>
         <p:nvSpPr>
-          <p:cNvPr id="65" name="TextBox 64"/>
+          <p:cNvPr id="64" name="TextBox 63"/>
           <p:cNvSpPr txBox="1"/>
           <p:nvPr/>
         </p:nvSpPr>
@@ -23838,74 +23009,6 @@
       </p:grpSpPr>
       <p:sp>
         <p:nvSpPr>
-          <p:cNvPr id="2" name="Title 1">
-            <a:extLst>
-              <a:ext uri="{FF2B5EF4-FFF2-40B4-BE49-F238E27FC236}">
-                <a16:creationId xmlns:a16="http://schemas.microsoft.com/office/drawing/2014/main" id="{16684294-49A0-4C63-A7D7-E3BF9E591F59}"/>
-              </a:ext>
-            </a:extLst>
-          </p:cNvPr>
-          <p:cNvSpPr>
-            <a:spLocks noGrp="1"/>
-          </p:cNvSpPr>
-          <p:nvPr>
-            <p:ph type="title"/>
-          </p:nvPr>
-        </p:nvSpPr>
-        <p:spPr>
-          <a:xfrm>
-            <a:off x="838200" y="365125"/>
-            <a:ext cx="10515600" cy="1325563"/>
-          </a:xfrm>
-        </p:spPr>
-        <p:txBody>
-          <a:bodyPr/>
-          <a:lstStyle/>
-          <a:p/>
-        </p:txBody>
-      </p:sp>
-      <p:sp>
-        <p:nvSpPr>
-          <p:cNvPr id="32" name="Text Placeholder 31">
-            <a:extLst>
-              <a:ext uri="{FF2B5EF4-FFF2-40B4-BE49-F238E27FC236}">
-                <a16:creationId xmlns:a16="http://schemas.microsoft.com/office/drawing/2014/main" id="{0830F660-D88D-4A5F-8F7C-44B1D5C8E661}"/>
-              </a:ext>
-            </a:extLst>
-          </p:cNvPr>
-          <p:cNvSpPr>
-            <a:spLocks noGrp="1"/>
-          </p:cNvSpPr>
-          <p:nvPr>
-            <p:ph type="body" sz="quarter" idx="59"/>
-          </p:nvPr>
-        </p:nvSpPr>
-        <p:spPr>
-          <a:xfrm>
-            <a:off x="2167128" y="2470398"/>
-            <a:ext cx="1828800" cy="696912"/>
-          </a:xfrm>
-          <a:noFill/>
-          <a:ln w="25400">
-            <a:solidFill>
-              <a:schemeClr val="accent3"/>
-            </a:solidFill>
-          </a:ln>
-        </p:spPr>
-        <p:txBody>
-          <a:bodyPr anchor="t" anchorCtr="0"/>
-          <a:lstStyle/>
-          <a:p>
-            <a:pPr>
-              <a:lnSpc>
-                <a:spcPct val="200000"/>
-              </a:lnSpc>
-            </a:pPr>
-          </a:p>
-        </p:txBody>
-      </p:sp>
-      <p:sp>
-        <p:nvSpPr>
           <p:cNvPr id="116" name="Text Placeholder 32">
             <a:extLst>
               <a:ext uri="{FF2B5EF4-FFF2-40B4-BE49-F238E27FC236}">
@@ -25188,398 +24291,6 @@
       </p:cxnSp>
       <p:sp>
         <p:nvSpPr>
-          <p:cNvPr id="6" name="Text Placeholder 5">
-            <a:extLst>
-              <a:ext uri="{FF2B5EF4-FFF2-40B4-BE49-F238E27FC236}">
-                <a16:creationId xmlns:a16="http://schemas.microsoft.com/office/drawing/2014/main" id="{A6861FF3-B902-4DEC-B46D-0F2E499C51CF}"/>
-              </a:ext>
-            </a:extLst>
-          </p:cNvPr>
-          <p:cNvSpPr>
-            <a:spLocks noGrp="1"/>
-          </p:cNvSpPr>
-          <p:nvPr>
-            <p:ph type="body" sz="quarter" idx="33"/>
-          </p:nvPr>
-        </p:nvSpPr>
-        <p:spPr>
-          <a:xfrm>
-            <a:off x="914399" y="3422952"/>
-            <a:ext cx="731520" cy="457200"/>
-          </a:xfrm>
-        </p:spPr>
-        <p:txBody>
-          <a:bodyPr>
-            <a:normAutofit/>
-          </a:bodyPr>
-          <a:lstStyle/>
-          <a:p>
-            <a:endParaRPr lang="en-US" dirty="0"/>
-          </a:p>
-        </p:txBody>
-      </p:sp>
-      <p:sp>
-        <p:nvSpPr>
-          <p:cNvPr id="7" name="Text Placeholder 6">
-            <a:extLst>
-              <a:ext uri="{FF2B5EF4-FFF2-40B4-BE49-F238E27FC236}">
-                <a16:creationId xmlns:a16="http://schemas.microsoft.com/office/drawing/2014/main" id="{05941AA2-C85B-41A7-9264-A0C66F32930C}"/>
-              </a:ext>
-            </a:extLst>
-          </p:cNvPr>
-          <p:cNvSpPr>
-            <a:spLocks noGrp="1"/>
-          </p:cNvSpPr>
-          <p:nvPr>
-            <p:ph type="body" sz="quarter" idx="34"/>
-          </p:nvPr>
-        </p:nvSpPr>
-        <p:spPr>
-          <a:xfrm>
-            <a:off x="1965960" y="3570392"/>
-            <a:ext cx="640080" cy="201776"/>
-          </a:xfrm>
-        </p:spPr>
-        <p:txBody>
-          <a:bodyPr>
-            <a:noAutofit/>
-          </a:bodyPr>
-          <a:lstStyle/>
-          <a:p/>
-        </p:txBody>
-      </p:sp>
-      <p:sp>
-        <p:nvSpPr>
-          <p:cNvPr id="8" name="Text Placeholder 7">
-            <a:extLst>
-              <a:ext uri="{FF2B5EF4-FFF2-40B4-BE49-F238E27FC236}">
-                <a16:creationId xmlns:a16="http://schemas.microsoft.com/office/drawing/2014/main" id="{2C4BD3D3-C7A9-46F1-8ED8-AB8D1BB89262}"/>
-              </a:ext>
-            </a:extLst>
-          </p:cNvPr>
-          <p:cNvSpPr>
-            <a:spLocks noGrp="1"/>
-          </p:cNvSpPr>
-          <p:nvPr>
-            <p:ph type="body" sz="quarter" idx="35"/>
-          </p:nvPr>
-        </p:nvSpPr>
-        <p:spPr>
-          <a:xfrm>
-            <a:off x="2753880" y="3570392"/>
-            <a:ext cx="640080" cy="201776"/>
-          </a:xfrm>
-        </p:spPr>
-        <p:txBody>
-          <a:bodyPr>
-            <a:noAutofit/>
-          </a:bodyPr>
-          <a:lstStyle/>
-          <a:p/>
-        </p:txBody>
-      </p:sp>
-      <p:sp>
-        <p:nvSpPr>
-          <p:cNvPr id="9" name="Text Placeholder 8">
-            <a:extLst>
-              <a:ext uri="{FF2B5EF4-FFF2-40B4-BE49-F238E27FC236}">
-                <a16:creationId xmlns:a16="http://schemas.microsoft.com/office/drawing/2014/main" id="{873EDDDB-6509-4407-BA35-232AAF9F198D}"/>
-              </a:ext>
-            </a:extLst>
-          </p:cNvPr>
-          <p:cNvSpPr>
-            <a:spLocks noGrp="1"/>
-          </p:cNvSpPr>
-          <p:nvPr>
-            <p:ph type="body" sz="quarter" idx="36"/>
-          </p:nvPr>
-        </p:nvSpPr>
-        <p:spPr>
-          <a:xfrm>
-            <a:off x="3541800" y="3570392"/>
-            <a:ext cx="640080" cy="201776"/>
-          </a:xfrm>
-        </p:spPr>
-        <p:txBody>
-          <a:bodyPr>
-            <a:noAutofit/>
-          </a:bodyPr>
-          <a:lstStyle/>
-          <a:p/>
-        </p:txBody>
-      </p:sp>
-      <p:sp>
-        <p:nvSpPr>
-          <p:cNvPr id="10" name="Text Placeholder 9">
-            <a:extLst>
-              <a:ext uri="{FF2B5EF4-FFF2-40B4-BE49-F238E27FC236}">
-                <a16:creationId xmlns:a16="http://schemas.microsoft.com/office/drawing/2014/main" id="{A33A061F-AC2A-4E3F-B448-DC6FEC307A53}"/>
-              </a:ext>
-            </a:extLst>
-          </p:cNvPr>
-          <p:cNvSpPr>
-            <a:spLocks noGrp="1"/>
-          </p:cNvSpPr>
-          <p:nvPr>
-            <p:ph type="body" sz="quarter" idx="37"/>
-          </p:nvPr>
-        </p:nvSpPr>
-        <p:spPr>
-          <a:xfrm>
-            <a:off x="4329720" y="3570392"/>
-            <a:ext cx="640080" cy="201776"/>
-          </a:xfrm>
-        </p:spPr>
-        <p:txBody>
-          <a:bodyPr>
-            <a:noAutofit/>
-          </a:bodyPr>
-          <a:lstStyle/>
-          <a:p/>
-        </p:txBody>
-      </p:sp>
-      <p:sp>
-        <p:nvSpPr>
-          <p:cNvPr id="12" name="Text Placeholder 11">
-            <a:extLst>
-              <a:ext uri="{FF2B5EF4-FFF2-40B4-BE49-F238E27FC236}">
-                <a16:creationId xmlns:a16="http://schemas.microsoft.com/office/drawing/2014/main" id="{FAC81818-8260-4E49-9FCC-569FDE30B0B1}"/>
-              </a:ext>
-            </a:extLst>
-          </p:cNvPr>
-          <p:cNvSpPr>
-            <a:spLocks noGrp="1"/>
-          </p:cNvSpPr>
-          <p:nvPr>
-            <p:ph type="body" sz="quarter" idx="39"/>
-          </p:nvPr>
-        </p:nvSpPr>
-        <p:spPr>
-          <a:xfrm>
-            <a:off x="5117640" y="3570392"/>
-            <a:ext cx="640080" cy="201776"/>
-          </a:xfrm>
-        </p:spPr>
-        <p:txBody>
-          <a:bodyPr>
-            <a:noAutofit/>
-          </a:bodyPr>
-          <a:lstStyle/>
-          <a:p/>
-        </p:txBody>
-      </p:sp>
-      <p:sp>
-        <p:nvSpPr>
-          <p:cNvPr id="13" name="Text Placeholder 12">
-            <a:extLst>
-              <a:ext uri="{FF2B5EF4-FFF2-40B4-BE49-F238E27FC236}">
-                <a16:creationId xmlns:a16="http://schemas.microsoft.com/office/drawing/2014/main" id="{D1FD068B-6917-4C40-B40D-5F7B670EA7BE}"/>
-              </a:ext>
-            </a:extLst>
-          </p:cNvPr>
-          <p:cNvSpPr>
-            <a:spLocks noGrp="1"/>
-          </p:cNvSpPr>
-          <p:nvPr>
-            <p:ph type="body" sz="quarter" idx="40"/>
-          </p:nvPr>
-        </p:nvSpPr>
-        <p:spPr>
-          <a:xfrm>
-            <a:off x="5905560" y="3570392"/>
-            <a:ext cx="640080" cy="201776"/>
-          </a:xfrm>
-        </p:spPr>
-        <p:txBody>
-          <a:bodyPr>
-            <a:noAutofit/>
-          </a:bodyPr>
-          <a:lstStyle/>
-          <a:p/>
-        </p:txBody>
-      </p:sp>
-      <p:sp>
-        <p:nvSpPr>
-          <p:cNvPr id="14" name="Text Placeholder 13">
-            <a:extLst>
-              <a:ext uri="{FF2B5EF4-FFF2-40B4-BE49-F238E27FC236}">
-                <a16:creationId xmlns:a16="http://schemas.microsoft.com/office/drawing/2014/main" id="{EEAE71AD-30AF-4021-B577-B686EC6DA329}"/>
-              </a:ext>
-            </a:extLst>
-          </p:cNvPr>
-          <p:cNvSpPr>
-            <a:spLocks noGrp="1"/>
-          </p:cNvSpPr>
-          <p:nvPr>
-            <p:ph type="body" sz="quarter" idx="41"/>
-          </p:nvPr>
-        </p:nvSpPr>
-        <p:spPr>
-          <a:xfrm>
-            <a:off x="6693480" y="3570392"/>
-            <a:ext cx="640080" cy="201776"/>
-          </a:xfrm>
-        </p:spPr>
-        <p:txBody>
-          <a:bodyPr>
-            <a:noAutofit/>
-          </a:bodyPr>
-          <a:lstStyle/>
-          <a:p/>
-        </p:txBody>
-      </p:sp>
-      <p:sp>
-        <p:nvSpPr>
-          <p:cNvPr id="16" name="Text Placeholder 15">
-            <a:extLst>
-              <a:ext uri="{FF2B5EF4-FFF2-40B4-BE49-F238E27FC236}">
-                <a16:creationId xmlns:a16="http://schemas.microsoft.com/office/drawing/2014/main" id="{D8E5FFBE-125E-43C8-A66E-DE8D2FE7AF38}"/>
-              </a:ext>
-            </a:extLst>
-          </p:cNvPr>
-          <p:cNvSpPr>
-            <a:spLocks noGrp="1"/>
-          </p:cNvSpPr>
-          <p:nvPr>
-            <p:ph type="body" sz="quarter" idx="43"/>
-          </p:nvPr>
-        </p:nvSpPr>
-        <p:spPr>
-          <a:xfrm>
-            <a:off x="7481400" y="3570392"/>
-            <a:ext cx="640080" cy="201776"/>
-          </a:xfrm>
-        </p:spPr>
-        <p:txBody>
-          <a:bodyPr>
-            <a:noAutofit/>
-          </a:bodyPr>
-          <a:lstStyle/>
-          <a:p/>
-        </p:txBody>
-      </p:sp>
-      <p:sp>
-        <p:nvSpPr>
-          <p:cNvPr id="17" name="Text Placeholder 16">
-            <a:extLst>
-              <a:ext uri="{FF2B5EF4-FFF2-40B4-BE49-F238E27FC236}">
-                <a16:creationId xmlns:a16="http://schemas.microsoft.com/office/drawing/2014/main" id="{7209F81D-5EC6-4D97-B0C2-AC00081AB1A7}"/>
-              </a:ext>
-            </a:extLst>
-          </p:cNvPr>
-          <p:cNvSpPr>
-            <a:spLocks noGrp="1"/>
-          </p:cNvSpPr>
-          <p:nvPr>
-            <p:ph type="body" sz="quarter" idx="44"/>
-          </p:nvPr>
-        </p:nvSpPr>
-        <p:spPr>
-          <a:xfrm>
-            <a:off x="8269320" y="3570392"/>
-            <a:ext cx="640080" cy="201776"/>
-          </a:xfrm>
-        </p:spPr>
-        <p:txBody>
-          <a:bodyPr>
-            <a:noAutofit/>
-          </a:bodyPr>
-          <a:lstStyle/>
-          <a:p/>
-        </p:txBody>
-      </p:sp>
-      <p:sp>
-        <p:nvSpPr>
-          <p:cNvPr id="15" name="Text Placeholder 14">
-            <a:extLst>
-              <a:ext uri="{FF2B5EF4-FFF2-40B4-BE49-F238E27FC236}">
-                <a16:creationId xmlns:a16="http://schemas.microsoft.com/office/drawing/2014/main" id="{4A477EE3-A17C-4158-91E8-03A401BE96CB}"/>
-              </a:ext>
-            </a:extLst>
-          </p:cNvPr>
-          <p:cNvSpPr>
-            <a:spLocks noGrp="1"/>
-          </p:cNvSpPr>
-          <p:nvPr>
-            <p:ph type="body" sz="quarter" idx="42"/>
-          </p:nvPr>
-        </p:nvSpPr>
-        <p:spPr>
-          <a:xfrm>
-            <a:off x="9057240" y="3570392"/>
-            <a:ext cx="640080" cy="201776"/>
-          </a:xfrm>
-        </p:spPr>
-        <p:txBody>
-          <a:bodyPr>
-            <a:noAutofit/>
-          </a:bodyPr>
-          <a:lstStyle/>
-          <a:p/>
-        </p:txBody>
-      </p:sp>
-      <p:sp>
-        <p:nvSpPr>
-          <p:cNvPr id="18" name="Text Placeholder 17">
-            <a:extLst>
-              <a:ext uri="{FF2B5EF4-FFF2-40B4-BE49-F238E27FC236}">
-                <a16:creationId xmlns:a16="http://schemas.microsoft.com/office/drawing/2014/main" id="{C477818B-3CAB-4A39-939D-99E98D2EE682}"/>
-              </a:ext>
-            </a:extLst>
-          </p:cNvPr>
-          <p:cNvSpPr>
-            <a:spLocks noGrp="1"/>
-          </p:cNvSpPr>
-          <p:nvPr>
-            <p:ph type="body" sz="quarter" idx="45"/>
-          </p:nvPr>
-        </p:nvSpPr>
-        <p:spPr>
-          <a:xfrm>
-            <a:off x="9845160" y="3570392"/>
-            <a:ext cx="640080" cy="201776"/>
-          </a:xfrm>
-        </p:spPr>
-        <p:txBody>
-          <a:bodyPr>
-            <a:noAutofit/>
-          </a:bodyPr>
-          <a:lstStyle/>
-          <a:p/>
-        </p:txBody>
-      </p:sp>
-      <p:sp>
-        <p:nvSpPr>
-          <p:cNvPr id="19" name="Text Placeholder 18">
-            <a:extLst>
-              <a:ext uri="{FF2B5EF4-FFF2-40B4-BE49-F238E27FC236}">
-                <a16:creationId xmlns:a16="http://schemas.microsoft.com/office/drawing/2014/main" id="{A7907FC8-DAAF-4896-A2B1-C173BF2FAE69}"/>
-              </a:ext>
-            </a:extLst>
-          </p:cNvPr>
-          <p:cNvSpPr>
-            <a:spLocks noGrp="1"/>
-          </p:cNvSpPr>
-          <p:nvPr>
-            <p:ph type="body" sz="quarter" idx="46"/>
-          </p:nvPr>
-        </p:nvSpPr>
-        <p:spPr>
-          <a:xfrm>
-            <a:off x="10633085" y="3570392"/>
-            <a:ext cx="640080" cy="201776"/>
-          </a:xfrm>
-        </p:spPr>
-        <p:txBody>
-          <a:bodyPr>
-            <a:noAutofit/>
-          </a:bodyPr>
-          <a:lstStyle/>
-          <a:p/>
-        </p:txBody>
-      </p:sp>
-      <p:sp>
-        <p:nvSpPr>
           <p:cNvPr id="114" name="Oval 113">
             <a:extLst>
               <a:ext uri="{FF2B5EF4-FFF2-40B4-BE49-F238E27FC236}">
@@ -25796,396 +24507,6 @@
             <a:pPr algn="ctr"/>
             <a:endParaRPr lang="en-US" dirty="0"/>
           </a:p>
-        </p:txBody>
-      </p:sp>
-      <p:sp>
-        <p:nvSpPr>
-          <p:cNvPr id="11" name="Year">
-            <a:extLst>
-              <a:ext uri="{FF2B5EF4-FFF2-40B4-BE49-F238E27FC236}">
-                <a16:creationId xmlns:a16="http://schemas.microsoft.com/office/drawing/2014/main" id="{44D29552-2F85-4F4F-9B7F-B79798681FB6}"/>
-              </a:ext>
-            </a:extLst>
-          </p:cNvPr>
-          <p:cNvSpPr>
-            <a:spLocks noGrp="1"/>
-          </p:cNvSpPr>
-          <p:nvPr>
-            <p:ph type="body" sz="quarter" idx="38"/>
-          </p:nvPr>
-        </p:nvSpPr>
-        <p:spPr>
-          <a:xfrm>
-            <a:off x="914400" y="4224228"/>
-            <a:ext cx="731520" cy="457200"/>
-          </a:xfrm>
-        </p:spPr>
-        <p:txBody>
-          <a:bodyPr>
-            <a:normAutofit/>
-          </a:bodyPr>
-          <a:lstStyle/>
-          <a:p/>
-        </p:txBody>
-      </p:sp>
-      <p:sp>
-        <p:nvSpPr>
-          <p:cNvPr id="20" name="Text Placeholder 19">
-            <a:extLst>
-              <a:ext uri="{FF2B5EF4-FFF2-40B4-BE49-F238E27FC236}">
-                <a16:creationId xmlns:a16="http://schemas.microsoft.com/office/drawing/2014/main" id="{FEC65619-A68A-4D21-9D17-40F8692EF196}"/>
-              </a:ext>
-            </a:extLst>
-          </p:cNvPr>
-          <p:cNvSpPr>
-            <a:spLocks noGrp="1"/>
-          </p:cNvSpPr>
-          <p:nvPr>
-            <p:ph type="body" sz="quarter" idx="47"/>
-          </p:nvPr>
-        </p:nvSpPr>
-        <p:spPr>
-          <a:xfrm>
-            <a:off x="1969915" y="4357456"/>
-            <a:ext cx="640080" cy="201776"/>
-          </a:xfrm>
-        </p:spPr>
-        <p:txBody>
-          <a:bodyPr>
-            <a:noAutofit/>
-          </a:bodyPr>
-          <a:lstStyle/>
-          <a:p/>
-        </p:txBody>
-      </p:sp>
-      <p:sp>
-        <p:nvSpPr>
-          <p:cNvPr id="21" name="Text Placeholder 20">
-            <a:extLst>
-              <a:ext uri="{FF2B5EF4-FFF2-40B4-BE49-F238E27FC236}">
-                <a16:creationId xmlns:a16="http://schemas.microsoft.com/office/drawing/2014/main" id="{D9C4CCA5-A2BE-4897-994D-9B1669D69FD3}"/>
-              </a:ext>
-            </a:extLst>
-          </p:cNvPr>
-          <p:cNvSpPr>
-            <a:spLocks noGrp="1"/>
-          </p:cNvSpPr>
-          <p:nvPr>
-            <p:ph type="body" sz="quarter" idx="48"/>
-          </p:nvPr>
-        </p:nvSpPr>
-        <p:spPr>
-          <a:xfrm>
-            <a:off x="2757602" y="4357456"/>
-            <a:ext cx="640080" cy="201776"/>
-          </a:xfrm>
-        </p:spPr>
-        <p:txBody>
-          <a:bodyPr>
-            <a:noAutofit/>
-          </a:bodyPr>
-          <a:lstStyle/>
-          <a:p/>
-        </p:txBody>
-      </p:sp>
-      <p:sp>
-        <p:nvSpPr>
-          <p:cNvPr id="22" name="Text Placeholder 21">
-            <a:extLst>
-              <a:ext uri="{FF2B5EF4-FFF2-40B4-BE49-F238E27FC236}">
-                <a16:creationId xmlns:a16="http://schemas.microsoft.com/office/drawing/2014/main" id="{0C5FD452-DC3E-4D62-B19B-0A79E604A8A8}"/>
-              </a:ext>
-            </a:extLst>
-          </p:cNvPr>
-          <p:cNvSpPr>
-            <a:spLocks noGrp="1"/>
-          </p:cNvSpPr>
-          <p:nvPr>
-            <p:ph type="body" sz="quarter" idx="49"/>
-          </p:nvPr>
-        </p:nvSpPr>
-        <p:spPr>
-          <a:xfrm>
-            <a:off x="3545289" y="4357456"/>
-            <a:ext cx="640080" cy="201776"/>
-          </a:xfrm>
-        </p:spPr>
-        <p:txBody>
-          <a:bodyPr>
-            <a:noAutofit/>
-          </a:bodyPr>
-          <a:lstStyle/>
-          <a:p/>
-        </p:txBody>
-      </p:sp>
-      <p:sp>
-        <p:nvSpPr>
-          <p:cNvPr id="23" name="Text Placeholder 22">
-            <a:extLst>
-              <a:ext uri="{FF2B5EF4-FFF2-40B4-BE49-F238E27FC236}">
-                <a16:creationId xmlns:a16="http://schemas.microsoft.com/office/drawing/2014/main" id="{96D290B2-F312-4D9A-96C7-D40523406AC5}"/>
-              </a:ext>
-            </a:extLst>
-          </p:cNvPr>
-          <p:cNvSpPr>
-            <a:spLocks noGrp="1"/>
-          </p:cNvSpPr>
-          <p:nvPr>
-            <p:ph type="body" sz="quarter" idx="50"/>
-          </p:nvPr>
-        </p:nvSpPr>
-        <p:spPr>
-          <a:xfrm>
-            <a:off x="4332976" y="4357456"/>
-            <a:ext cx="640080" cy="201776"/>
-          </a:xfrm>
-        </p:spPr>
-        <p:txBody>
-          <a:bodyPr>
-            <a:noAutofit/>
-          </a:bodyPr>
-          <a:lstStyle/>
-          <a:p/>
-        </p:txBody>
-      </p:sp>
-      <p:sp>
-        <p:nvSpPr>
-          <p:cNvPr id="24" name="Text Placeholder 23">
-            <a:extLst>
-              <a:ext uri="{FF2B5EF4-FFF2-40B4-BE49-F238E27FC236}">
-                <a16:creationId xmlns:a16="http://schemas.microsoft.com/office/drawing/2014/main" id="{80E52477-0BA9-471B-B2C2-F1A03FCF188F}"/>
-              </a:ext>
-            </a:extLst>
-          </p:cNvPr>
-          <p:cNvSpPr>
-            <a:spLocks noGrp="1"/>
-          </p:cNvSpPr>
-          <p:nvPr>
-            <p:ph type="body" sz="quarter" idx="51"/>
-          </p:nvPr>
-        </p:nvSpPr>
-        <p:spPr>
-          <a:xfrm>
-            <a:off x="5120663" y="4357456"/>
-            <a:ext cx="640080" cy="201776"/>
-          </a:xfrm>
-        </p:spPr>
-        <p:txBody>
-          <a:bodyPr>
-            <a:noAutofit/>
-          </a:bodyPr>
-          <a:lstStyle/>
-          <a:p/>
-        </p:txBody>
-      </p:sp>
-      <p:sp>
-        <p:nvSpPr>
-          <p:cNvPr id="25" name="Text Placeholder 24">
-            <a:extLst>
-              <a:ext uri="{FF2B5EF4-FFF2-40B4-BE49-F238E27FC236}">
-                <a16:creationId xmlns:a16="http://schemas.microsoft.com/office/drawing/2014/main" id="{70D1D022-03FA-47E6-8430-252C6D5B4C4E}"/>
-              </a:ext>
-            </a:extLst>
-          </p:cNvPr>
-          <p:cNvSpPr>
-            <a:spLocks noGrp="1"/>
-          </p:cNvSpPr>
-          <p:nvPr>
-            <p:ph type="body" sz="quarter" idx="52"/>
-          </p:nvPr>
-        </p:nvSpPr>
-        <p:spPr>
-          <a:xfrm>
-            <a:off x="5908350" y="4357456"/>
-            <a:ext cx="640080" cy="201776"/>
-          </a:xfrm>
-        </p:spPr>
-        <p:txBody>
-          <a:bodyPr>
-            <a:noAutofit/>
-          </a:bodyPr>
-          <a:lstStyle/>
-          <a:p/>
-        </p:txBody>
-      </p:sp>
-      <p:sp>
-        <p:nvSpPr>
-          <p:cNvPr id="26" name="Text Placeholder 25">
-            <a:extLst>
-              <a:ext uri="{FF2B5EF4-FFF2-40B4-BE49-F238E27FC236}">
-                <a16:creationId xmlns:a16="http://schemas.microsoft.com/office/drawing/2014/main" id="{FA7483FC-7290-41B1-B371-ECA1174519DE}"/>
-              </a:ext>
-            </a:extLst>
-          </p:cNvPr>
-          <p:cNvSpPr>
-            <a:spLocks noGrp="1"/>
-          </p:cNvSpPr>
-          <p:nvPr>
-            <p:ph type="body" sz="quarter" idx="53"/>
-          </p:nvPr>
-        </p:nvSpPr>
-        <p:spPr>
-          <a:xfrm>
-            <a:off x="6696037" y="4357456"/>
-            <a:ext cx="640080" cy="201776"/>
-          </a:xfrm>
-        </p:spPr>
-        <p:txBody>
-          <a:bodyPr>
-            <a:noAutofit/>
-          </a:bodyPr>
-          <a:lstStyle/>
-          <a:p/>
-        </p:txBody>
-      </p:sp>
-      <p:sp>
-        <p:nvSpPr>
-          <p:cNvPr id="28" name="Text Placeholder 27">
-            <a:extLst>
-              <a:ext uri="{FF2B5EF4-FFF2-40B4-BE49-F238E27FC236}">
-                <a16:creationId xmlns:a16="http://schemas.microsoft.com/office/drawing/2014/main" id="{D149E385-DCE9-4DC9-8F0A-F8BAF02D9797}"/>
-              </a:ext>
-            </a:extLst>
-          </p:cNvPr>
-          <p:cNvSpPr>
-            <a:spLocks noGrp="1"/>
-          </p:cNvSpPr>
-          <p:nvPr>
-            <p:ph type="body" sz="quarter" idx="55"/>
-          </p:nvPr>
-        </p:nvSpPr>
-        <p:spPr>
-          <a:xfrm>
-            <a:off x="7483724" y="4357456"/>
-            <a:ext cx="640080" cy="201776"/>
-          </a:xfrm>
-        </p:spPr>
-        <p:txBody>
-          <a:bodyPr>
-            <a:noAutofit/>
-          </a:bodyPr>
-          <a:lstStyle/>
-          <a:p/>
-        </p:txBody>
-      </p:sp>
-      <p:sp>
-        <p:nvSpPr>
-          <p:cNvPr id="29" name="Text Placeholder 28">
-            <a:extLst>
-              <a:ext uri="{FF2B5EF4-FFF2-40B4-BE49-F238E27FC236}">
-                <a16:creationId xmlns:a16="http://schemas.microsoft.com/office/drawing/2014/main" id="{B7A506EE-32D5-4685-97A6-8FDFEF238C43}"/>
-              </a:ext>
-            </a:extLst>
-          </p:cNvPr>
-          <p:cNvSpPr>
-            <a:spLocks noGrp="1"/>
-          </p:cNvSpPr>
-          <p:nvPr>
-            <p:ph type="body" sz="quarter" idx="56"/>
-          </p:nvPr>
-        </p:nvSpPr>
-        <p:spPr>
-          <a:xfrm>
-            <a:off x="8271411" y="4357456"/>
-            <a:ext cx="640080" cy="201776"/>
-          </a:xfrm>
-        </p:spPr>
-        <p:txBody>
-          <a:bodyPr>
-            <a:noAutofit/>
-          </a:bodyPr>
-          <a:lstStyle/>
-          <a:p/>
-        </p:txBody>
-      </p:sp>
-      <p:sp>
-        <p:nvSpPr>
-          <p:cNvPr id="27" name="Text Placeholder 26">
-            <a:extLst>
-              <a:ext uri="{FF2B5EF4-FFF2-40B4-BE49-F238E27FC236}">
-                <a16:creationId xmlns:a16="http://schemas.microsoft.com/office/drawing/2014/main" id="{1787EDAC-5EAB-4A0D-9BD2-D6E9FD0B26A1}"/>
-              </a:ext>
-            </a:extLst>
-          </p:cNvPr>
-          <p:cNvSpPr>
-            <a:spLocks noGrp="1"/>
-          </p:cNvSpPr>
-          <p:nvPr>
-            <p:ph type="body" sz="quarter" idx="54"/>
-          </p:nvPr>
-        </p:nvSpPr>
-        <p:spPr>
-          <a:xfrm>
-            <a:off x="9059098" y="4357456"/>
-            <a:ext cx="640080" cy="201776"/>
-          </a:xfrm>
-        </p:spPr>
-        <p:txBody>
-          <a:bodyPr>
-            <a:noAutofit/>
-          </a:bodyPr>
-          <a:lstStyle/>
-          <a:p/>
-        </p:txBody>
-      </p:sp>
-      <p:sp>
-        <p:nvSpPr>
-          <p:cNvPr id="30" name="Text Placeholder 29">
-            <a:extLst>
-              <a:ext uri="{FF2B5EF4-FFF2-40B4-BE49-F238E27FC236}">
-                <a16:creationId xmlns:a16="http://schemas.microsoft.com/office/drawing/2014/main" id="{E80CB353-63CA-4305-9748-807B6905DBFF}"/>
-              </a:ext>
-            </a:extLst>
-          </p:cNvPr>
-          <p:cNvSpPr>
-            <a:spLocks noGrp="1"/>
-          </p:cNvSpPr>
-          <p:nvPr>
-            <p:ph type="body" sz="quarter" idx="57"/>
-          </p:nvPr>
-        </p:nvSpPr>
-        <p:spPr>
-          <a:xfrm>
-            <a:off x="9846785" y="4357456"/>
-            <a:ext cx="640080" cy="201776"/>
-          </a:xfrm>
-        </p:spPr>
-        <p:txBody>
-          <a:bodyPr>
-            <a:noAutofit/>
-          </a:bodyPr>
-          <a:lstStyle/>
-          <a:p/>
-        </p:txBody>
-      </p:sp>
-      <p:sp>
-        <p:nvSpPr>
-          <p:cNvPr id="31" name="Text Placeholder 30">
-            <a:extLst>
-              <a:ext uri="{FF2B5EF4-FFF2-40B4-BE49-F238E27FC236}">
-                <a16:creationId xmlns:a16="http://schemas.microsoft.com/office/drawing/2014/main" id="{1B52C010-5159-4F61-821F-E73647E7C066}"/>
-              </a:ext>
-            </a:extLst>
-          </p:cNvPr>
-          <p:cNvSpPr>
-            <a:spLocks noGrp="1"/>
-          </p:cNvSpPr>
-          <p:nvPr>
-            <p:ph type="body" sz="quarter" idx="58"/>
-          </p:nvPr>
-        </p:nvSpPr>
-        <p:spPr>
-          <a:xfrm>
-            <a:off x="10634472" y="4357456"/>
-            <a:ext cx="640080" cy="201776"/>
-          </a:xfrm>
-        </p:spPr>
-        <p:txBody>
-          <a:bodyPr>
-            <a:noAutofit/>
-          </a:bodyPr>
-          <a:lstStyle/>
-          <a:p/>
         </p:txBody>
       </p:sp>
       <p:cxnSp>
@@ -27710,88 +26031,7 @@
       </p:sp>
       <p:sp>
         <p:nvSpPr>
-          <p:cNvPr id="145" name="Date Placeholder 144">
-            <a:extLst>
-              <a:ext uri="{FF2B5EF4-FFF2-40B4-BE49-F238E27FC236}">
-                <a16:creationId xmlns:a16="http://schemas.microsoft.com/office/drawing/2014/main" id="{EDFDF909-B06D-4D45-B05A-FB9B7D1C9B5B}"/>
-              </a:ext>
-            </a:extLst>
-          </p:cNvPr>
-          <p:cNvSpPr>
-            <a:spLocks noGrp="1"/>
-          </p:cNvSpPr>
-          <p:nvPr>
-            <p:ph type="dt" sz="half" idx="61"/>
-          </p:nvPr>
-        </p:nvSpPr>
-        <p:spPr/>
-        <p:txBody>
-          <a:bodyPr/>
-          <a:lstStyle/>
-          <a:p/>
-        </p:txBody>
-      </p:sp>
-      <p:sp>
-        <p:nvSpPr>
-          <p:cNvPr id="3" name="Footer Placeholder 2">
-            <a:extLst>
-              <a:ext uri="{FF2B5EF4-FFF2-40B4-BE49-F238E27FC236}">
-                <a16:creationId xmlns:a16="http://schemas.microsoft.com/office/drawing/2014/main" id="{BA35BD6B-402B-4987-9FCE-9A6924EE2F00}"/>
-              </a:ext>
-            </a:extLst>
-          </p:cNvPr>
-          <p:cNvSpPr>
-            <a:spLocks noGrp="1"/>
-          </p:cNvSpPr>
-          <p:nvPr>
-            <p:ph type="ftr" sz="quarter" idx="10"/>
-          </p:nvPr>
-        </p:nvSpPr>
-        <p:spPr>
-          <a:xfrm>
-            <a:off x="4038600" y="6356350"/>
-            <a:ext cx="4114800" cy="365125"/>
-          </a:xfrm>
-        </p:spPr>
-        <p:txBody>
-          <a:bodyPr/>
-          <a:lstStyle/>
-          <a:p/>
-        </p:txBody>
-      </p:sp>
-      <p:sp>
-        <p:nvSpPr>
-          <p:cNvPr id="4" name="Slide Number Placeholder 3">
-            <a:extLst>
-              <a:ext uri="{FF2B5EF4-FFF2-40B4-BE49-F238E27FC236}">
-                <a16:creationId xmlns:a16="http://schemas.microsoft.com/office/drawing/2014/main" id="{E259ECD5-0EAD-48D0-B30B-16305BC1062F}"/>
-              </a:ext>
-            </a:extLst>
-          </p:cNvPr>
-          <p:cNvSpPr>
-            <a:spLocks noGrp="1"/>
-          </p:cNvSpPr>
-          <p:nvPr>
-            <p:ph type="sldNum" sz="quarter" idx="11"/>
-          </p:nvPr>
-        </p:nvSpPr>
-        <p:spPr>
-          <a:xfrm>
-            <a:off x="8610600" y="6356350"/>
-            <a:ext cx="2743200" cy="365125"/>
-          </a:xfrm>
-        </p:spPr>
-        <p:txBody>
-          <a:bodyPr/>
-          <a:lstStyle/>
-          <a:p>
-            <a:endParaRPr lang="en-ZA" dirty="0"/>
-          </a:p>
-        </p:txBody>
-      </p:sp>
-      <p:sp>
-        <p:nvSpPr>
-          <p:cNvPr id="146" name="Rectangle 145"/>
+          <p:cNvPr id="145" name="Rectangle 144"/>
           <p:cNvSpPr/>
           <p:nvPr/>
         </p:nvSpPr>
@@ -27836,7 +26076,7 @@
       </p:sp>
       <p:sp>
         <p:nvSpPr>
-          <p:cNvPr id="147" name="TextBox 146"/>
+          <p:cNvPr id="146" name="TextBox 145"/>
           <p:cNvSpPr txBox="1"/>
           <p:nvPr/>
         </p:nvSpPr>
@@ -27871,7 +26111,7 @@
       </p:sp>
       <p:sp>
         <p:nvSpPr>
-          <p:cNvPr id="148" name="TextBox 147"/>
+          <p:cNvPr id="147" name="TextBox 146"/>
           <p:cNvSpPr txBox="1"/>
           <p:nvPr/>
         </p:nvSpPr>
@@ -27906,7 +26146,7 @@
       </p:sp>
       <p:cxnSp>
         <p:nvCxnSpPr>
-          <p:cNvPr id="149" name="Connector 148"/>
+          <p:cNvPr id="148" name="Connector 147"/>
           <p:cNvCxnSpPr/>
           <p:nvPr/>
         </p:nvCxnSpPr>
@@ -27941,7 +26181,7 @@
       </p:cxnSp>
       <p:sp>
         <p:nvSpPr>
-          <p:cNvPr id="150" name="Oval 149"/>
+          <p:cNvPr id="149" name="Oval 148"/>
           <p:cNvSpPr/>
           <p:nvPr/>
         </p:nvSpPr>
@@ -27995,7 +26235,7 @@
       </p:sp>
       <p:sp>
         <p:nvSpPr>
-          <p:cNvPr id="151" name="TextBox 150"/>
+          <p:cNvPr id="150" name="TextBox 149"/>
           <p:cNvSpPr txBox="1"/>
           <p:nvPr/>
         </p:nvSpPr>
@@ -28030,7 +26270,7 @@
       </p:sp>
       <p:sp>
         <p:nvSpPr>
-          <p:cNvPr id="152" name="TextBox 151"/>
+          <p:cNvPr id="151" name="TextBox 150"/>
           <p:cNvSpPr txBox="1"/>
           <p:nvPr/>
         </p:nvSpPr>
@@ -28065,7 +26305,7 @@
       </p:sp>
       <p:sp>
         <p:nvSpPr>
-          <p:cNvPr id="153" name="Oval 152"/>
+          <p:cNvPr id="152" name="Oval 151"/>
           <p:cNvSpPr/>
           <p:nvPr/>
         </p:nvSpPr>
@@ -28119,7 +26359,7 @@
       </p:sp>
       <p:sp>
         <p:nvSpPr>
-          <p:cNvPr id="154" name="TextBox 153"/>
+          <p:cNvPr id="153" name="TextBox 152"/>
           <p:cNvSpPr txBox="1"/>
           <p:nvPr/>
         </p:nvSpPr>
@@ -28154,7 +26394,7 @@
       </p:sp>
       <p:sp>
         <p:nvSpPr>
-          <p:cNvPr id="155" name="TextBox 154"/>
+          <p:cNvPr id="154" name="TextBox 153"/>
           <p:cNvSpPr txBox="1"/>
           <p:nvPr/>
         </p:nvSpPr>
@@ -28189,7 +26429,7 @@
       </p:sp>
       <p:sp>
         <p:nvSpPr>
-          <p:cNvPr id="156" name="Oval 155"/>
+          <p:cNvPr id="155" name="Oval 154"/>
           <p:cNvSpPr/>
           <p:nvPr/>
         </p:nvSpPr>
@@ -28243,7 +26483,7 @@
       </p:sp>
       <p:sp>
         <p:nvSpPr>
-          <p:cNvPr id="157" name="TextBox 156"/>
+          <p:cNvPr id="156" name="TextBox 155"/>
           <p:cNvSpPr txBox="1"/>
           <p:nvPr/>
         </p:nvSpPr>
@@ -28278,7 +26518,7 @@
       </p:sp>
       <p:sp>
         <p:nvSpPr>
-          <p:cNvPr id="158" name="TextBox 157"/>
+          <p:cNvPr id="157" name="TextBox 156"/>
           <p:cNvSpPr txBox="1"/>
           <p:nvPr/>
         </p:nvSpPr>
@@ -28313,7 +26553,7 @@
       </p:sp>
       <p:sp>
         <p:nvSpPr>
-          <p:cNvPr id="159" name="Oval 158"/>
+          <p:cNvPr id="158" name="Oval 157"/>
           <p:cNvSpPr/>
           <p:nvPr/>
         </p:nvSpPr>
@@ -28367,7 +26607,7 @@
       </p:sp>
       <p:sp>
         <p:nvSpPr>
-          <p:cNvPr id="160" name="TextBox 159"/>
+          <p:cNvPr id="159" name="TextBox 158"/>
           <p:cNvSpPr txBox="1"/>
           <p:nvPr/>
         </p:nvSpPr>
@@ -28402,7 +26642,7 @@
       </p:sp>
       <p:sp>
         <p:nvSpPr>
-          <p:cNvPr id="161" name="TextBox 160"/>
+          <p:cNvPr id="160" name="TextBox 159"/>
           <p:cNvSpPr txBox="1"/>
           <p:nvPr/>
         </p:nvSpPr>
@@ -28437,7 +26677,7 @@
       </p:sp>
       <p:sp>
         <p:nvSpPr>
-          <p:cNvPr id="162" name="Oval 161"/>
+          <p:cNvPr id="161" name="Oval 160"/>
           <p:cNvSpPr/>
           <p:nvPr/>
         </p:nvSpPr>
@@ -28491,7 +26731,7 @@
       </p:sp>
       <p:sp>
         <p:nvSpPr>
-          <p:cNvPr id="163" name="TextBox 162"/>
+          <p:cNvPr id="162" name="TextBox 161"/>
           <p:cNvSpPr txBox="1"/>
           <p:nvPr/>
         </p:nvSpPr>
@@ -28526,7 +26766,7 @@
       </p:sp>
       <p:sp>
         <p:nvSpPr>
-          <p:cNvPr id="164" name="TextBox 163"/>
+          <p:cNvPr id="163" name="TextBox 162"/>
           <p:cNvSpPr txBox="1"/>
           <p:nvPr/>
         </p:nvSpPr>
@@ -28561,7 +26801,7 @@
       </p:sp>
       <p:sp>
         <p:nvSpPr>
-          <p:cNvPr id="165" name="Oval 164"/>
+          <p:cNvPr id="164" name="Oval 163"/>
           <p:cNvSpPr/>
           <p:nvPr/>
         </p:nvSpPr>
@@ -28615,7 +26855,7 @@
       </p:sp>
       <p:sp>
         <p:nvSpPr>
-          <p:cNvPr id="166" name="TextBox 165"/>
+          <p:cNvPr id="165" name="TextBox 164"/>
           <p:cNvSpPr txBox="1"/>
           <p:nvPr/>
         </p:nvSpPr>
@@ -28650,7 +26890,7 @@
       </p:sp>
       <p:sp>
         <p:nvSpPr>
-          <p:cNvPr id="167" name="TextBox 166"/>
+          <p:cNvPr id="166" name="TextBox 165"/>
           <p:cNvSpPr txBox="1"/>
           <p:nvPr/>
         </p:nvSpPr>
@@ -28685,7 +26925,7 @@
       </p:sp>
       <p:sp>
         <p:nvSpPr>
-          <p:cNvPr id="168" name="Rounded Rectangle 167"/>
+          <p:cNvPr id="167" name="Rounded Rectangle 166"/>
           <p:cNvSpPr/>
           <p:nvPr/>
         </p:nvSpPr>
@@ -28730,7 +26970,7 @@
       </p:sp>
       <p:sp>
         <p:nvSpPr>
-          <p:cNvPr id="169" name="TextBox 168"/>
+          <p:cNvPr id="168" name="TextBox 167"/>
           <p:cNvSpPr txBox="1"/>
           <p:nvPr/>
         </p:nvSpPr>
@@ -28765,7 +27005,7 @@
       </p:sp>
       <p:sp>
         <p:nvSpPr>
-          <p:cNvPr id="170" name="TextBox 169"/>
+          <p:cNvPr id="169" name="TextBox 168"/>
           <p:cNvSpPr txBox="1"/>
           <p:nvPr/>
         </p:nvSpPr>
@@ -28800,7 +27040,7 @@
       </p:sp>
       <p:sp>
         <p:nvSpPr>
-          <p:cNvPr id="171" name="TextBox 170"/>
+          <p:cNvPr id="170" name="TextBox 169"/>
           <p:cNvSpPr txBox="1"/>
           <p:nvPr/>
         </p:nvSpPr>
@@ -28835,7 +27075,7 @@
       </p:sp>
       <p:sp>
         <p:nvSpPr>
-          <p:cNvPr id="172" name="TextBox 171"/>
+          <p:cNvPr id="171" name="TextBox 170"/>
           <p:cNvSpPr txBox="1"/>
           <p:nvPr/>
         </p:nvSpPr>
@@ -28934,148 +27174,7 @@
       </p:pic>
       <p:sp>
         <p:nvSpPr>
-          <p:cNvPr id="28" name="Title 27">
-            <a:extLst>
-              <a:ext uri="{FF2B5EF4-FFF2-40B4-BE49-F238E27FC236}">
-                <a16:creationId xmlns:a16="http://schemas.microsoft.com/office/drawing/2014/main" id="{0648DE95-334E-46CE-B3A6-AEEB61BA16E7}"/>
-              </a:ext>
-            </a:extLst>
-          </p:cNvPr>
-          <p:cNvSpPr>
-            <a:spLocks noGrp="1"/>
-          </p:cNvSpPr>
-          <p:nvPr>
-            <p:ph type="title"/>
-          </p:nvPr>
-        </p:nvSpPr>
-        <p:spPr/>
-        <p:txBody>
-          <a:bodyPr>
-            <a:normAutofit fontScale="90000"/>
-          </a:bodyPr>
-          <a:lstStyle/>
-          <a:p/>
-        </p:txBody>
-      </p:sp>
-      <p:sp>
-        <p:nvSpPr>
-          <p:cNvPr id="23" name="Content Placeholder 22">
-            <a:extLst>
-              <a:ext uri="{FF2B5EF4-FFF2-40B4-BE49-F238E27FC236}">
-                <a16:creationId xmlns:a16="http://schemas.microsoft.com/office/drawing/2014/main" id="{80E486CF-8877-4DB4-98D3-2CD9F1CB339E}"/>
-              </a:ext>
-            </a:extLst>
-          </p:cNvPr>
-          <p:cNvSpPr>
-            <a:spLocks noGrp="1"/>
-          </p:cNvSpPr>
-          <p:nvPr>
-            <p:ph idx="14"/>
-          </p:nvPr>
-        </p:nvSpPr>
-        <p:spPr>
-          <a:xfrm>
-            <a:off x="7467603" y="4681728"/>
-            <a:ext cx="3838731" cy="1645920"/>
-          </a:xfrm>
-        </p:spPr>
-        <p:txBody>
-          <a:bodyPr>
-            <a:normAutofit/>
-          </a:bodyPr>
-          <a:lstStyle/>
-          <a:p/>
-        </p:txBody>
-      </p:sp>
-      <p:sp>
-        <p:nvSpPr>
-          <p:cNvPr id="50" name="Date Placeholder 49">
-            <a:extLst>
-              <a:ext uri="{FF2B5EF4-FFF2-40B4-BE49-F238E27FC236}">
-                <a16:creationId xmlns:a16="http://schemas.microsoft.com/office/drawing/2014/main" id="{108C1532-C197-478C-AFA8-3EACE6CE5EC3}"/>
-              </a:ext>
-            </a:extLst>
-          </p:cNvPr>
-          <p:cNvSpPr>
-            <a:spLocks noGrp="1"/>
-          </p:cNvSpPr>
-          <p:nvPr>
-            <p:ph type="dt" sz="half" idx="10"/>
-          </p:nvPr>
-        </p:nvSpPr>
-        <p:spPr>
-          <a:xfrm>
-            <a:off x="838200" y="6356350"/>
-            <a:ext cx="2743200" cy="365125"/>
-          </a:xfrm>
-        </p:spPr>
-        <p:txBody>
-          <a:bodyPr/>
-          <a:lstStyle/>
-          <a:p/>
-        </p:txBody>
-      </p:sp>
-      <p:sp>
-        <p:nvSpPr>
-          <p:cNvPr id="51" name="Footer Placeholder 50">
-            <a:extLst>
-              <a:ext uri="{FF2B5EF4-FFF2-40B4-BE49-F238E27FC236}">
-                <a16:creationId xmlns:a16="http://schemas.microsoft.com/office/drawing/2014/main" id="{07E67588-DFE4-40B6-B7B2-7329C1D7CC38}"/>
-              </a:ext>
-            </a:extLst>
-          </p:cNvPr>
-          <p:cNvSpPr>
-            <a:spLocks noGrp="1"/>
-          </p:cNvSpPr>
-          <p:nvPr>
-            <p:ph type="ftr" sz="quarter" idx="11"/>
-          </p:nvPr>
-        </p:nvSpPr>
-        <p:spPr>
-          <a:xfrm>
-            <a:off x="4038600" y="6356350"/>
-            <a:ext cx="4114800" cy="365125"/>
-          </a:xfrm>
-        </p:spPr>
-        <p:txBody>
-          <a:bodyPr/>
-          <a:lstStyle/>
-          <a:p/>
-        </p:txBody>
-      </p:sp>
-      <p:sp>
-        <p:nvSpPr>
-          <p:cNvPr id="52" name="Slide Number Placeholder 51">
-            <a:extLst>
-              <a:ext uri="{FF2B5EF4-FFF2-40B4-BE49-F238E27FC236}">
-                <a16:creationId xmlns:a16="http://schemas.microsoft.com/office/drawing/2014/main" id="{FFBA0FCD-5060-4B39-B311-BE2FE37C81E1}"/>
-              </a:ext>
-            </a:extLst>
-          </p:cNvPr>
-          <p:cNvSpPr>
-            <a:spLocks noGrp="1"/>
-          </p:cNvSpPr>
-          <p:nvPr>
-            <p:ph type="sldNum" sz="quarter" idx="12"/>
-          </p:nvPr>
-        </p:nvSpPr>
-        <p:spPr>
-          <a:xfrm>
-            <a:off x="8610600" y="6356350"/>
-            <a:ext cx="2743200" cy="365125"/>
-          </a:xfrm>
-        </p:spPr>
-        <p:txBody>
-          <a:bodyPr/>
-          <a:lstStyle/>
-          <a:p>
-            <a:endParaRPr lang="en-US" dirty="0"/>
-          </a:p>
-        </p:txBody>
-      </p:sp>
-      <p:sp>
-        <p:nvSpPr>
-          <p:cNvPr id="53" name="TextBox 52"/>
+          <p:cNvPr id="8" name="TextBox 7"/>
           <p:cNvSpPr txBox="1"/>
           <p:nvPr/>
         </p:nvSpPr>
@@ -29110,7 +27209,7 @@
       </p:sp>
       <p:sp>
         <p:nvSpPr>
-          <p:cNvPr id="54" name="TextBox 53"/>
+          <p:cNvPr id="9" name="TextBox 8"/>
           <p:cNvSpPr txBox="1"/>
           <p:nvPr/>
         </p:nvSpPr>
@@ -29147,7 +27246,7 @@
       </p:sp>
       <p:sp>
         <p:nvSpPr>
-          <p:cNvPr id="55" name="TextBox 54"/>
+          <p:cNvPr id="10" name="TextBox 9"/>
           <p:cNvSpPr txBox="1"/>
           <p:nvPr/>
         </p:nvSpPr>
@@ -29182,7 +27281,7 @@
       </p:sp>
       <p:sp>
         <p:nvSpPr>
-          <p:cNvPr id="56" name="TextBox 55"/>
+          <p:cNvPr id="11" name="TextBox 10"/>
           <p:cNvSpPr txBox="1"/>
           <p:nvPr/>
         </p:nvSpPr>
@@ -29281,407 +27380,7 @@
       </p:pic>
       <p:sp>
         <p:nvSpPr>
-          <p:cNvPr id="2" name="Title 1">
-            <a:extLst>
-              <a:ext uri="{FF2B5EF4-FFF2-40B4-BE49-F238E27FC236}">
-                <a16:creationId xmlns:a16="http://schemas.microsoft.com/office/drawing/2014/main" id="{67708C79-A4AC-4B5D-92DF-600737E4D11A}"/>
-              </a:ext>
-            </a:extLst>
-          </p:cNvPr>
-          <p:cNvSpPr>
-            <a:spLocks noGrp="1"/>
-          </p:cNvSpPr>
-          <p:nvPr>
-            <p:ph type="title"/>
-          </p:nvPr>
-        </p:nvSpPr>
-        <p:spPr>
-          <a:xfrm>
-            <a:off x="914400" y="365125"/>
-            <a:ext cx="8562475" cy="1325563"/>
-          </a:xfrm>
-        </p:spPr>
-        <p:txBody>
-          <a:bodyPr/>
-          <a:lstStyle/>
-          <a:p/>
-        </p:txBody>
-      </p:sp>
-      <p:sp>
-        <p:nvSpPr>
-          <p:cNvPr id="41" name="Text Placeholder 40">
-            <a:extLst>
-              <a:ext uri="{FF2B5EF4-FFF2-40B4-BE49-F238E27FC236}">
-                <a16:creationId xmlns:a16="http://schemas.microsoft.com/office/drawing/2014/main" id="{96363A03-E425-4DF0-A245-F0EEE2D0431D}"/>
-              </a:ext>
-            </a:extLst>
-          </p:cNvPr>
-          <p:cNvSpPr>
-            <a:spLocks noGrp="1"/>
-          </p:cNvSpPr>
-          <p:nvPr>
-            <p:ph type="body" sz="quarter" idx="25"/>
-          </p:nvPr>
-        </p:nvSpPr>
-        <p:spPr>
-          <a:xfrm>
-            <a:off x="0" y="1465263"/>
-            <a:ext cx="10026650" cy="4754562"/>
-          </a:xfrm>
-        </p:spPr>
-        <p:txBody>
-          <a:bodyPr/>
-          <a:lstStyle/>
-          <a:p/>
-        </p:txBody>
-      </p:sp>
-      <p:sp>
-        <p:nvSpPr>
-          <p:cNvPr id="44" name="Text Placeholder 43">
-            <a:extLst>
-              <a:ext uri="{FF2B5EF4-FFF2-40B4-BE49-F238E27FC236}">
-                <a16:creationId xmlns:a16="http://schemas.microsoft.com/office/drawing/2014/main" id="{980B2038-1B53-491E-BC2F-148E99EFDBB8}"/>
-              </a:ext>
-            </a:extLst>
-          </p:cNvPr>
-          <p:cNvSpPr>
-            <a:spLocks noGrp="1"/>
-          </p:cNvSpPr>
-          <p:nvPr>
-            <p:ph type="body" sz="quarter" idx="15"/>
-          </p:nvPr>
-        </p:nvSpPr>
-        <p:spPr>
-          <a:xfrm>
-            <a:off x="914274" y="2242336"/>
-            <a:ext cx="3886200" cy="914400"/>
-          </a:xfrm>
-        </p:spPr>
-        <p:txBody>
-          <a:bodyPr/>
-          <a:lstStyle/>
-          <a:p/>
-        </p:txBody>
-      </p:sp>
-      <p:sp>
-        <p:nvSpPr>
-          <p:cNvPr id="45" name="Text Placeholder 44">
-            <a:extLst>
-              <a:ext uri="{FF2B5EF4-FFF2-40B4-BE49-F238E27FC236}">
-                <a16:creationId xmlns:a16="http://schemas.microsoft.com/office/drawing/2014/main" id="{F970A788-9414-4536-9C00-F0C8714580AB}"/>
-              </a:ext>
-            </a:extLst>
-          </p:cNvPr>
-          <p:cNvSpPr>
-            <a:spLocks noGrp="1"/>
-          </p:cNvSpPr>
-          <p:nvPr>
-            <p:ph type="body" sz="quarter" idx="16"/>
-          </p:nvPr>
-        </p:nvSpPr>
-        <p:spPr>
-          <a:xfrm>
-            <a:off x="914525" y="3218688"/>
-            <a:ext cx="3886200" cy="320040"/>
-          </a:xfrm>
-        </p:spPr>
-        <p:txBody>
-          <a:bodyPr/>
-          <a:lstStyle/>
-          <a:p/>
-        </p:txBody>
-      </p:sp>
-      <p:sp>
-        <p:nvSpPr>
-          <p:cNvPr id="46" name="Text Placeholder 45">
-            <a:extLst>
-              <a:ext uri="{FF2B5EF4-FFF2-40B4-BE49-F238E27FC236}">
-                <a16:creationId xmlns:a16="http://schemas.microsoft.com/office/drawing/2014/main" id="{F845A907-CC82-47DD-86EC-58C44C2EA61D}"/>
-              </a:ext>
-            </a:extLst>
-          </p:cNvPr>
-          <p:cNvSpPr>
-            <a:spLocks noGrp="1"/>
-          </p:cNvSpPr>
-          <p:nvPr>
-            <p:ph type="body" sz="quarter" idx="17"/>
-          </p:nvPr>
-        </p:nvSpPr>
-        <p:spPr>
-          <a:xfrm>
-            <a:off x="914399" y="3545967"/>
-            <a:ext cx="3886200" cy="914400"/>
-          </a:xfrm>
-        </p:spPr>
-        <p:txBody>
-          <a:bodyPr>
-            <a:noAutofit/>
-          </a:bodyPr>
-          <a:lstStyle/>
-          <a:p/>
-        </p:txBody>
-      </p:sp>
-      <p:sp>
-        <p:nvSpPr>
-          <p:cNvPr id="16" name="Text Placeholder 15">
-            <a:extLst>
-              <a:ext uri="{FF2B5EF4-FFF2-40B4-BE49-F238E27FC236}">
-                <a16:creationId xmlns:a16="http://schemas.microsoft.com/office/drawing/2014/main" id="{DEF3428C-82C8-426A-8AA5-06D41239356C}"/>
-              </a:ext>
-            </a:extLst>
-          </p:cNvPr>
-          <p:cNvSpPr>
-            <a:spLocks noGrp="1"/>
-          </p:cNvSpPr>
-          <p:nvPr>
-            <p:ph type="body" sz="quarter" idx="22"/>
-          </p:nvPr>
-        </p:nvSpPr>
-        <p:spPr>
-          <a:xfrm>
-            <a:off x="914525" y="4709160"/>
-            <a:ext cx="3886200" cy="320040"/>
-          </a:xfrm>
-        </p:spPr>
-        <p:txBody>
-          <a:bodyPr/>
-          <a:lstStyle/>
-          <a:p/>
-        </p:txBody>
-      </p:sp>
-      <p:sp>
-        <p:nvSpPr>
-          <p:cNvPr id="17" name="Text Placeholder 16">
-            <a:extLst>
-              <a:ext uri="{FF2B5EF4-FFF2-40B4-BE49-F238E27FC236}">
-                <a16:creationId xmlns:a16="http://schemas.microsoft.com/office/drawing/2014/main" id="{8B178A14-FF95-463C-89E7-D71BB431EA6A}"/>
-              </a:ext>
-            </a:extLst>
-          </p:cNvPr>
-          <p:cNvSpPr>
-            <a:spLocks noGrp="1"/>
-          </p:cNvSpPr>
-          <p:nvPr>
-            <p:ph type="body" sz="quarter" idx="23"/>
-          </p:nvPr>
-        </p:nvSpPr>
-        <p:spPr>
-          <a:xfrm>
-            <a:off x="914399" y="5036439"/>
-            <a:ext cx="3886200" cy="737604"/>
-          </a:xfrm>
-        </p:spPr>
-        <p:txBody>
-          <a:bodyPr>
-            <a:normAutofit/>
-          </a:bodyPr>
-          <a:lstStyle/>
-          <a:p/>
-        </p:txBody>
-      </p:sp>
-      <p:sp>
-        <p:nvSpPr>
-          <p:cNvPr id="149" name="Date Placeholder 148">
-            <a:extLst>
-              <a:ext uri="{FF2B5EF4-FFF2-40B4-BE49-F238E27FC236}">
-                <a16:creationId xmlns:a16="http://schemas.microsoft.com/office/drawing/2014/main" id="{9598B89F-8751-4A36-9936-166C165858EF}"/>
-              </a:ext>
-            </a:extLst>
-          </p:cNvPr>
-          <p:cNvSpPr>
-            <a:spLocks noGrp="1"/>
-          </p:cNvSpPr>
-          <p:nvPr>
-            <p:ph type="dt" sz="half" idx="10"/>
-          </p:nvPr>
-        </p:nvSpPr>
-        <p:spPr>
-          <a:xfrm>
-            <a:off x="838200" y="6356350"/>
-            <a:ext cx="2743200" cy="365125"/>
-          </a:xfrm>
-        </p:spPr>
-        <p:txBody>
-          <a:bodyPr/>
-          <a:lstStyle/>
-          <a:p/>
-        </p:txBody>
-      </p:sp>
-      <p:sp>
-        <p:nvSpPr>
-          <p:cNvPr id="47" name="Text Placeholder 46">
-            <a:extLst>
-              <a:ext uri="{FF2B5EF4-FFF2-40B4-BE49-F238E27FC236}">
-                <a16:creationId xmlns:a16="http://schemas.microsoft.com/office/drawing/2014/main" id="{5B76A604-CBAD-4494-A846-E4C833A6092C}"/>
-              </a:ext>
-            </a:extLst>
-          </p:cNvPr>
-          <p:cNvSpPr>
-            <a:spLocks noGrp="1"/>
-          </p:cNvSpPr>
-          <p:nvPr>
-            <p:ph type="body" sz="quarter" idx="18"/>
-          </p:nvPr>
-        </p:nvSpPr>
-        <p:spPr>
-          <a:xfrm>
-            <a:off x="5590801" y="1916113"/>
-            <a:ext cx="3886200" cy="320040"/>
-          </a:xfrm>
-        </p:spPr>
-        <p:txBody>
-          <a:bodyPr/>
-          <a:lstStyle/>
-          <a:p/>
-        </p:txBody>
-      </p:sp>
-      <p:sp>
-        <p:nvSpPr>
-          <p:cNvPr id="48" name="Text Placeholder 47">
-            <a:extLst>
-              <a:ext uri="{FF2B5EF4-FFF2-40B4-BE49-F238E27FC236}">
-                <a16:creationId xmlns:a16="http://schemas.microsoft.com/office/drawing/2014/main" id="{BF07FAC4-029F-4076-B784-683A1CCA6865}"/>
-              </a:ext>
-            </a:extLst>
-          </p:cNvPr>
-          <p:cNvSpPr>
-            <a:spLocks noGrp="1"/>
-          </p:cNvSpPr>
-          <p:nvPr>
-            <p:ph type="body" sz="quarter" idx="19"/>
-          </p:nvPr>
-        </p:nvSpPr>
-        <p:spPr>
-          <a:xfrm>
-            <a:off x="5590675" y="2242336"/>
-            <a:ext cx="3886200" cy="914400"/>
-          </a:xfrm>
-        </p:spPr>
-        <p:txBody>
-          <a:bodyPr>
-            <a:normAutofit/>
-          </a:bodyPr>
-          <a:lstStyle/>
-          <a:p/>
-        </p:txBody>
-      </p:sp>
-      <p:sp>
-        <p:nvSpPr>
-          <p:cNvPr id="49" name="Text Placeholder 48">
-            <a:extLst>
-              <a:ext uri="{FF2B5EF4-FFF2-40B4-BE49-F238E27FC236}">
-                <a16:creationId xmlns:a16="http://schemas.microsoft.com/office/drawing/2014/main" id="{BEEA5224-6F24-4134-84A4-4BB922BE15DE}"/>
-              </a:ext>
-            </a:extLst>
-          </p:cNvPr>
-          <p:cNvSpPr>
-            <a:spLocks noGrp="1"/>
-          </p:cNvSpPr>
-          <p:nvPr>
-            <p:ph type="body" sz="quarter" idx="20"/>
-          </p:nvPr>
-        </p:nvSpPr>
-        <p:spPr>
-          <a:xfrm>
-            <a:off x="5590801" y="3218688"/>
-            <a:ext cx="3886200" cy="320040"/>
-          </a:xfrm>
-        </p:spPr>
-        <p:txBody>
-          <a:bodyPr/>
-          <a:lstStyle/>
-          <a:p/>
-        </p:txBody>
-      </p:sp>
-      <p:sp>
-        <p:nvSpPr>
-          <p:cNvPr id="50" name="Text Placeholder 49">
-            <a:extLst>
-              <a:ext uri="{FF2B5EF4-FFF2-40B4-BE49-F238E27FC236}">
-                <a16:creationId xmlns:a16="http://schemas.microsoft.com/office/drawing/2014/main" id="{6DC9F3A7-D8E7-4ABC-8153-8AFB777CAC78}"/>
-              </a:ext>
-            </a:extLst>
-          </p:cNvPr>
-          <p:cNvSpPr>
-            <a:spLocks noGrp="1"/>
-          </p:cNvSpPr>
-          <p:nvPr>
-            <p:ph type="body" sz="quarter" idx="21"/>
-          </p:nvPr>
-        </p:nvSpPr>
-        <p:spPr>
-          <a:xfrm>
-            <a:off x="5590675" y="3545967"/>
-            <a:ext cx="3886200" cy="914400"/>
-          </a:xfrm>
-        </p:spPr>
-        <p:txBody>
-          <a:bodyPr>
-            <a:normAutofit/>
-          </a:bodyPr>
-          <a:lstStyle/>
-          <a:p/>
-        </p:txBody>
-      </p:sp>
-      <p:sp>
-        <p:nvSpPr>
-          <p:cNvPr id="150" name="Footer Placeholder 149">
-            <a:extLst>
-              <a:ext uri="{FF2B5EF4-FFF2-40B4-BE49-F238E27FC236}">
-                <a16:creationId xmlns:a16="http://schemas.microsoft.com/office/drawing/2014/main" id="{BF3830E9-8071-46F4-9061-47A9D52729BA}"/>
-              </a:ext>
-            </a:extLst>
-          </p:cNvPr>
-          <p:cNvSpPr>
-            <a:spLocks noGrp="1"/>
-          </p:cNvSpPr>
-          <p:nvPr>
-            <p:ph type="ftr" sz="quarter" idx="11"/>
-          </p:nvPr>
-        </p:nvSpPr>
-        <p:spPr>
-          <a:xfrm>
-            <a:off x="4038600" y="6356350"/>
-            <a:ext cx="4114800" cy="365125"/>
-          </a:xfrm>
-        </p:spPr>
-        <p:txBody>
-          <a:bodyPr/>
-          <a:lstStyle/>
-          <a:p/>
-        </p:txBody>
-      </p:sp>
-      <p:sp>
-        <p:nvSpPr>
-          <p:cNvPr id="152" name="Text Placeholder 151">
-            <a:extLst>
-              <a:ext uri="{FF2B5EF4-FFF2-40B4-BE49-F238E27FC236}">
-                <a16:creationId xmlns:a16="http://schemas.microsoft.com/office/drawing/2014/main" id="{3C4F874E-995C-4034-ACF3-1F09DDFD1EF2}"/>
-              </a:ext>
-            </a:extLst>
-          </p:cNvPr>
-          <p:cNvSpPr>
-            <a:spLocks noGrp="1"/>
-          </p:cNvSpPr>
-          <p:nvPr>
-            <p:ph type="body" sz="quarter" idx="24"/>
-          </p:nvPr>
-        </p:nvSpPr>
-        <p:spPr>
-          <a:xfrm>
-            <a:off x="10734040" y="-68580"/>
-            <a:ext cx="1737360" cy="6858000"/>
-          </a:xfrm>
-        </p:spPr>
-        <p:txBody>
-          <a:bodyPr/>
-          <a:lstStyle/>
-          <a:p/>
-        </p:txBody>
-      </p:sp>
-      <p:sp>
-        <p:nvSpPr>
-          <p:cNvPr id="153" name="TextBox 152"/>
+          <p:cNvPr id="11" name="TextBox 10"/>
           <p:cNvSpPr txBox="1"/>
           <p:nvPr/>
         </p:nvSpPr>
@@ -29716,7 +27415,7 @@
       </p:sp>
       <p:sp>
         <p:nvSpPr>
-          <p:cNvPr id="154" name="TextBox 153"/>
+          <p:cNvPr id="12" name="TextBox 11"/>
           <p:cNvSpPr txBox="1"/>
           <p:nvPr/>
         </p:nvSpPr>
@@ -29751,7 +27450,7 @@
       </p:sp>
       <p:sp>
         <p:nvSpPr>
-          <p:cNvPr id="155" name="TextBox 154"/>
+          <p:cNvPr id="13" name="TextBox 12"/>
           <p:cNvSpPr txBox="1"/>
           <p:nvPr/>
         </p:nvSpPr>
@@ -29838,7 +27537,7 @@
       </p:sp>
       <p:sp>
         <p:nvSpPr>
-          <p:cNvPr id="156" name="TextBox 155"/>
+          <p:cNvPr id="14" name="TextBox 13"/>
           <p:cNvSpPr txBox="1"/>
           <p:nvPr/>
         </p:nvSpPr>
@@ -29925,7 +27624,7 @@
       </p:sp>
       <p:sp>
         <p:nvSpPr>
-          <p:cNvPr id="157" name="Rectangle 156"/>
+          <p:cNvPr id="15" name="Rectangle 14"/>
           <p:cNvSpPr/>
           <p:nvPr/>
         </p:nvSpPr>
@@ -29970,7 +27669,7 @@
       </p:sp>
       <p:sp>
         <p:nvSpPr>
-          <p:cNvPr id="158" name="TextBox 157"/>
+          <p:cNvPr id="16" name="TextBox 15"/>
           <p:cNvSpPr txBox="1"/>
           <p:nvPr/>
         </p:nvSpPr>
@@ -30005,7 +27704,7 @@
       </p:sp>
       <p:sp>
         <p:nvSpPr>
-          <p:cNvPr id="159" name="TextBox 158"/>
+          <p:cNvPr id="17" name="TextBox 16"/>
           <p:cNvSpPr txBox="1"/>
           <p:nvPr/>
         </p:nvSpPr>
@@ -30040,7 +27739,7 @@
       </p:sp>
       <p:sp>
         <p:nvSpPr>
-          <p:cNvPr id="160" name="TextBox 159"/>
+          <p:cNvPr id="18" name="TextBox 17"/>
           <p:cNvSpPr txBox="1"/>
           <p:nvPr/>
         </p:nvSpPr>
@@ -30075,7 +27774,7 @@
       </p:sp>
       <p:sp>
         <p:nvSpPr>
-          <p:cNvPr id="161" name="TextBox 160"/>
+          <p:cNvPr id="19" name="TextBox 18"/>
           <p:cNvSpPr txBox="1"/>
           <p:nvPr/>
         </p:nvSpPr>
@@ -30138,34 +27837,6 @@
           <a:chExt cx="0" cy="0"/>
         </a:xfrm>
       </p:grpSpPr>
-      <p:sp>
-        <p:nvSpPr>
-          <p:cNvPr id="2" name="Title 1">
-            <a:extLst>
-              <a:ext uri="{FF2B5EF4-FFF2-40B4-BE49-F238E27FC236}">
-                <a16:creationId xmlns:a16="http://schemas.microsoft.com/office/drawing/2014/main" id="{75031FE9-9059-4FE8-B4AC-9771F23A1B89}"/>
-              </a:ext>
-            </a:extLst>
-          </p:cNvPr>
-          <p:cNvSpPr>
-            <a:spLocks noGrp="1"/>
-          </p:cNvSpPr>
-          <p:nvPr>
-            <p:ph type="title"/>
-          </p:nvPr>
-        </p:nvSpPr>
-        <p:spPr>
-          <a:xfrm>
-            <a:off x="6155363" y="365125"/>
-            <a:ext cx="5103007" cy="1325563"/>
-          </a:xfrm>
-        </p:spPr>
-        <p:txBody>
-          <a:bodyPr/>
-          <a:lstStyle/>
-          <a:p/>
-        </p:txBody>
-      </p:sp>
       <p:pic>
         <p:nvPicPr>
           <p:cNvPr id="7" name="Picture Placeholder 6" descr="Man working on laptop sitting by the window">
@@ -30202,325 +27873,7 @@
       </p:pic>
       <p:sp>
         <p:nvSpPr>
-          <p:cNvPr id="3" name="Content Placeholder 2">
-            <a:extLst>
-              <a:ext uri="{FF2B5EF4-FFF2-40B4-BE49-F238E27FC236}">
-                <a16:creationId xmlns:a16="http://schemas.microsoft.com/office/drawing/2014/main" id="{D4A2EB3F-4D60-451F-8F45-7D6654D2FCD9}"/>
-              </a:ext>
-            </a:extLst>
-          </p:cNvPr>
-          <p:cNvSpPr>
-            <a:spLocks noGrp="1"/>
-          </p:cNvSpPr>
-          <p:nvPr>
-            <p:ph type="body" sz="quarter" idx="14"/>
-          </p:nvPr>
-        </p:nvSpPr>
-        <p:spPr>
-          <a:xfrm>
-            <a:off x="6153182" y="2093976"/>
-            <a:ext cx="5120640" cy="320040"/>
-          </a:xfrm>
-        </p:spPr>
-        <p:txBody>
-          <a:bodyPr vert="horz" lIns="91440" tIns="45720" rIns="91440" bIns="45720" rtlCol="0" anchor="t">
-            <a:normAutofit lnSpcReduction="10000"/>
-          </a:bodyPr>
-          <a:lstStyle/>
-          <a:p/>
-        </p:txBody>
-      </p:sp>
-      <p:sp>
-        <p:nvSpPr>
-          <p:cNvPr id="21" name="Text Placeholder 20">
-            <a:extLst>
-              <a:ext uri="{FF2B5EF4-FFF2-40B4-BE49-F238E27FC236}">
-                <a16:creationId xmlns:a16="http://schemas.microsoft.com/office/drawing/2014/main" id="{43DDEB93-8628-4CD2-969D-1108E86844B5}"/>
-              </a:ext>
-            </a:extLst>
-          </p:cNvPr>
-          <p:cNvSpPr>
-            <a:spLocks noGrp="1"/>
-          </p:cNvSpPr>
-          <p:nvPr>
-            <p:ph type="body" sz="quarter" idx="15"/>
-          </p:nvPr>
-        </p:nvSpPr>
-        <p:spPr>
-          <a:xfrm>
-            <a:off x="6153056" y="2422684"/>
-            <a:ext cx="5120640" cy="640080"/>
-          </a:xfrm>
-        </p:spPr>
-        <p:txBody>
-          <a:bodyPr>
-            <a:normAutofit/>
-          </a:bodyPr>
-          <a:lstStyle/>
-          <a:p/>
-        </p:txBody>
-      </p:sp>
-      <p:sp>
-        <p:nvSpPr>
-          <p:cNvPr id="22" name="Text Placeholder 21">
-            <a:extLst>
-              <a:ext uri="{FF2B5EF4-FFF2-40B4-BE49-F238E27FC236}">
-                <a16:creationId xmlns:a16="http://schemas.microsoft.com/office/drawing/2014/main" id="{1148019F-B471-48D3-A6AA-3F0B467240B5}"/>
-              </a:ext>
-            </a:extLst>
-          </p:cNvPr>
-          <p:cNvSpPr>
-            <a:spLocks noGrp="1"/>
-          </p:cNvSpPr>
-          <p:nvPr>
-            <p:ph type="body" sz="quarter" idx="16"/>
-          </p:nvPr>
-        </p:nvSpPr>
-        <p:spPr>
-          <a:xfrm>
-            <a:off x="6153307" y="3227832"/>
-            <a:ext cx="5120640" cy="320040"/>
-          </a:xfrm>
-        </p:spPr>
-        <p:txBody>
-          <a:bodyPr/>
-          <a:lstStyle/>
-          <a:p/>
-        </p:txBody>
-      </p:sp>
-      <p:sp>
-        <p:nvSpPr>
-          <p:cNvPr id="23" name="Text Placeholder 22">
-            <a:extLst>
-              <a:ext uri="{FF2B5EF4-FFF2-40B4-BE49-F238E27FC236}">
-                <a16:creationId xmlns:a16="http://schemas.microsoft.com/office/drawing/2014/main" id="{1B300A6A-6AD6-4D6C-85C5-FDF36EF1D3CF}"/>
-              </a:ext>
-            </a:extLst>
-          </p:cNvPr>
-          <p:cNvSpPr>
-            <a:spLocks noGrp="1"/>
-          </p:cNvSpPr>
-          <p:nvPr>
-            <p:ph type="body" sz="quarter" idx="17"/>
-          </p:nvPr>
-        </p:nvSpPr>
-        <p:spPr>
-          <a:xfrm>
-            <a:off x="6153181" y="3559290"/>
-            <a:ext cx="5120640" cy="457200"/>
-          </a:xfrm>
-        </p:spPr>
-        <p:txBody>
-          <a:bodyPr>
-            <a:normAutofit/>
-          </a:bodyPr>
-          <a:lstStyle/>
-          <a:p/>
-        </p:txBody>
-      </p:sp>
-      <p:sp>
-        <p:nvSpPr>
-          <p:cNvPr id="24" name="Text Placeholder 23">
-            <a:extLst>
-              <a:ext uri="{FF2B5EF4-FFF2-40B4-BE49-F238E27FC236}">
-                <a16:creationId xmlns:a16="http://schemas.microsoft.com/office/drawing/2014/main" id="{C03AC016-5A46-4B6E-943F-B9F46486290F}"/>
-              </a:ext>
-            </a:extLst>
-          </p:cNvPr>
-          <p:cNvSpPr>
-            <a:spLocks noGrp="1"/>
-          </p:cNvSpPr>
-          <p:nvPr>
-            <p:ph type="body" sz="quarter" idx="18"/>
-          </p:nvPr>
-        </p:nvSpPr>
-        <p:spPr>
-          <a:xfrm>
-            <a:off x="6149167" y="4059936"/>
-            <a:ext cx="5120640" cy="320040"/>
-          </a:xfrm>
-        </p:spPr>
-        <p:txBody>
-          <a:bodyPr/>
-          <a:lstStyle/>
-          <a:p/>
-        </p:txBody>
-      </p:sp>
-      <p:sp>
-        <p:nvSpPr>
-          <p:cNvPr id="25" name="Text Placeholder 24">
-            <a:extLst>
-              <a:ext uri="{FF2B5EF4-FFF2-40B4-BE49-F238E27FC236}">
-                <a16:creationId xmlns:a16="http://schemas.microsoft.com/office/drawing/2014/main" id="{10A43BEE-B04F-469B-9957-9AF5947E5A19}"/>
-              </a:ext>
-            </a:extLst>
-          </p:cNvPr>
-          <p:cNvSpPr>
-            <a:spLocks noGrp="1"/>
-          </p:cNvSpPr>
-          <p:nvPr>
-            <p:ph type="body" sz="quarter" idx="19"/>
-          </p:nvPr>
-        </p:nvSpPr>
-        <p:spPr>
-          <a:xfrm>
-            <a:off x="6149041" y="4388168"/>
-            <a:ext cx="5120640" cy="640080"/>
-          </a:xfrm>
-        </p:spPr>
-        <p:txBody>
-          <a:bodyPr>
-            <a:normAutofit/>
-          </a:bodyPr>
-          <a:lstStyle/>
-          <a:p/>
-        </p:txBody>
-      </p:sp>
-      <p:sp>
-        <p:nvSpPr>
-          <p:cNvPr id="26" name="Text Placeholder 25">
-            <a:extLst>
-              <a:ext uri="{FF2B5EF4-FFF2-40B4-BE49-F238E27FC236}">
-                <a16:creationId xmlns:a16="http://schemas.microsoft.com/office/drawing/2014/main" id="{2631719C-FC8F-4C94-8D70-74C636AC876C}"/>
-              </a:ext>
-            </a:extLst>
-          </p:cNvPr>
-          <p:cNvSpPr>
-            <a:spLocks noGrp="1"/>
-          </p:cNvSpPr>
-          <p:nvPr>
-            <p:ph type="body" sz="quarter" idx="20"/>
-          </p:nvPr>
-        </p:nvSpPr>
-        <p:spPr>
-          <a:xfrm>
-            <a:off x="6149292" y="5202936"/>
-            <a:ext cx="5120640" cy="320040"/>
-          </a:xfrm>
-        </p:spPr>
-        <p:txBody>
-          <a:bodyPr/>
-          <a:lstStyle/>
-          <a:p/>
-        </p:txBody>
-      </p:sp>
-      <p:sp>
-        <p:nvSpPr>
-          <p:cNvPr id="27" name="Text Placeholder 26">
-            <a:extLst>
-              <a:ext uri="{FF2B5EF4-FFF2-40B4-BE49-F238E27FC236}">
-                <a16:creationId xmlns:a16="http://schemas.microsoft.com/office/drawing/2014/main" id="{58552BB2-2387-4A2C-8668-B6633FE46EE4}"/>
-              </a:ext>
-            </a:extLst>
-          </p:cNvPr>
-          <p:cNvSpPr>
-            <a:spLocks noGrp="1"/>
-          </p:cNvSpPr>
-          <p:nvPr>
-            <p:ph type="body" sz="quarter" idx="21"/>
-          </p:nvPr>
-        </p:nvSpPr>
-        <p:spPr>
-          <a:xfrm>
-            <a:off x="6149166" y="5535502"/>
-            <a:ext cx="5120640" cy="640080"/>
-          </a:xfrm>
-        </p:spPr>
-        <p:txBody>
-          <a:bodyPr/>
-          <a:lstStyle/>
-          <a:p/>
-        </p:txBody>
-      </p:sp>
-      <p:sp>
-        <p:nvSpPr>
-          <p:cNvPr id="50" name="Date Placeholder 49">
-            <a:extLst>
-              <a:ext uri="{FF2B5EF4-FFF2-40B4-BE49-F238E27FC236}">
-                <a16:creationId xmlns:a16="http://schemas.microsoft.com/office/drawing/2014/main" id="{9726F8A6-61E7-497C-B12F-6E9E2C0564C8}"/>
-              </a:ext>
-            </a:extLst>
-          </p:cNvPr>
-          <p:cNvSpPr>
-            <a:spLocks noGrp="1"/>
-          </p:cNvSpPr>
-          <p:nvPr>
-            <p:ph type="dt" sz="half" idx="10"/>
-          </p:nvPr>
-        </p:nvSpPr>
-        <p:spPr>
-          <a:xfrm>
-            <a:off x="838200" y="6356350"/>
-            <a:ext cx="2743200" cy="365125"/>
-          </a:xfrm>
-        </p:spPr>
-        <p:txBody>
-          <a:bodyPr/>
-          <a:lstStyle/>
-          <a:p/>
-        </p:txBody>
-      </p:sp>
-      <p:sp>
-        <p:nvSpPr>
-          <p:cNvPr id="51" name="Footer Placeholder 50">
-            <a:extLst>
-              <a:ext uri="{FF2B5EF4-FFF2-40B4-BE49-F238E27FC236}">
-                <a16:creationId xmlns:a16="http://schemas.microsoft.com/office/drawing/2014/main" id="{9EF76BD2-EB69-4D45-9701-8A82B812A6E0}"/>
-              </a:ext>
-            </a:extLst>
-          </p:cNvPr>
-          <p:cNvSpPr>
-            <a:spLocks noGrp="1"/>
-          </p:cNvSpPr>
-          <p:nvPr>
-            <p:ph type="ftr" sz="quarter" idx="11"/>
-          </p:nvPr>
-        </p:nvSpPr>
-        <p:spPr>
-          <a:xfrm>
-            <a:off x="4038600" y="6356350"/>
-            <a:ext cx="4114800" cy="365125"/>
-          </a:xfrm>
-        </p:spPr>
-        <p:txBody>
-          <a:bodyPr/>
-          <a:lstStyle/>
-          <a:p/>
-        </p:txBody>
-      </p:sp>
-      <p:sp>
-        <p:nvSpPr>
-          <p:cNvPr id="52" name="Slide Number Placeholder 51">
-            <a:extLst>
-              <a:ext uri="{FF2B5EF4-FFF2-40B4-BE49-F238E27FC236}">
-                <a16:creationId xmlns:a16="http://schemas.microsoft.com/office/drawing/2014/main" id="{BD1651FB-5427-4C2E-968C-077A5FCB9D89}"/>
-              </a:ext>
-            </a:extLst>
-          </p:cNvPr>
-          <p:cNvSpPr>
-            <a:spLocks noGrp="1"/>
-          </p:cNvSpPr>
-          <p:nvPr>
-            <p:ph type="sldNum" sz="quarter" idx="12"/>
-          </p:nvPr>
-        </p:nvSpPr>
-        <p:spPr>
-          <a:xfrm>
-            <a:off x="8610600" y="6356350"/>
-            <a:ext cx="2743200" cy="365125"/>
-          </a:xfrm>
-        </p:spPr>
-        <p:txBody>
-          <a:bodyPr/>
-          <a:lstStyle/>
-          <a:p>
-            <a:endParaRPr lang="en-US" dirty="0"/>
-          </a:p>
-        </p:txBody>
-      </p:sp>
-      <p:sp>
-        <p:nvSpPr>
-          <p:cNvPr id="53" name="TextBox 52"/>
+          <p:cNvPr id="8" name="TextBox 7"/>
           <p:cNvSpPr txBox="1"/>
           <p:nvPr/>
         </p:nvSpPr>
@@ -30555,7 +27908,7 @@
       </p:sp>
       <p:sp>
         <p:nvSpPr>
-          <p:cNvPr id="54" name="TextBox 53"/>
+          <p:cNvPr id="9" name="TextBox 8"/>
           <p:cNvSpPr txBox="1"/>
           <p:nvPr/>
         </p:nvSpPr>
@@ -30590,7 +27943,7 @@
       </p:sp>
       <p:sp>
         <p:nvSpPr>
-          <p:cNvPr id="55" name="Oval 54"/>
+          <p:cNvPr id="10" name="Oval 9"/>
           <p:cNvSpPr/>
           <p:nvPr/>
         </p:nvSpPr>
@@ -30644,7 +27997,7 @@
       </p:sp>
       <p:sp>
         <p:nvSpPr>
-          <p:cNvPr id="56" name="TextBox 55"/>
+          <p:cNvPr id="11" name="TextBox 10"/>
           <p:cNvSpPr txBox="1"/>
           <p:nvPr/>
         </p:nvSpPr>
@@ -30699,7 +28052,7 @@
       </p:sp>
       <p:sp>
         <p:nvSpPr>
-          <p:cNvPr id="57" name="Oval 56"/>
+          <p:cNvPr id="12" name="Oval 11"/>
           <p:cNvSpPr/>
           <p:nvPr/>
         </p:nvSpPr>
@@ -30753,7 +28106,7 @@
       </p:sp>
       <p:sp>
         <p:nvSpPr>
-          <p:cNvPr id="58" name="TextBox 57"/>
+          <p:cNvPr id="13" name="TextBox 12"/>
           <p:cNvSpPr txBox="1"/>
           <p:nvPr/>
         </p:nvSpPr>
@@ -30808,7 +28161,7 @@
       </p:sp>
       <p:sp>
         <p:nvSpPr>
-          <p:cNvPr id="59" name="Oval 58"/>
+          <p:cNvPr id="14" name="Oval 13"/>
           <p:cNvSpPr/>
           <p:nvPr/>
         </p:nvSpPr>
@@ -30862,7 +28215,7 @@
       </p:sp>
       <p:sp>
         <p:nvSpPr>
-          <p:cNvPr id="60" name="TextBox 59"/>
+          <p:cNvPr id="15" name="TextBox 14"/>
           <p:cNvSpPr txBox="1"/>
           <p:nvPr/>
         </p:nvSpPr>
@@ -30917,7 +28270,7 @@
       </p:sp>
       <p:sp>
         <p:nvSpPr>
-          <p:cNvPr id="61" name="Oval 60"/>
+          <p:cNvPr id="16" name="Oval 15"/>
           <p:cNvSpPr/>
           <p:nvPr/>
         </p:nvSpPr>
@@ -30971,7 +28324,7 @@
       </p:sp>
       <p:sp>
         <p:nvSpPr>
-          <p:cNvPr id="62" name="TextBox 61"/>
+          <p:cNvPr id="17" name="TextBox 16"/>
           <p:cNvSpPr txBox="1"/>
           <p:nvPr/>
         </p:nvSpPr>
@@ -31026,7 +28379,7 @@
       </p:sp>
       <p:sp>
         <p:nvSpPr>
-          <p:cNvPr id="63" name="TextBox 62"/>
+          <p:cNvPr id="18" name="TextBox 17"/>
           <p:cNvSpPr txBox="1"/>
           <p:nvPr/>
         </p:nvSpPr>
@@ -31061,7 +28414,7 @@
       </p:sp>
       <p:sp>
         <p:nvSpPr>
-          <p:cNvPr id="64" name="TextBox 63"/>
+          <p:cNvPr id="19" name="TextBox 18"/>
           <p:cNvSpPr txBox="1"/>
           <p:nvPr/>
         </p:nvSpPr>
@@ -31096,7 +28449,7 @@
       </p:sp>
       <p:sp>
         <p:nvSpPr>
-          <p:cNvPr id="65" name="TextBox 64"/>
+          <p:cNvPr id="20" name="TextBox 19"/>
           <p:cNvSpPr txBox="1"/>
           <p:nvPr/>
         </p:nvSpPr>
@@ -31131,7 +28484,7 @@
       </p:sp>
       <p:sp>
         <p:nvSpPr>
-          <p:cNvPr id="66" name="TextBox 65"/>
+          <p:cNvPr id="21" name="TextBox 20"/>
           <p:cNvSpPr txBox="1"/>
           <p:nvPr/>
         </p:nvSpPr>
@@ -31230,298 +28583,6 @@
       </p:pic>
       <p:sp>
         <p:nvSpPr>
-          <p:cNvPr id="2" name="Title 1">
-            <a:extLst>
-              <a:ext uri="{FF2B5EF4-FFF2-40B4-BE49-F238E27FC236}">
-                <a16:creationId xmlns:a16="http://schemas.microsoft.com/office/drawing/2014/main" id="{8A4E0A63-A388-49B1-A04E-27CE9BD622EF}"/>
-              </a:ext>
-            </a:extLst>
-          </p:cNvPr>
-          <p:cNvSpPr>
-            <a:spLocks noGrp="1"/>
-          </p:cNvSpPr>
-          <p:nvPr>
-            <p:ph type="title"/>
-          </p:nvPr>
-        </p:nvSpPr>
-        <p:spPr>
-          <a:xfrm>
-            <a:off x="838200" y="365125"/>
-            <a:ext cx="10515600" cy="1325563"/>
-          </a:xfrm>
-        </p:spPr>
-        <p:txBody>
-          <a:bodyPr/>
-          <a:lstStyle/>
-          <a:p/>
-        </p:txBody>
-      </p:sp>
-      <p:sp>
-        <p:nvSpPr>
-          <p:cNvPr id="5" name="Text Placeholder 4">
-            <a:extLst>
-              <a:ext uri="{FF2B5EF4-FFF2-40B4-BE49-F238E27FC236}">
-                <a16:creationId xmlns:a16="http://schemas.microsoft.com/office/drawing/2014/main" id="{06E82690-B145-4D4F-B2D1-0B2A8C50FD71}"/>
-              </a:ext>
-            </a:extLst>
-          </p:cNvPr>
-          <p:cNvSpPr>
-            <a:spLocks noGrp="1"/>
-          </p:cNvSpPr>
-          <p:nvPr>
-            <p:ph type="body" sz="quarter" idx="33"/>
-          </p:nvPr>
-        </p:nvSpPr>
-        <p:spPr>
-          <a:xfrm>
-            <a:off x="1444752" y="2487165"/>
-            <a:ext cx="2926080" cy="2714379"/>
-          </a:xfrm>
-        </p:spPr>
-        <p:txBody>
-          <a:bodyPr/>
-          <a:lstStyle/>
-          <a:p/>
-        </p:txBody>
-      </p:sp>
-      <p:sp>
-        <p:nvSpPr>
-          <p:cNvPr id="6" name="Text Placeholder 5">
-            <a:extLst>
-              <a:ext uri="{FF2B5EF4-FFF2-40B4-BE49-F238E27FC236}">
-                <a16:creationId xmlns:a16="http://schemas.microsoft.com/office/drawing/2014/main" id="{7640DF9D-0C9E-4C5D-9635-6B4DE10CCEE5}"/>
-              </a:ext>
-            </a:extLst>
-          </p:cNvPr>
-          <p:cNvSpPr>
-            <a:spLocks noGrp="1"/>
-          </p:cNvSpPr>
-          <p:nvPr>
-            <p:ph type="body" sz="quarter" idx="34"/>
-          </p:nvPr>
-        </p:nvSpPr>
-        <p:spPr>
-          <a:xfrm>
-            <a:off x="1673352" y="3374136"/>
-            <a:ext cx="2468880" cy="1371600"/>
-          </a:xfrm>
-        </p:spPr>
-        <p:txBody>
-          <a:bodyPr vert="horz" lIns="91440" tIns="45720" rIns="91440" bIns="45720" rtlCol="0" anchor="t">
-            <a:noAutofit/>
-          </a:bodyPr>
-          <a:lstStyle/>
-          <a:p/>
-        </p:txBody>
-      </p:sp>
-      <p:sp>
-        <p:nvSpPr>
-          <p:cNvPr id="7" name="Text Placeholder 6">
-            <a:extLst>
-              <a:ext uri="{FF2B5EF4-FFF2-40B4-BE49-F238E27FC236}">
-                <a16:creationId xmlns:a16="http://schemas.microsoft.com/office/drawing/2014/main" id="{40297407-CE4E-4284-879D-AEC395713625}"/>
-              </a:ext>
-            </a:extLst>
-          </p:cNvPr>
-          <p:cNvSpPr>
-            <a:spLocks noGrp="1"/>
-          </p:cNvSpPr>
-          <p:nvPr>
-            <p:ph type="body" sz="quarter" idx="35"/>
-          </p:nvPr>
-        </p:nvSpPr>
-        <p:spPr>
-          <a:xfrm>
-            <a:off x="4636008" y="2487165"/>
-            <a:ext cx="2926080" cy="2715768"/>
-          </a:xfrm>
-        </p:spPr>
-        <p:txBody>
-          <a:bodyPr>
-            <a:normAutofit/>
-          </a:bodyPr>
-          <a:lstStyle/>
-          <a:p/>
-        </p:txBody>
-      </p:sp>
-      <p:sp>
-        <p:nvSpPr>
-          <p:cNvPr id="8" name="Text Placeholder 7">
-            <a:extLst>
-              <a:ext uri="{FF2B5EF4-FFF2-40B4-BE49-F238E27FC236}">
-                <a16:creationId xmlns:a16="http://schemas.microsoft.com/office/drawing/2014/main" id="{F5C3A7BE-F7FC-4942-A31A-491A8A806103}"/>
-              </a:ext>
-            </a:extLst>
-          </p:cNvPr>
-          <p:cNvSpPr>
-            <a:spLocks noGrp="1"/>
-          </p:cNvSpPr>
-          <p:nvPr>
-            <p:ph type="body" sz="quarter" idx="36"/>
-          </p:nvPr>
-        </p:nvSpPr>
-        <p:spPr>
-          <a:xfrm>
-            <a:off x="4873775" y="3374136"/>
-            <a:ext cx="2468880" cy="1371600"/>
-          </a:xfrm>
-        </p:spPr>
-        <p:txBody>
-          <a:bodyPr vert="horz" lIns="91440" tIns="45720" rIns="91440" bIns="45720" rtlCol="0" anchor="t">
-            <a:noAutofit/>
-          </a:bodyPr>
-          <a:lstStyle/>
-          <a:p/>
-        </p:txBody>
-      </p:sp>
-      <p:sp>
-        <p:nvSpPr>
-          <p:cNvPr id="9" name="Text Placeholder 8">
-            <a:extLst>
-              <a:ext uri="{FF2B5EF4-FFF2-40B4-BE49-F238E27FC236}">
-                <a16:creationId xmlns:a16="http://schemas.microsoft.com/office/drawing/2014/main" id="{95CCE699-03D1-4642-B46A-B14EF17DA183}"/>
-              </a:ext>
-            </a:extLst>
-          </p:cNvPr>
-          <p:cNvSpPr>
-            <a:spLocks noGrp="1"/>
-          </p:cNvSpPr>
-          <p:nvPr>
-            <p:ph type="body" sz="quarter" idx="37"/>
-          </p:nvPr>
-        </p:nvSpPr>
-        <p:spPr>
-          <a:xfrm>
-            <a:off x="7790688" y="2487165"/>
-            <a:ext cx="2926080" cy="2715768"/>
-          </a:xfrm>
-        </p:spPr>
-        <p:txBody>
-          <a:bodyPr>
-            <a:normAutofit/>
-          </a:bodyPr>
-          <a:lstStyle/>
-          <a:p/>
-        </p:txBody>
-      </p:sp>
-      <p:sp>
-        <p:nvSpPr>
-          <p:cNvPr id="10" name="Text Placeholder 9">
-            <a:extLst>
-              <a:ext uri="{FF2B5EF4-FFF2-40B4-BE49-F238E27FC236}">
-                <a16:creationId xmlns:a16="http://schemas.microsoft.com/office/drawing/2014/main" id="{BC1DF189-6F2F-4C21-88CC-C82D3D0D147B}"/>
-              </a:ext>
-            </a:extLst>
-          </p:cNvPr>
-          <p:cNvSpPr>
-            <a:spLocks noGrp="1"/>
-          </p:cNvSpPr>
-          <p:nvPr>
-            <p:ph type="body" sz="quarter" idx="38"/>
-          </p:nvPr>
-        </p:nvSpPr>
-        <p:spPr>
-          <a:xfrm>
-            <a:off x="8019288" y="3374136"/>
-            <a:ext cx="2468880" cy="1371600"/>
-          </a:xfrm>
-        </p:spPr>
-        <p:txBody>
-          <a:bodyPr vert="horz" lIns="91440" tIns="45720" rIns="91440" bIns="45720" rtlCol="0" anchor="t">
-            <a:normAutofit/>
-          </a:bodyPr>
-          <a:lstStyle/>
-          <a:p/>
-        </p:txBody>
-      </p:sp>
-      <p:sp>
-        <p:nvSpPr>
-          <p:cNvPr id="11" name="Date Placeholder 10">
-            <a:extLst>
-              <a:ext uri="{FF2B5EF4-FFF2-40B4-BE49-F238E27FC236}">
-                <a16:creationId xmlns:a16="http://schemas.microsoft.com/office/drawing/2014/main" id="{FAAA39EA-03A4-4F7C-AD28-57646912356E}"/>
-              </a:ext>
-            </a:extLst>
-          </p:cNvPr>
-          <p:cNvSpPr>
-            <a:spLocks noGrp="1"/>
-          </p:cNvSpPr>
-          <p:nvPr>
-            <p:ph type="dt" sz="half" idx="39"/>
-          </p:nvPr>
-        </p:nvSpPr>
-        <p:spPr>
-          <a:xfrm>
-            <a:off x="838200" y="6356350"/>
-            <a:ext cx="2743200" cy="365125"/>
-          </a:xfrm>
-        </p:spPr>
-        <p:txBody>
-          <a:bodyPr/>
-          <a:lstStyle/>
-          <a:p/>
-        </p:txBody>
-      </p:sp>
-      <p:sp>
-        <p:nvSpPr>
-          <p:cNvPr id="3" name="Footer Placeholder 2">
-            <a:extLst>
-              <a:ext uri="{FF2B5EF4-FFF2-40B4-BE49-F238E27FC236}">
-                <a16:creationId xmlns:a16="http://schemas.microsoft.com/office/drawing/2014/main" id="{005C44B1-BA82-483C-BD91-F89067442F9E}"/>
-              </a:ext>
-            </a:extLst>
-          </p:cNvPr>
-          <p:cNvSpPr>
-            <a:spLocks noGrp="1"/>
-          </p:cNvSpPr>
-          <p:nvPr>
-            <p:ph type="ftr" sz="quarter" idx="10"/>
-          </p:nvPr>
-        </p:nvSpPr>
-        <p:spPr>
-          <a:xfrm>
-            <a:off x="4038600" y="6356350"/>
-            <a:ext cx="4114800" cy="365125"/>
-          </a:xfrm>
-        </p:spPr>
-        <p:txBody>
-          <a:bodyPr/>
-          <a:lstStyle/>
-          <a:p/>
-        </p:txBody>
-      </p:sp>
-      <p:sp>
-        <p:nvSpPr>
-          <p:cNvPr id="4" name="Slide Number Placeholder 3">
-            <a:extLst>
-              <a:ext uri="{FF2B5EF4-FFF2-40B4-BE49-F238E27FC236}">
-                <a16:creationId xmlns:a16="http://schemas.microsoft.com/office/drawing/2014/main" id="{79ED4A67-3A46-4F54-A12A-EAE1B53E6457}"/>
-              </a:ext>
-            </a:extLst>
-          </p:cNvPr>
-          <p:cNvSpPr>
-            <a:spLocks noGrp="1"/>
-          </p:cNvSpPr>
-          <p:nvPr>
-            <p:ph type="sldNum" sz="quarter" idx="11"/>
-          </p:nvPr>
-        </p:nvSpPr>
-        <p:spPr>
-          <a:xfrm>
-            <a:off x="8610600" y="6356350"/>
-            <a:ext cx="2743200" cy="365125"/>
-          </a:xfrm>
-        </p:spPr>
-        <p:txBody>
-          <a:bodyPr/>
-          <a:lstStyle/>
-          <a:p>
-            <a:endParaRPr lang="en-ZA" dirty="0"/>
-          </a:p>
-        </p:txBody>
-      </p:sp>
-      <p:sp>
-        <p:nvSpPr>
           <p:cNvPr id="16" name="TextBox 15"/>
           <p:cNvSpPr txBox="1"/>
           <p:nvPr/>
@@ -32311,320 +29372,7 @@
       </p:pic>
       <p:sp>
         <p:nvSpPr>
-          <p:cNvPr id="23" name="Title 22">
-            <a:extLst>
-              <a:ext uri="{FF2B5EF4-FFF2-40B4-BE49-F238E27FC236}">
-                <a16:creationId xmlns:a16="http://schemas.microsoft.com/office/drawing/2014/main" id="{5FB75C3E-5885-49DD-8190-BB1E8C511A7E}"/>
-              </a:ext>
-            </a:extLst>
-          </p:cNvPr>
-          <p:cNvSpPr>
-            <a:spLocks noGrp="1"/>
-          </p:cNvSpPr>
-          <p:nvPr>
-            <p:ph type="title"/>
-          </p:nvPr>
-        </p:nvSpPr>
-        <p:spPr>
-          <a:xfrm>
-            <a:off x="838200" y="365125"/>
-            <a:ext cx="10515600" cy="1325563"/>
-          </a:xfrm>
-        </p:spPr>
-        <p:txBody>
-          <a:bodyPr/>
-          <a:lstStyle/>
-          <a:p/>
-        </p:txBody>
-      </p:sp>
-      <p:sp>
-        <p:nvSpPr>
-          <p:cNvPr id="18" name="Text Placeholder 17">
-            <a:extLst>
-              <a:ext uri="{FF2B5EF4-FFF2-40B4-BE49-F238E27FC236}">
-                <a16:creationId xmlns:a16="http://schemas.microsoft.com/office/drawing/2014/main" id="{2FF04D30-F224-451C-9FFE-3930E78F7E5C}"/>
-              </a:ext>
-            </a:extLst>
-          </p:cNvPr>
-          <p:cNvSpPr>
-            <a:spLocks noGrp="1"/>
-          </p:cNvSpPr>
-          <p:nvPr>
-            <p:ph type="body" sz="quarter" idx="39"/>
-          </p:nvPr>
-        </p:nvSpPr>
-        <p:spPr/>
-        <p:txBody>
-          <a:bodyPr/>
-          <a:lstStyle/>
-          <a:p>
-            <a:endParaRPr lang="en-US" dirty="0"/>
-          </a:p>
-        </p:txBody>
-      </p:sp>
-      <p:sp>
-        <p:nvSpPr>
-          <p:cNvPr id="27" name="Text Placeholder 26">
-            <a:extLst>
-              <a:ext uri="{FF2B5EF4-FFF2-40B4-BE49-F238E27FC236}">
-                <a16:creationId xmlns:a16="http://schemas.microsoft.com/office/drawing/2014/main" id="{3C7B196D-A4EB-4450-8C2E-D4F26C77F843}"/>
-              </a:ext>
-            </a:extLst>
-          </p:cNvPr>
-          <p:cNvSpPr>
-            <a:spLocks noGrp="1"/>
-          </p:cNvSpPr>
-          <p:nvPr>
-            <p:ph type="body" sz="quarter" idx="30"/>
-          </p:nvPr>
-        </p:nvSpPr>
-        <p:spPr>
-          <a:xfrm>
-            <a:off x="1767130" y="2752344"/>
-            <a:ext cx="2560320" cy="603504"/>
-          </a:xfrm>
-        </p:spPr>
-        <p:txBody>
-          <a:bodyPr anchor="ctr">
-            <a:normAutofit/>
-          </a:bodyPr>
-          <a:lstStyle/>
-          <a:p/>
-        </p:txBody>
-      </p:sp>
-      <p:sp>
-        <p:nvSpPr>
-          <p:cNvPr id="28" name="Text Placeholder 27">
-            <a:extLst>
-              <a:ext uri="{FF2B5EF4-FFF2-40B4-BE49-F238E27FC236}">
-                <a16:creationId xmlns:a16="http://schemas.microsoft.com/office/drawing/2014/main" id="{16852965-5187-4677-B878-4167E7B69252}"/>
-              </a:ext>
-            </a:extLst>
-          </p:cNvPr>
-          <p:cNvSpPr>
-            <a:spLocks noGrp="1"/>
-          </p:cNvSpPr>
-          <p:nvPr>
-            <p:ph type="body" sz="quarter" idx="31"/>
-          </p:nvPr>
-        </p:nvSpPr>
-        <p:spPr>
-          <a:xfrm>
-            <a:off x="4815840" y="2752344"/>
-            <a:ext cx="2560320" cy="603504"/>
-          </a:xfrm>
-        </p:spPr>
-        <p:txBody>
-          <a:bodyPr anchor="ctr"/>
-          <a:lstStyle/>
-          <a:p/>
-        </p:txBody>
-      </p:sp>
-      <p:sp>
-        <p:nvSpPr>
-          <p:cNvPr id="29" name="Text Placeholder 28">
-            <a:extLst>
-              <a:ext uri="{FF2B5EF4-FFF2-40B4-BE49-F238E27FC236}">
-                <a16:creationId xmlns:a16="http://schemas.microsoft.com/office/drawing/2014/main" id="{A362839C-0A6B-4785-ACD4-42645537AFF4}"/>
-              </a:ext>
-            </a:extLst>
-          </p:cNvPr>
-          <p:cNvSpPr>
-            <a:spLocks noGrp="1"/>
-          </p:cNvSpPr>
-          <p:nvPr>
-            <p:ph type="body" sz="quarter" idx="33"/>
-          </p:nvPr>
-        </p:nvSpPr>
-        <p:spPr>
-          <a:xfrm>
-            <a:off x="7867194" y="2752344"/>
-            <a:ext cx="2560320" cy="603504"/>
-          </a:xfrm>
-        </p:spPr>
-        <p:txBody>
-          <a:bodyPr anchor="ctr"/>
-          <a:lstStyle/>
-          <a:p/>
-        </p:txBody>
-      </p:sp>
-      <p:sp>
-        <p:nvSpPr>
-          <p:cNvPr id="3" name="Text Placeholder 2">
-            <a:extLst>
-              <a:ext uri="{FF2B5EF4-FFF2-40B4-BE49-F238E27FC236}">
-                <a16:creationId xmlns:a16="http://schemas.microsoft.com/office/drawing/2014/main" id="{082463A9-91ED-406C-A142-DF9DBB5C018D}"/>
-              </a:ext>
-            </a:extLst>
-          </p:cNvPr>
-          <p:cNvSpPr>
-            <a:spLocks noGrp="1"/>
-          </p:cNvSpPr>
-          <p:nvPr>
-            <p:ph type="body" sz="quarter" idx="35"/>
-          </p:nvPr>
-        </p:nvSpPr>
-        <p:spPr>
-          <a:xfrm>
-            <a:off x="1767130" y="3502152"/>
-            <a:ext cx="2560320" cy="1371600"/>
-          </a:xfrm>
-        </p:spPr>
-        <p:txBody>
-          <a:bodyPr vert="horz" lIns="91440" tIns="45720" rIns="91440" bIns="45720" rtlCol="0" anchor="t">
-            <a:normAutofit/>
-          </a:bodyPr>
-          <a:lstStyle/>
-          <a:p/>
-        </p:txBody>
-      </p:sp>
-      <p:sp>
-        <p:nvSpPr>
-          <p:cNvPr id="40" name="Text Placeholder 39">
-            <a:extLst>
-              <a:ext uri="{FF2B5EF4-FFF2-40B4-BE49-F238E27FC236}">
-                <a16:creationId xmlns:a16="http://schemas.microsoft.com/office/drawing/2014/main" id="{FDC3A9B5-5598-4CD5-88DB-141F093C2F5C}"/>
-              </a:ext>
-            </a:extLst>
-          </p:cNvPr>
-          <p:cNvSpPr>
-            <a:spLocks noGrp="1"/>
-          </p:cNvSpPr>
-          <p:nvPr>
-            <p:ph type="body" sz="quarter" idx="36"/>
-          </p:nvPr>
-        </p:nvSpPr>
-        <p:spPr>
-          <a:xfrm>
-            <a:off x="4815840" y="3502152"/>
-            <a:ext cx="2560320" cy="1371600"/>
-          </a:xfrm>
-        </p:spPr>
-        <p:txBody>
-          <a:bodyPr/>
-          <a:lstStyle/>
-          <a:p>
-            <a:endParaRPr lang="en-US" dirty="0"/>
-          </a:p>
-        </p:txBody>
-      </p:sp>
-      <p:sp>
-        <p:nvSpPr>
-          <p:cNvPr id="41" name="Text Placeholder 40">
-            <a:extLst>
-              <a:ext uri="{FF2B5EF4-FFF2-40B4-BE49-F238E27FC236}">
-                <a16:creationId xmlns:a16="http://schemas.microsoft.com/office/drawing/2014/main" id="{624C0B95-53C2-4500-8EAE-8B7F73AAE5B5}"/>
-              </a:ext>
-            </a:extLst>
-          </p:cNvPr>
-          <p:cNvSpPr>
-            <a:spLocks noGrp="1"/>
-          </p:cNvSpPr>
-          <p:nvPr>
-            <p:ph type="body" sz="quarter" idx="37"/>
-          </p:nvPr>
-        </p:nvSpPr>
-        <p:spPr>
-          <a:xfrm>
-            <a:off x="7867194" y="3502152"/>
-            <a:ext cx="2560320" cy="1371600"/>
-          </a:xfrm>
-        </p:spPr>
-        <p:txBody>
-          <a:bodyPr/>
-          <a:lstStyle/>
-          <a:p/>
-        </p:txBody>
-      </p:sp>
-      <p:sp>
-        <p:nvSpPr>
-          <p:cNvPr id="2" name="Date Placeholder 1">
-            <a:extLst>
-              <a:ext uri="{FF2B5EF4-FFF2-40B4-BE49-F238E27FC236}">
-                <a16:creationId xmlns:a16="http://schemas.microsoft.com/office/drawing/2014/main" id="{86F27C7F-0ED2-4657-B2A4-AF40C8659E41}"/>
-              </a:ext>
-            </a:extLst>
-          </p:cNvPr>
-          <p:cNvSpPr>
-            <a:spLocks noGrp="1"/>
-          </p:cNvSpPr>
-          <p:nvPr>
-            <p:ph type="dt" sz="half" idx="38"/>
-          </p:nvPr>
-        </p:nvSpPr>
-        <p:spPr>
-          <a:xfrm>
-            <a:off x="838200" y="6356350"/>
-            <a:ext cx="2743200" cy="365125"/>
-          </a:xfrm>
-        </p:spPr>
-        <p:txBody>
-          <a:bodyPr/>
-          <a:lstStyle/>
-          <a:p/>
-        </p:txBody>
-      </p:sp>
-      <p:sp>
-        <p:nvSpPr>
-          <p:cNvPr id="6" name="Footer Placeholder 5">
-            <a:extLst>
-              <a:ext uri="{FF2B5EF4-FFF2-40B4-BE49-F238E27FC236}">
-                <a16:creationId xmlns:a16="http://schemas.microsoft.com/office/drawing/2014/main" id="{232271CD-BE6E-4BDA-AE95-037EC2B14655}"/>
-              </a:ext>
-            </a:extLst>
-          </p:cNvPr>
-          <p:cNvSpPr>
-            <a:spLocks noGrp="1"/>
-          </p:cNvSpPr>
-          <p:nvPr>
-            <p:ph type="ftr" sz="quarter" idx="10"/>
-          </p:nvPr>
-        </p:nvSpPr>
-        <p:spPr>
-          <a:xfrm>
-            <a:off x="4038600" y="6356350"/>
-            <a:ext cx="4114800" cy="365125"/>
-          </a:xfrm>
-        </p:spPr>
-        <p:txBody>
-          <a:bodyPr/>
-          <a:lstStyle/>
-          <a:p/>
-        </p:txBody>
-      </p:sp>
-      <p:sp>
-        <p:nvSpPr>
-          <p:cNvPr id="7" name="Slide Number Placeholder 6">
-            <a:extLst>
-              <a:ext uri="{FF2B5EF4-FFF2-40B4-BE49-F238E27FC236}">
-                <a16:creationId xmlns:a16="http://schemas.microsoft.com/office/drawing/2014/main" id="{D52C7452-8DFB-4E08-B517-7802CB6719F4}"/>
-              </a:ext>
-            </a:extLst>
-          </p:cNvPr>
-          <p:cNvSpPr>
-            <a:spLocks noGrp="1"/>
-          </p:cNvSpPr>
-          <p:nvPr>
-            <p:ph type="sldNum" sz="quarter" idx="11"/>
-          </p:nvPr>
-        </p:nvSpPr>
-        <p:spPr>
-          <a:xfrm>
-            <a:off x="8610600" y="6356350"/>
-            <a:ext cx="2743200" cy="365125"/>
-          </a:xfrm>
-        </p:spPr>
-        <p:txBody>
-          <a:bodyPr/>
-          <a:lstStyle/>
-          <a:p>
-            <a:endParaRPr lang="en-ZA" dirty="0"/>
-          </a:p>
-        </p:txBody>
-      </p:sp>
-      <p:sp>
-        <p:nvSpPr>
-          <p:cNvPr id="42" name="TextBox 41"/>
+          <p:cNvPr id="11" name="TextBox 10"/>
           <p:cNvSpPr txBox="1"/>
           <p:nvPr/>
         </p:nvSpPr>
@@ -32659,7 +29407,7 @@
       </p:sp>
       <p:sp>
         <p:nvSpPr>
-          <p:cNvPr id="43" name="TextBox 42"/>
+          <p:cNvPr id="12" name="TextBox 11"/>
           <p:cNvSpPr txBox="1"/>
           <p:nvPr/>
         </p:nvSpPr>
@@ -32694,7 +29442,7 @@
       </p:sp>
       <p:sp>
         <p:nvSpPr>
-          <p:cNvPr id="44" name="TextBox 43"/>
+          <p:cNvPr id="13" name="TextBox 12"/>
           <p:cNvSpPr txBox="1"/>
           <p:nvPr/>
         </p:nvSpPr>
@@ -32729,7 +29477,7 @@
       </p:sp>
       <p:sp>
         <p:nvSpPr>
-          <p:cNvPr id="45" name="TextBox 44"/>
+          <p:cNvPr id="14" name="TextBox 13"/>
           <p:cNvSpPr txBox="1"/>
           <p:nvPr/>
         </p:nvSpPr>
@@ -32764,7 +29512,7 @@
       </p:sp>
       <p:sp>
         <p:nvSpPr>
-          <p:cNvPr id="46" name="TextBox 45"/>
+          <p:cNvPr id="15" name="TextBox 14"/>
           <p:cNvSpPr txBox="1"/>
           <p:nvPr/>
         </p:nvSpPr>
@@ -32799,7 +29547,7 @@
       </p:sp>
       <p:sp>
         <p:nvSpPr>
-          <p:cNvPr id="47" name="TextBox 46"/>
+          <p:cNvPr id="16" name="TextBox 15"/>
           <p:cNvSpPr txBox="1"/>
           <p:nvPr/>
         </p:nvSpPr>
@@ -32834,7 +29582,7 @@
       </p:sp>
       <p:sp>
         <p:nvSpPr>
-          <p:cNvPr id="48" name="TextBox 47"/>
+          <p:cNvPr id="17" name="TextBox 16"/>
           <p:cNvSpPr txBox="1"/>
           <p:nvPr/>
         </p:nvSpPr>
@@ -32869,7 +29617,7 @@
       </p:sp>
       <p:sp>
         <p:nvSpPr>
-          <p:cNvPr id="49" name="TextBox 48"/>
+          <p:cNvPr id="18" name="TextBox 17"/>
           <p:cNvSpPr txBox="1"/>
           <p:nvPr/>
         </p:nvSpPr>
@@ -32904,7 +29652,7 @@
       </p:sp>
       <p:sp>
         <p:nvSpPr>
-          <p:cNvPr id="50" name="TextBox 49"/>
+          <p:cNvPr id="19" name="TextBox 18"/>
           <p:cNvSpPr txBox="1"/>
           <p:nvPr/>
         </p:nvSpPr>
@@ -32939,7 +29687,7 @@
       </p:sp>
       <p:sp>
         <p:nvSpPr>
-          <p:cNvPr id="51" name="TextBox 50"/>
+          <p:cNvPr id="20" name="TextBox 19"/>
           <p:cNvSpPr txBox="1"/>
           <p:nvPr/>
         </p:nvSpPr>
@@ -32974,7 +29722,7 @@
       </p:sp>
       <p:sp>
         <p:nvSpPr>
-          <p:cNvPr id="52" name="TextBox 51"/>
+          <p:cNvPr id="21" name="TextBox 20"/>
           <p:cNvSpPr txBox="1"/>
           <p:nvPr/>
         </p:nvSpPr>
@@ -33009,7 +29757,7 @@
       </p:sp>
       <p:cxnSp>
         <p:nvCxnSpPr>
-          <p:cNvPr id="53" name="Connector 52"/>
+          <p:cNvPr id="22" name="Connector 21"/>
           <p:cNvCxnSpPr/>
           <p:nvPr/>
         </p:nvCxnSpPr>
@@ -33044,7 +29792,7 @@
       </p:cxnSp>
       <p:cxnSp>
         <p:nvCxnSpPr>
-          <p:cNvPr id="54" name="Connector 53"/>
+          <p:cNvPr id="23" name="Connector 22"/>
           <p:cNvCxnSpPr/>
           <p:nvPr/>
         </p:nvCxnSpPr>
@@ -33079,7 +29827,7 @@
       </p:cxnSp>
       <p:sp>
         <p:nvSpPr>
-          <p:cNvPr id="55" name="TextBox 54"/>
+          <p:cNvPr id="24" name="TextBox 23"/>
           <p:cNvSpPr txBox="1"/>
           <p:nvPr/>
         </p:nvSpPr>
@@ -33114,7 +29862,7 @@
       </p:sp>
       <p:sp>
         <p:nvSpPr>
-          <p:cNvPr id="56" name="TextBox 55"/>
+          <p:cNvPr id="25" name="TextBox 24"/>
           <p:cNvSpPr txBox="1"/>
           <p:nvPr/>
         </p:nvSpPr>
@@ -33149,7 +29897,7 @@
       </p:sp>
       <p:sp>
         <p:nvSpPr>
-          <p:cNvPr id="57" name="TextBox 56"/>
+          <p:cNvPr id="26" name="TextBox 25"/>
           <p:cNvSpPr txBox="1"/>
           <p:nvPr/>
         </p:nvSpPr>
@@ -33184,7 +29932,7 @@
       </p:sp>
       <p:sp>
         <p:nvSpPr>
-          <p:cNvPr id="58" name="TextBox 57"/>
+          <p:cNvPr id="27" name="TextBox 26"/>
           <p:cNvSpPr txBox="1"/>
           <p:nvPr/>
         </p:nvSpPr>
@@ -33219,7 +29967,7 @@
       </p:sp>
       <p:sp>
         <p:nvSpPr>
-          <p:cNvPr id="59" name="TextBox 58"/>
+          <p:cNvPr id="28" name="TextBox 27"/>
           <p:cNvSpPr txBox="1"/>
           <p:nvPr/>
         </p:nvSpPr>

</xml_diff>

<commit_message>
feat: show seven-step implementation roadmap
</commit_message>
<xml_diff>
--- a/PITCH DECK - MEMORY WITH A RECEIPT - FINAL.pptx
+++ b/PITCH DECK - MEMORY WITH A RECEIPT - FINAL.pptx
@@ -19924,7 +19924,7 @@
           <a:p>
             <a:pPr algn="ctr"/>
             <a:r>
-              <a:rPr sz="3100" b="1" i="0">
+              <a:rPr sz="3000" b="1" i="0">
                 <a:solidFill>
                   <a:srgbClr val="FFFFFF"/>
                 </a:solidFill>
@@ -20793,13 +20793,13 @@
           <a:p>
             <a:pPr algn="ctr"/>
             <a:r>
-              <a:rPr sz="3100" b="1" i="0">
+              <a:rPr sz="3000" b="1" i="0">
                 <a:solidFill>
                   <a:srgbClr val="FFFFFF"/>
                 </a:solidFill>
                 <a:latin typeface="Arial"/>
               </a:rPr>
-              <a:t>ROADMAP &amp; SEAMLESS EXECUTION</a:t>
+              <a:t>OUR 7-STEP IMPLEMENTATION PLAN</a:t>
             </a:r>
           </a:p>
         </p:txBody>
@@ -20812,8 +20812,8 @@
         </p:nvSpPr>
         <p:spPr>
           <a:xfrm>
-            <a:off x="1828800" y="1024128"/>
-            <a:ext cx="8503920" cy="320040"/>
+            <a:off x="1600200" y="1024128"/>
+            <a:ext cx="8961120" cy="320040"/>
           </a:xfrm>
           <a:prstGeom prst="rect">
             <a:avLst/>
@@ -20828,37 +20828,37 @@
           <a:p>
             <a:pPr algn="ctr"/>
             <a:r>
-              <a:rPr sz="1600" b="0" i="0">
+              <a:rPr sz="1500" b="0" i="0">
                 <a:solidFill>
                   <a:srgbClr val="FFFFFF"/>
                 </a:solidFill>
                 <a:latin typeface="Arial"/>
               </a:rPr>
-              <a:t>We planned for evidence first — and shipped the whole loop in that order.</a:t>
-            </a:r>
-          </a:p>
-        </p:txBody>
-      </p:sp>
-      <p:sp>
-        <p:nvSpPr>
-          <p:cNvPr id="50" name="Rounded Rectangle 49"/>
+              <a:t>We planned the full system end to end — then executed the loop in order.</a:t>
+            </a:r>
+          </a:p>
+        </p:txBody>
+      </p:sp>
+      <p:sp>
+        <p:nvSpPr>
+          <p:cNvPr id="50" name="Rectangle 49"/>
           <p:cNvSpPr/>
           <p:nvPr/>
         </p:nvSpPr>
         <p:spPr>
           <a:xfrm>
-            <a:off x="1417320" y="1874519"/>
-            <a:ext cx="2971800" cy="2514600"/>
-          </a:xfrm>
-          <a:prstGeom prst="roundRect">
+            <a:off x="658368" y="1517904"/>
+            <a:ext cx="10881360" cy="4315968"/>
+          </a:xfrm>
+          <a:prstGeom prst="rect">
             <a:avLst/>
           </a:prstGeom>
           <a:solidFill>
-            <a:srgbClr val="FFFFFF"/>
+            <a:srgbClr val="000000"/>
           </a:solidFill>
           <a:ln>
             <a:solidFill>
-              <a:srgbClr val="FFFFFF"/>
+              <a:srgbClr val="000000"/>
             </a:solidFill>
           </a:ln>
         </p:spPr>
@@ -20884,26 +20884,236 @@
           </a:p>
         </p:txBody>
       </p:sp>
-      <p:sp>
-        <p:nvSpPr>
-          <p:cNvPr id="51" name="Rectangle 50"/>
+      <p:cxnSp>
+        <p:nvCxnSpPr>
+          <p:cNvPr id="51" name="Connector 50"/>
+          <p:cNvCxnSpPr/>
+          <p:nvPr/>
+        </p:nvCxnSpPr>
+        <p:spPr>
+          <a:xfrm>
+            <a:off x="3136392" y="2359152"/>
+            <a:ext cx="484632" cy="0"/>
+          </a:xfrm>
+          <a:prstGeom prst="line">
+            <a:avLst/>
+          </a:prstGeom>
+          <a:ln w="31750">
+            <a:solidFill>
+              <a:srgbClr val="0995A9"/>
+            </a:solidFill>
+          </a:ln>
+        </p:spPr>
+        <p:style>
+          <a:lnRef idx="2">
+            <a:schemeClr val="accent1"/>
+          </a:lnRef>
+          <a:fillRef idx="0">
+            <a:schemeClr val="accent1"/>
+          </a:fillRef>
+          <a:effectRef idx="1">
+            <a:schemeClr val="accent1"/>
+          </a:effectRef>
+          <a:fontRef idx="minor">
+            <a:schemeClr val="tx1"/>
+          </a:fontRef>
+        </p:style>
+      </p:cxnSp>
+      <p:cxnSp>
+        <p:nvCxnSpPr>
+          <p:cNvPr id="52" name="Connector 51"/>
+          <p:cNvCxnSpPr/>
+          <p:nvPr/>
+        </p:nvCxnSpPr>
+        <p:spPr>
+          <a:xfrm>
+            <a:off x="5861304" y="2359152"/>
+            <a:ext cx="484632" cy="0"/>
+          </a:xfrm>
+          <a:prstGeom prst="line">
+            <a:avLst/>
+          </a:prstGeom>
+          <a:ln w="31750">
+            <a:solidFill>
+              <a:srgbClr val="0995A9"/>
+            </a:solidFill>
+          </a:ln>
+        </p:spPr>
+        <p:style>
+          <a:lnRef idx="2">
+            <a:schemeClr val="accent1"/>
+          </a:lnRef>
+          <a:fillRef idx="0">
+            <a:schemeClr val="accent1"/>
+          </a:fillRef>
+          <a:effectRef idx="1">
+            <a:schemeClr val="accent1"/>
+          </a:effectRef>
+          <a:fontRef idx="minor">
+            <a:schemeClr val="tx1"/>
+          </a:fontRef>
+        </p:style>
+      </p:cxnSp>
+      <p:cxnSp>
+        <p:nvCxnSpPr>
+          <p:cNvPr id="53" name="Connector 52"/>
+          <p:cNvCxnSpPr/>
+          <p:nvPr/>
+        </p:nvCxnSpPr>
+        <p:spPr>
+          <a:xfrm>
+            <a:off x="8586216" y="2359152"/>
+            <a:ext cx="484632" cy="0"/>
+          </a:xfrm>
+          <a:prstGeom prst="line">
+            <a:avLst/>
+          </a:prstGeom>
+          <a:ln w="31750">
+            <a:solidFill>
+              <a:srgbClr val="0995A9"/>
+            </a:solidFill>
+          </a:ln>
+        </p:spPr>
+        <p:style>
+          <a:lnRef idx="2">
+            <a:schemeClr val="accent1"/>
+          </a:lnRef>
+          <a:fillRef idx="0">
+            <a:schemeClr val="accent1"/>
+          </a:fillRef>
+          <a:effectRef idx="1">
+            <a:schemeClr val="accent1"/>
+          </a:effectRef>
+          <a:fontRef idx="minor">
+            <a:schemeClr val="tx1"/>
+          </a:fontRef>
+        </p:style>
+      </p:cxnSp>
+      <p:cxnSp>
+        <p:nvCxnSpPr>
+          <p:cNvPr id="54" name="Connector 53"/>
+          <p:cNvCxnSpPr/>
+          <p:nvPr/>
+        </p:nvCxnSpPr>
+        <p:spPr>
+          <a:xfrm>
+            <a:off x="5943600" y="2999232"/>
+            <a:ext cx="0" cy="310896"/>
+          </a:xfrm>
+          <a:prstGeom prst="line">
+            <a:avLst/>
+          </a:prstGeom>
+          <a:ln w="31750">
+            <a:solidFill>
+              <a:srgbClr val="0995A9"/>
+            </a:solidFill>
+          </a:ln>
+        </p:spPr>
+        <p:style>
+          <a:lnRef idx="2">
+            <a:schemeClr val="accent1"/>
+          </a:lnRef>
+          <a:fillRef idx="0">
+            <a:schemeClr val="accent1"/>
+          </a:fillRef>
+          <a:effectRef idx="1">
+            <a:schemeClr val="accent1"/>
+          </a:effectRef>
+          <a:fontRef idx="minor">
+            <a:schemeClr val="tx1"/>
+          </a:fontRef>
+        </p:style>
+      </p:cxnSp>
+      <p:cxnSp>
+        <p:nvCxnSpPr>
+          <p:cNvPr id="55" name="Connector 54"/>
+          <p:cNvCxnSpPr/>
+          <p:nvPr/>
+        </p:nvCxnSpPr>
+        <p:spPr>
+          <a:xfrm>
+            <a:off x="4498848" y="4096512"/>
+            <a:ext cx="484632" cy="0"/>
+          </a:xfrm>
+          <a:prstGeom prst="line">
+            <a:avLst/>
+          </a:prstGeom>
+          <a:ln w="31750">
+            <a:solidFill>
+              <a:srgbClr val="0995A9"/>
+            </a:solidFill>
+          </a:ln>
+        </p:spPr>
+        <p:style>
+          <a:lnRef idx="2">
+            <a:schemeClr val="accent1"/>
+          </a:lnRef>
+          <a:fillRef idx="0">
+            <a:schemeClr val="accent1"/>
+          </a:fillRef>
+          <a:effectRef idx="1">
+            <a:schemeClr val="accent1"/>
+          </a:effectRef>
+          <a:fontRef idx="minor">
+            <a:schemeClr val="tx1"/>
+          </a:fontRef>
+        </p:style>
+      </p:cxnSp>
+      <p:cxnSp>
+        <p:nvCxnSpPr>
+          <p:cNvPr id="56" name="Connector 55"/>
+          <p:cNvCxnSpPr/>
+          <p:nvPr/>
+        </p:nvCxnSpPr>
+        <p:spPr>
+          <a:xfrm>
+            <a:off x="7223760" y="4096512"/>
+            <a:ext cx="484632" cy="0"/>
+          </a:xfrm>
+          <a:prstGeom prst="line">
+            <a:avLst/>
+          </a:prstGeom>
+          <a:ln w="31750">
+            <a:solidFill>
+              <a:srgbClr val="0995A9"/>
+            </a:solidFill>
+          </a:ln>
+        </p:spPr>
+        <p:style>
+          <a:lnRef idx="2">
+            <a:schemeClr val="accent1"/>
+          </a:lnRef>
+          <a:fillRef idx="0">
+            <a:schemeClr val="accent1"/>
+          </a:fillRef>
+          <a:effectRef idx="1">
+            <a:schemeClr val="accent1"/>
+          </a:effectRef>
+          <a:fontRef idx="minor">
+            <a:schemeClr val="tx1"/>
+          </a:fontRef>
+        </p:style>
+      </p:cxnSp>
+      <p:sp>
+        <p:nvSpPr>
+          <p:cNvPr id="57" name="Rounded Rectangle 56"/>
           <p:cNvSpPr/>
           <p:nvPr/>
         </p:nvSpPr>
         <p:spPr>
           <a:xfrm>
-            <a:off x="1417320" y="1874519"/>
-            <a:ext cx="2971800" cy="91440"/>
-          </a:xfrm>
-          <a:prstGeom prst="rect">
+            <a:off x="896112" y="1719072"/>
+            <a:ext cx="2240280" cy="1280160"/>
+          </a:xfrm>
+          <a:prstGeom prst="roundRect">
             <a:avLst/>
           </a:prstGeom>
           <a:solidFill>
-            <a:srgbClr val="0995A9"/>
+            <a:srgbClr val="FFFFFF"/>
           </a:solidFill>
           <a:ln>
             <a:solidFill>
-              <a:srgbClr val="0995A9"/>
+              <a:srgbClr val="FFFFFF"/>
             </a:solidFill>
           </a:ln>
         </p:spPr>
@@ -20931,96 +21141,24 @@
       </p:sp>
       <p:sp>
         <p:nvSpPr>
-          <p:cNvPr id="52" name="TextBox 51"/>
-          <p:cNvSpPr txBox="1"/>
+          <p:cNvPr id="58" name="Rectangle 57"/>
+          <p:cNvSpPr/>
           <p:nvPr/>
         </p:nvSpPr>
         <p:spPr>
           <a:xfrm>
-            <a:off x="1581912" y="2103120"/>
-            <a:ext cx="2642616" cy="320040"/>
+            <a:off x="896112" y="1719072"/>
+            <a:ext cx="2240280" cy="73152"/>
           </a:xfrm>
           <a:prstGeom prst="rect">
             <a:avLst/>
           </a:prstGeom>
-          <a:noFill/>
-        </p:spPr>
-        <p:txBody>
-          <a:bodyPr wrap="square" lIns="18288" rIns="18288" tIns="18288" bIns="18288" anchor="t">
-            <a:spAutoFit/>
-          </a:bodyPr>
-          <a:lstStyle/>
-          <a:p>
-            <a:pPr algn="ctr"/>
-            <a:r>
-              <a:rPr sz="1600" b="1" i="0">
-                <a:solidFill>
-                  <a:srgbClr val="164D71"/>
-                </a:solidFill>
-                <a:latin typeface="Arial"/>
-              </a:rPr>
-              <a:t>1 · LOCK THE MEMORY</a:t>
-            </a:r>
-          </a:p>
-        </p:txBody>
-      </p:sp>
-      <p:sp>
-        <p:nvSpPr>
-          <p:cNvPr id="53" name="TextBox 52"/>
-          <p:cNvSpPr txBox="1"/>
-          <p:nvPr/>
-        </p:nvSpPr>
-        <p:spPr>
-          <a:xfrm>
-            <a:off x="1618488" y="2624327"/>
-            <a:ext cx="2569464" cy="1600200"/>
-          </a:xfrm>
-          <a:prstGeom prst="rect">
-            <a:avLst/>
-          </a:prstGeom>
-          <a:noFill/>
-        </p:spPr>
-        <p:txBody>
-          <a:bodyPr wrap="square" lIns="9144" rIns="9144" tIns="9144" bIns="9144" anchor="ctr">
-            <a:spAutoFit/>
-          </a:bodyPr>
-          <a:lstStyle/>
-          <a:p>
-            <a:pPr algn="ctr"/>
-            <a:r>
-              <a:rPr sz="1300" b="0" i="0">
-                <a:solidFill>
-                  <a:srgbClr val="121A22"/>
-                </a:solidFill>
-                <a:latin typeface="Arial"/>
-              </a:rPr>
-              <a:t>45 source files
-→ 2,534 atomic Evidence Units
-→ stable, citable IDs</a:t>
-            </a:r>
-          </a:p>
-        </p:txBody>
-      </p:sp>
-      <p:sp>
-        <p:nvSpPr>
-          <p:cNvPr id="54" name="Rounded Rectangle 53"/>
-          <p:cNvSpPr/>
-          <p:nvPr/>
-        </p:nvSpPr>
-        <p:spPr>
-          <a:xfrm>
-            <a:off x="4590288" y="1874519"/>
-            <a:ext cx="2971800" cy="2514600"/>
-          </a:xfrm>
-          <a:prstGeom prst="roundRect">
-            <a:avLst/>
-          </a:prstGeom>
           <a:solidFill>
-            <a:srgbClr val="FFFFFF"/>
+            <a:srgbClr val="0995A9"/>
           </a:solidFill>
           <a:ln>
             <a:solidFill>
-              <a:srgbClr val="FFFFFF"/>
+              <a:srgbClr val="0995A9"/>
             </a:solidFill>
           </a:ln>
         </p:spPr>
@@ -21048,16 +21186,16 @@
       </p:sp>
       <p:sp>
         <p:nvSpPr>
-          <p:cNvPr id="55" name="Rectangle 54"/>
+          <p:cNvPr id="59" name="Oval 58"/>
           <p:cNvSpPr/>
           <p:nvPr/>
         </p:nvSpPr>
         <p:spPr>
           <a:xfrm>
-            <a:off x="4590288" y="1874519"/>
-            <a:ext cx="2971800" cy="91440"/>
-          </a:xfrm>
-          <a:prstGeom prst="rect">
+            <a:off x="1033271" y="1865376"/>
+            <a:ext cx="283464" cy="283464"/>
+          </a:xfrm>
+          <a:prstGeom prst="ellipse">
             <a:avLst/>
           </a:prstGeom>
           <a:solidFill>
@@ -21088,19 +21226,28 @@
           <a:lstStyle/>
           <a:p>
             <a:pPr algn="ctr"/>
-          </a:p>
-        </p:txBody>
-      </p:sp>
-      <p:sp>
-        <p:nvSpPr>
-          <p:cNvPr id="56" name="TextBox 55"/>
+            <a:r>
+              <a:rPr sz="1000" b="1">
+                <a:solidFill>
+                  <a:srgbClr val="FFFFFF"/>
+                </a:solidFill>
+                <a:latin typeface="Arial"/>
+              </a:rPr>
+              <a:t>1</a:t>
+            </a:r>
+          </a:p>
+        </p:txBody>
+      </p:sp>
+      <p:sp>
+        <p:nvSpPr>
+          <p:cNvPr id="60" name="TextBox 59"/>
           <p:cNvSpPr txBox="1"/>
           <p:nvPr/>
         </p:nvSpPr>
         <p:spPr>
           <a:xfrm>
-            <a:off x="4754879" y="2103120"/>
-            <a:ext cx="2642616" cy="320040"/>
+            <a:off x="1399032" y="1847088"/>
+            <a:ext cx="1618488" cy="256032"/>
           </a:xfrm>
           <a:prstGeom prst="rect">
             <a:avLst/>
@@ -21113,29 +21260,29 @@
           </a:bodyPr>
           <a:lstStyle/>
           <a:p>
-            <a:pPr algn="ctr"/>
-            <a:r>
-              <a:rPr sz="1600" b="1" i="0">
+            <a:pPr algn="l"/>
+            <a:r>
+              <a:rPr sz="1100" b="1" i="0">
                 <a:solidFill>
                   <a:srgbClr val="164D71"/>
                 </a:solidFill>
                 <a:latin typeface="Arial"/>
               </a:rPr>
-              <a:t>2 · BUILD THE AUDITOR</a:t>
-            </a:r>
-          </a:p>
-        </p:txBody>
-      </p:sp>
-      <p:sp>
-        <p:nvSpPr>
-          <p:cNvPr id="57" name="TextBox 56"/>
+              <a:t>INGEST &amp; PARSE</a:t>
+            </a:r>
+          </a:p>
+        </p:txBody>
+      </p:sp>
+      <p:sp>
+        <p:nvSpPr>
+          <p:cNvPr id="61" name="TextBox 60"/>
           <p:cNvSpPr txBox="1"/>
           <p:nvPr/>
         </p:nvSpPr>
         <p:spPr>
           <a:xfrm>
-            <a:off x="4791455" y="2624327"/>
-            <a:ext cx="2569464" cy="1600200"/>
+            <a:off x="1060704" y="2240279"/>
+            <a:ext cx="1911096" cy="658367"/>
           </a:xfrm>
           <a:prstGeom prst="rect">
             <a:avLst/>
@@ -21148,32 +21295,30 @@
           </a:bodyPr>
           <a:lstStyle/>
           <a:p>
-            <a:pPr algn="ctr"/>
-            <a:r>
-              <a:rPr sz="1300" b="0" i="0">
+            <a:pPr algn="l"/>
+            <a:r>
+              <a:rPr sz="1100" b="0" i="0">
                 <a:solidFill>
                   <a:srgbClr val="121A22"/>
                 </a:solidFill>
                 <a:latin typeface="Arial"/>
               </a:rPr>
-              <a:t>Retrieve
-→ challenge
-→ reconcile
-→ validate</a:t>
-            </a:r>
-          </a:p>
-        </p:txBody>
-      </p:sp>
-      <p:sp>
-        <p:nvSpPr>
-          <p:cNvPr id="58" name="Rounded Rectangle 57"/>
+              <a:t>Canonicalize the
+45-file archive.</a:t>
+            </a:r>
+          </a:p>
+        </p:txBody>
+      </p:sp>
+      <p:sp>
+        <p:nvSpPr>
+          <p:cNvPr id="62" name="Rounded Rectangle 61"/>
           <p:cNvSpPr/>
           <p:nvPr/>
         </p:nvSpPr>
         <p:spPr>
           <a:xfrm>
-            <a:off x="7763256" y="1874519"/>
-            <a:ext cx="2971800" cy="2514600"/>
+            <a:off x="3621024" y="1719072"/>
+            <a:ext cx="2240280" cy="1280160"/>
           </a:xfrm>
           <a:prstGeom prst="roundRect">
             <a:avLst/>
@@ -21211,14 +21356,14 @@
       </p:sp>
       <p:sp>
         <p:nvSpPr>
-          <p:cNvPr id="59" name="Rectangle 58"/>
+          <p:cNvPr id="63" name="Rectangle 62"/>
           <p:cNvSpPr/>
           <p:nvPr/>
         </p:nvSpPr>
         <p:spPr>
           <a:xfrm>
-            <a:off x="7763256" y="1874519"/>
-            <a:ext cx="2971800" cy="91440"/>
+            <a:off x="3621024" y="1719072"/>
+            <a:ext cx="2240280" cy="73152"/>
           </a:xfrm>
           <a:prstGeom prst="rect">
             <a:avLst/>
@@ -21256,14 +21401,68 @@
       </p:sp>
       <p:sp>
         <p:nvSpPr>
-          <p:cNvPr id="60" name="TextBox 59"/>
+          <p:cNvPr id="64" name="Oval 63"/>
+          <p:cNvSpPr/>
+          <p:nvPr/>
+        </p:nvSpPr>
+        <p:spPr>
+          <a:xfrm>
+            <a:off x="3758184" y="1865376"/>
+            <a:ext cx="283464" cy="283464"/>
+          </a:xfrm>
+          <a:prstGeom prst="ellipse">
+            <a:avLst/>
+          </a:prstGeom>
+          <a:solidFill>
+            <a:srgbClr val="0995A9"/>
+          </a:solidFill>
+          <a:ln>
+            <a:solidFill>
+              <a:srgbClr val="0995A9"/>
+            </a:solidFill>
+          </a:ln>
+        </p:spPr>
+        <p:style>
+          <a:lnRef idx="1">
+            <a:schemeClr val="accent1"/>
+          </a:lnRef>
+          <a:fillRef idx="3">
+            <a:schemeClr val="accent1"/>
+          </a:fillRef>
+          <a:effectRef idx="2">
+            <a:schemeClr val="accent1"/>
+          </a:effectRef>
+          <a:fontRef idx="minor">
+            <a:schemeClr val="lt1"/>
+          </a:fontRef>
+        </p:style>
+        <p:txBody>
+          <a:bodyPr rtlCol="0" anchor="ctr"/>
+          <a:lstStyle/>
+          <a:p>
+            <a:pPr algn="ctr"/>
+            <a:r>
+              <a:rPr sz="1000" b="1">
+                <a:solidFill>
+                  <a:srgbClr val="FFFFFF"/>
+                </a:solidFill>
+                <a:latin typeface="Arial"/>
+              </a:rPr>
+              <a:t>2</a:t>
+            </a:r>
+          </a:p>
+        </p:txBody>
+      </p:sp>
+      <p:sp>
+        <p:nvSpPr>
+          <p:cNvPr id="65" name="TextBox 64"/>
           <p:cNvSpPr txBox="1"/>
           <p:nvPr/>
         </p:nvSpPr>
         <p:spPr>
           <a:xfrm>
-            <a:off x="7927848" y="2103120"/>
-            <a:ext cx="2642616" cy="320040"/>
+            <a:off x="4123944" y="1847088"/>
+            <a:ext cx="1618488" cy="256032"/>
           </a:xfrm>
           <a:prstGeom prst="rect">
             <a:avLst/>
@@ -21276,29 +21475,29 @@
           </a:bodyPr>
           <a:lstStyle/>
           <a:p>
-            <a:pPr algn="ctr"/>
-            <a:r>
-              <a:rPr sz="1600" b="1" i="0">
+            <a:pPr algn="l"/>
+            <a:r>
+              <a:rPr sz="1100" b="1" i="0">
                 <a:solidFill>
                   <a:srgbClr val="164D71"/>
                 </a:solidFill>
                 <a:latin typeface="Arial"/>
               </a:rPr>
-              <a:t>3 · PROVE THE EDGES</a:t>
-            </a:r>
-          </a:p>
-        </p:txBody>
-      </p:sp>
-      <p:sp>
-        <p:nvSpPr>
-          <p:cNvPr id="61" name="TextBox 60"/>
+              <a:t>LOCK MEMORY</a:t>
+            </a:r>
+          </a:p>
+        </p:txBody>
+      </p:sp>
+      <p:sp>
+        <p:nvSpPr>
+          <p:cNvPr id="66" name="TextBox 65"/>
           <p:cNvSpPr txBox="1"/>
           <p:nvPr/>
         </p:nvSpPr>
         <p:spPr>
           <a:xfrm>
-            <a:off x="7964424" y="2624327"/>
-            <a:ext cx="2569464" cy="1600200"/>
+            <a:off x="3785615" y="2240279"/>
+            <a:ext cx="1911096" cy="658367"/>
           </a:xfrm>
           <a:prstGeom prst="rect">
             <a:avLst/>
@@ -21311,31 +21510,174 @@
           </a:bodyPr>
           <a:lstStyle/>
           <a:p>
-            <a:pPr algn="ctr"/>
-            <a:r>
-              <a:rPr sz="1300" b="0" i="0">
+            <a:pPr algn="l"/>
+            <a:r>
+              <a:rPr sz="1100" b="0" i="0">
                 <a:solidFill>
                   <a:srgbClr val="121A22"/>
                 </a:solidFill>
                 <a:latin typeface="Arial"/>
               </a:rPr>
-              <a:t>490 passing tests
-+ privacy/reversal rehearsal
-+ live demo path</a:t>
-            </a:r>
-          </a:p>
-        </p:txBody>
-      </p:sp>
-      <p:sp>
-        <p:nvSpPr>
-          <p:cNvPr id="62" name="TextBox 61"/>
+              <a:t>2,534 atomic units
++ stable Evidence IDs.</a:t>
+            </a:r>
+          </a:p>
+        </p:txBody>
+      </p:sp>
+      <p:sp>
+        <p:nvSpPr>
+          <p:cNvPr id="67" name="Rounded Rectangle 66"/>
+          <p:cNvSpPr/>
+          <p:nvPr/>
+        </p:nvSpPr>
+        <p:spPr>
+          <a:xfrm>
+            <a:off x="6345936" y="1719072"/>
+            <a:ext cx="2240280" cy="1280160"/>
+          </a:xfrm>
+          <a:prstGeom prst="roundRect">
+            <a:avLst/>
+          </a:prstGeom>
+          <a:solidFill>
+            <a:srgbClr val="FFFFFF"/>
+          </a:solidFill>
+          <a:ln>
+            <a:solidFill>
+              <a:srgbClr val="FFFFFF"/>
+            </a:solidFill>
+          </a:ln>
+        </p:spPr>
+        <p:style>
+          <a:lnRef idx="1">
+            <a:schemeClr val="accent1"/>
+          </a:lnRef>
+          <a:fillRef idx="3">
+            <a:schemeClr val="accent1"/>
+          </a:fillRef>
+          <a:effectRef idx="2">
+            <a:schemeClr val="accent1"/>
+          </a:effectRef>
+          <a:fontRef idx="minor">
+            <a:schemeClr val="lt1"/>
+          </a:fontRef>
+        </p:style>
+        <p:txBody>
+          <a:bodyPr rtlCol="0" anchor="ctr"/>
+          <a:lstStyle/>
+          <a:p>
+            <a:pPr algn="ctr"/>
+          </a:p>
+        </p:txBody>
+      </p:sp>
+      <p:sp>
+        <p:nvSpPr>
+          <p:cNvPr id="68" name="Rectangle 67"/>
+          <p:cNvSpPr/>
+          <p:nvPr/>
+        </p:nvSpPr>
+        <p:spPr>
+          <a:xfrm>
+            <a:off x="6345936" y="1719072"/>
+            <a:ext cx="2240280" cy="73152"/>
+          </a:xfrm>
+          <a:prstGeom prst="rect">
+            <a:avLst/>
+          </a:prstGeom>
+          <a:solidFill>
+            <a:srgbClr val="0995A9"/>
+          </a:solidFill>
+          <a:ln>
+            <a:solidFill>
+              <a:srgbClr val="0995A9"/>
+            </a:solidFill>
+          </a:ln>
+        </p:spPr>
+        <p:style>
+          <a:lnRef idx="1">
+            <a:schemeClr val="accent1"/>
+          </a:lnRef>
+          <a:fillRef idx="3">
+            <a:schemeClr val="accent1"/>
+          </a:fillRef>
+          <a:effectRef idx="2">
+            <a:schemeClr val="accent1"/>
+          </a:effectRef>
+          <a:fontRef idx="minor">
+            <a:schemeClr val="lt1"/>
+          </a:fontRef>
+        </p:style>
+        <p:txBody>
+          <a:bodyPr rtlCol="0" anchor="ctr"/>
+          <a:lstStyle/>
+          <a:p>
+            <a:pPr algn="ctr"/>
+          </a:p>
+        </p:txBody>
+      </p:sp>
+      <p:sp>
+        <p:nvSpPr>
+          <p:cNvPr id="69" name="Oval 68"/>
+          <p:cNvSpPr/>
+          <p:nvPr/>
+        </p:nvSpPr>
+        <p:spPr>
+          <a:xfrm>
+            <a:off x="6483096" y="1865376"/>
+            <a:ext cx="283464" cy="283464"/>
+          </a:xfrm>
+          <a:prstGeom prst="ellipse">
+            <a:avLst/>
+          </a:prstGeom>
+          <a:solidFill>
+            <a:srgbClr val="0995A9"/>
+          </a:solidFill>
+          <a:ln>
+            <a:solidFill>
+              <a:srgbClr val="0995A9"/>
+            </a:solidFill>
+          </a:ln>
+        </p:spPr>
+        <p:style>
+          <a:lnRef idx="1">
+            <a:schemeClr val="accent1"/>
+          </a:lnRef>
+          <a:fillRef idx="3">
+            <a:schemeClr val="accent1"/>
+          </a:fillRef>
+          <a:effectRef idx="2">
+            <a:schemeClr val="accent1"/>
+          </a:effectRef>
+          <a:fontRef idx="minor">
+            <a:schemeClr val="lt1"/>
+          </a:fontRef>
+        </p:style>
+        <p:txBody>
+          <a:bodyPr rtlCol="0" anchor="ctr"/>
+          <a:lstStyle/>
+          <a:p>
+            <a:pPr algn="ctr"/>
+            <a:r>
+              <a:rPr sz="1000" b="1">
+                <a:solidFill>
+                  <a:srgbClr val="FFFFFF"/>
+                </a:solidFill>
+                <a:latin typeface="Arial"/>
+              </a:rPr>
+              <a:t>3</a:t>
+            </a:r>
+          </a:p>
+        </p:txBody>
+      </p:sp>
+      <p:sp>
+        <p:nvSpPr>
+          <p:cNvPr id="70" name="TextBox 69"/>
           <p:cNvSpPr txBox="1"/>
           <p:nvPr/>
         </p:nvSpPr>
         <p:spPr>
           <a:xfrm>
-            <a:off x="1965960" y="4882896"/>
-            <a:ext cx="8229600" cy="347472"/>
+            <a:off x="6848856" y="1847088"/>
+            <a:ext cx="1618488" cy="256032"/>
           </a:xfrm>
           <a:prstGeom prst="rect">
             <a:avLst/>
@@ -21348,29 +21690,29 @@
           </a:bodyPr>
           <a:lstStyle/>
           <a:p>
-            <a:pPr algn="ctr"/>
-            <a:r>
-              <a:rPr sz="1700" b="1" i="0">
-                <a:solidFill>
-                  <a:srgbClr val="FFFFFF"/>
+            <a:pPr algn="l"/>
+            <a:r>
+              <a:rPr sz="1100" b="1" i="0">
+                <a:solidFill>
+                  <a:srgbClr val="164D71"/>
                 </a:solidFill>
                 <a:latin typeface="Arial"/>
               </a:rPr>
-              <a:t>PLAN  →  BUILD  →  VERIFY  →  DEMO</a:t>
-            </a:r>
-          </a:p>
-        </p:txBody>
-      </p:sp>
-      <p:sp>
-        <p:nvSpPr>
-          <p:cNvPr id="63" name="TextBox 62"/>
+              <a:t>MAP PEOPLE</a:t>
+            </a:r>
+          </a:p>
+        </p:txBody>
+      </p:sp>
+      <p:sp>
+        <p:nvSpPr>
+          <p:cNvPr id="71" name="TextBox 70"/>
           <p:cNvSpPr txBox="1"/>
           <p:nvPr/>
         </p:nvSpPr>
         <p:spPr>
           <a:xfrm>
-            <a:off x="1828800" y="5358384"/>
-            <a:ext cx="8503920" cy="310896"/>
+            <a:off x="6510528" y="2240279"/>
+            <a:ext cx="1911096" cy="658367"/>
           </a:xfrm>
           <a:prstGeom prst="rect">
             <a:avLst/>
@@ -21378,34 +21720,214 @@
           <a:noFill/>
         </p:spPr>
         <p:txBody>
+          <a:bodyPr wrap="square" lIns="9144" rIns="9144" tIns="9144" bIns="9144" anchor="ctr">
+            <a:spAutoFit/>
+          </a:bodyPr>
+          <a:lstStyle/>
+          <a:p>
+            <a:pPr algn="l"/>
+            <a:r>
+              <a:rPr sz="1100" b="0" i="0">
+                <a:solidFill>
+                  <a:srgbClr val="121A22"/>
+                </a:solidFill>
+                <a:latin typeface="Arial"/>
+              </a:rPr>
+              <a:t>Attribution, aliases
++ relationships.</a:t>
+            </a:r>
+          </a:p>
+        </p:txBody>
+      </p:sp>
+      <p:sp>
+        <p:nvSpPr>
+          <p:cNvPr id="72" name="Rounded Rectangle 71"/>
+          <p:cNvSpPr/>
+          <p:nvPr/>
+        </p:nvSpPr>
+        <p:spPr>
+          <a:xfrm>
+            <a:off x="9070848" y="1719072"/>
+            <a:ext cx="2240280" cy="1280160"/>
+          </a:xfrm>
+          <a:prstGeom prst="roundRect">
+            <a:avLst/>
+          </a:prstGeom>
+          <a:solidFill>
+            <a:srgbClr val="FFFFFF"/>
+          </a:solidFill>
+          <a:ln>
+            <a:solidFill>
+              <a:srgbClr val="FFFFFF"/>
+            </a:solidFill>
+          </a:ln>
+        </p:spPr>
+        <p:style>
+          <a:lnRef idx="1">
+            <a:schemeClr val="accent1"/>
+          </a:lnRef>
+          <a:fillRef idx="3">
+            <a:schemeClr val="accent1"/>
+          </a:fillRef>
+          <a:effectRef idx="2">
+            <a:schemeClr val="accent1"/>
+          </a:effectRef>
+          <a:fontRef idx="minor">
+            <a:schemeClr val="lt1"/>
+          </a:fontRef>
+        </p:style>
+        <p:txBody>
+          <a:bodyPr rtlCol="0" anchor="ctr"/>
+          <a:lstStyle/>
+          <a:p>
+            <a:pPr algn="ctr"/>
+          </a:p>
+        </p:txBody>
+      </p:sp>
+      <p:sp>
+        <p:nvSpPr>
+          <p:cNvPr id="73" name="Rectangle 72"/>
+          <p:cNvSpPr/>
+          <p:nvPr/>
+        </p:nvSpPr>
+        <p:spPr>
+          <a:xfrm>
+            <a:off x="9070848" y="1719072"/>
+            <a:ext cx="2240280" cy="73152"/>
+          </a:xfrm>
+          <a:prstGeom prst="rect">
+            <a:avLst/>
+          </a:prstGeom>
+          <a:solidFill>
+            <a:srgbClr val="0995A9"/>
+          </a:solidFill>
+          <a:ln>
+            <a:solidFill>
+              <a:srgbClr val="0995A9"/>
+            </a:solidFill>
+          </a:ln>
+        </p:spPr>
+        <p:style>
+          <a:lnRef idx="1">
+            <a:schemeClr val="accent1"/>
+          </a:lnRef>
+          <a:fillRef idx="3">
+            <a:schemeClr val="accent1"/>
+          </a:fillRef>
+          <a:effectRef idx="2">
+            <a:schemeClr val="accent1"/>
+          </a:effectRef>
+          <a:fontRef idx="minor">
+            <a:schemeClr val="lt1"/>
+          </a:fontRef>
+        </p:style>
+        <p:txBody>
+          <a:bodyPr rtlCol="0" anchor="ctr"/>
+          <a:lstStyle/>
+          <a:p>
+            <a:pPr algn="ctr"/>
+          </a:p>
+        </p:txBody>
+      </p:sp>
+      <p:sp>
+        <p:nvSpPr>
+          <p:cNvPr id="74" name="Oval 73"/>
+          <p:cNvSpPr/>
+          <p:nvPr/>
+        </p:nvSpPr>
+        <p:spPr>
+          <a:xfrm>
+            <a:off x="9208008" y="1865376"/>
+            <a:ext cx="283464" cy="283464"/>
+          </a:xfrm>
+          <a:prstGeom prst="ellipse">
+            <a:avLst/>
+          </a:prstGeom>
+          <a:solidFill>
+            <a:srgbClr val="0995A9"/>
+          </a:solidFill>
+          <a:ln>
+            <a:solidFill>
+              <a:srgbClr val="0995A9"/>
+            </a:solidFill>
+          </a:ln>
+        </p:spPr>
+        <p:style>
+          <a:lnRef idx="1">
+            <a:schemeClr val="accent1"/>
+          </a:lnRef>
+          <a:fillRef idx="3">
+            <a:schemeClr val="accent1"/>
+          </a:fillRef>
+          <a:effectRef idx="2">
+            <a:schemeClr val="accent1"/>
+          </a:effectRef>
+          <a:fontRef idx="minor">
+            <a:schemeClr val="lt1"/>
+          </a:fontRef>
+        </p:style>
+        <p:txBody>
+          <a:bodyPr rtlCol="0" anchor="ctr"/>
+          <a:lstStyle/>
+          <a:p>
+            <a:pPr algn="ctr"/>
+            <a:r>
+              <a:rPr sz="1000" b="1">
+                <a:solidFill>
+                  <a:srgbClr val="FFFFFF"/>
+                </a:solidFill>
+                <a:latin typeface="Arial"/>
+              </a:rPr>
+              <a:t>4</a:t>
+            </a:r>
+          </a:p>
+        </p:txBody>
+      </p:sp>
+      <p:sp>
+        <p:nvSpPr>
+          <p:cNvPr id="75" name="TextBox 74"/>
+          <p:cNvSpPr txBox="1"/>
+          <p:nvPr/>
+        </p:nvSpPr>
+        <p:spPr>
+          <a:xfrm>
+            <a:off x="9573768" y="1847088"/>
+            <a:ext cx="1618488" cy="256032"/>
+          </a:xfrm>
+          <a:prstGeom prst="rect">
+            <a:avLst/>
+          </a:prstGeom>
+          <a:noFill/>
+        </p:spPr>
+        <p:txBody>
           <a:bodyPr wrap="square" lIns="18288" rIns="18288" tIns="18288" bIns="18288" anchor="t">
             <a:spAutoFit/>
           </a:bodyPr>
           <a:lstStyle/>
           <a:p>
-            <a:pPr algn="ctr"/>
-            <a:r>
-              <a:rPr sz="1300" b="0" i="1">
-                <a:solidFill>
-                  <a:srgbClr val="FFFFFF"/>
+            <a:pPr algn="l"/>
+            <a:r>
+              <a:rPr sz="1100" b="1" i="0">
+                <a:solidFill>
+                  <a:srgbClr val="164D71"/>
                 </a:solidFill>
                 <a:latin typeface="Arial"/>
               </a:rPr>
-              <a:t>What the judge sees: one coherent product, not a collection of promises.</a:t>
-            </a:r>
-          </a:p>
-        </p:txBody>
-      </p:sp>
-      <p:sp>
-        <p:nvSpPr>
-          <p:cNvPr id="64" name="TextBox 63"/>
+              <a:t>FIND TRUTH</a:t>
+            </a:r>
+          </a:p>
+        </p:txBody>
+      </p:sp>
+      <p:sp>
+        <p:nvSpPr>
+          <p:cNvPr id="76" name="TextBox 75"/>
           <p:cNvSpPr txBox="1"/>
           <p:nvPr/>
         </p:nvSpPr>
         <p:spPr>
           <a:xfrm>
-            <a:off x="868680" y="6446520"/>
-            <a:ext cx="2377440" cy="182880"/>
+            <a:off x="9235440" y="2240279"/>
+            <a:ext cx="1911096" cy="658367"/>
           </a:xfrm>
           <a:prstGeom prst="rect">
             <a:avLst/>
@@ -21413,6 +21935,186 @@
           <a:noFill/>
         </p:spPr>
         <p:txBody>
+          <a:bodyPr wrap="square" lIns="9144" rIns="9144" tIns="9144" bIns="9144" anchor="ctr">
+            <a:spAutoFit/>
+          </a:bodyPr>
+          <a:lstStyle/>
+          <a:p>
+            <a:pPr algn="l"/>
+            <a:r>
+              <a:rPr sz="1100" b="0" i="0">
+                <a:solidFill>
+                  <a:srgbClr val="121A22"/>
+                </a:solidFill>
+                <a:latin typeface="Arial"/>
+              </a:rPr>
+              <a:t>Hybrid lexical +
+semantic retrieval.</a:t>
+            </a:r>
+          </a:p>
+        </p:txBody>
+      </p:sp>
+      <p:sp>
+        <p:nvSpPr>
+          <p:cNvPr id="77" name="Rounded Rectangle 76"/>
+          <p:cNvSpPr/>
+          <p:nvPr/>
+        </p:nvSpPr>
+        <p:spPr>
+          <a:xfrm>
+            <a:off x="2258568" y="3456432"/>
+            <a:ext cx="2240280" cy="1280160"/>
+          </a:xfrm>
+          <a:prstGeom prst="roundRect">
+            <a:avLst/>
+          </a:prstGeom>
+          <a:solidFill>
+            <a:srgbClr val="FFFFFF"/>
+          </a:solidFill>
+          <a:ln>
+            <a:solidFill>
+              <a:srgbClr val="FFFFFF"/>
+            </a:solidFill>
+          </a:ln>
+        </p:spPr>
+        <p:style>
+          <a:lnRef idx="1">
+            <a:schemeClr val="accent1"/>
+          </a:lnRef>
+          <a:fillRef idx="3">
+            <a:schemeClr val="accent1"/>
+          </a:fillRef>
+          <a:effectRef idx="2">
+            <a:schemeClr val="accent1"/>
+          </a:effectRef>
+          <a:fontRef idx="minor">
+            <a:schemeClr val="lt1"/>
+          </a:fontRef>
+        </p:style>
+        <p:txBody>
+          <a:bodyPr rtlCol="0" anchor="ctr"/>
+          <a:lstStyle/>
+          <a:p>
+            <a:pPr algn="ctr"/>
+          </a:p>
+        </p:txBody>
+      </p:sp>
+      <p:sp>
+        <p:nvSpPr>
+          <p:cNvPr id="78" name="Rectangle 77"/>
+          <p:cNvSpPr/>
+          <p:nvPr/>
+        </p:nvSpPr>
+        <p:spPr>
+          <a:xfrm>
+            <a:off x="2258568" y="3456432"/>
+            <a:ext cx="2240280" cy="73152"/>
+          </a:xfrm>
+          <a:prstGeom prst="rect">
+            <a:avLst/>
+          </a:prstGeom>
+          <a:solidFill>
+            <a:srgbClr val="0995A9"/>
+          </a:solidFill>
+          <a:ln>
+            <a:solidFill>
+              <a:srgbClr val="0995A9"/>
+            </a:solidFill>
+          </a:ln>
+        </p:spPr>
+        <p:style>
+          <a:lnRef idx="1">
+            <a:schemeClr val="accent1"/>
+          </a:lnRef>
+          <a:fillRef idx="3">
+            <a:schemeClr val="accent1"/>
+          </a:fillRef>
+          <a:effectRef idx="2">
+            <a:schemeClr val="accent1"/>
+          </a:effectRef>
+          <a:fontRef idx="minor">
+            <a:schemeClr val="lt1"/>
+          </a:fontRef>
+        </p:style>
+        <p:txBody>
+          <a:bodyPr rtlCol="0" anchor="ctr"/>
+          <a:lstStyle/>
+          <a:p>
+            <a:pPr algn="ctr"/>
+          </a:p>
+        </p:txBody>
+      </p:sp>
+      <p:sp>
+        <p:nvSpPr>
+          <p:cNvPr id="79" name="Oval 78"/>
+          <p:cNvSpPr/>
+          <p:nvPr/>
+        </p:nvSpPr>
+        <p:spPr>
+          <a:xfrm>
+            <a:off x="2395728" y="3602736"/>
+            <a:ext cx="283464" cy="283464"/>
+          </a:xfrm>
+          <a:prstGeom prst="ellipse">
+            <a:avLst/>
+          </a:prstGeom>
+          <a:solidFill>
+            <a:srgbClr val="0995A9"/>
+          </a:solidFill>
+          <a:ln>
+            <a:solidFill>
+              <a:srgbClr val="0995A9"/>
+            </a:solidFill>
+          </a:ln>
+        </p:spPr>
+        <p:style>
+          <a:lnRef idx="1">
+            <a:schemeClr val="accent1"/>
+          </a:lnRef>
+          <a:fillRef idx="3">
+            <a:schemeClr val="accent1"/>
+          </a:fillRef>
+          <a:effectRef idx="2">
+            <a:schemeClr val="accent1"/>
+          </a:effectRef>
+          <a:fontRef idx="minor">
+            <a:schemeClr val="lt1"/>
+          </a:fontRef>
+        </p:style>
+        <p:txBody>
+          <a:bodyPr rtlCol="0" anchor="ctr"/>
+          <a:lstStyle/>
+          <a:p>
+            <a:pPr algn="ctr"/>
+            <a:r>
+              <a:rPr sz="1000" b="1">
+                <a:solidFill>
+                  <a:srgbClr val="FFFFFF"/>
+                </a:solidFill>
+                <a:latin typeface="Arial"/>
+              </a:rPr>
+              <a:t>5</a:t>
+            </a:r>
+          </a:p>
+        </p:txBody>
+      </p:sp>
+      <p:sp>
+        <p:nvSpPr>
+          <p:cNvPr id="80" name="TextBox 79"/>
+          <p:cNvSpPr txBox="1"/>
+          <p:nvPr/>
+        </p:nvSpPr>
+        <p:spPr>
+          <a:xfrm>
+            <a:off x="2761488" y="3584448"/>
+            <a:ext cx="1618488" cy="256032"/>
+          </a:xfrm>
+          <a:prstGeom prst="rect">
+            <a:avLst/>
+          </a:prstGeom>
+          <a:noFill/>
+        </p:spPr>
+        <p:txBody>
           <a:bodyPr wrap="square" lIns="18288" rIns="18288" tIns="18288" bIns="18288" anchor="t">
             <a:spAutoFit/>
           </a:bodyPr>
@@ -21420,27 +22122,27 @@
           <a:p>
             <a:pPr algn="l"/>
             <a:r>
-              <a:rPr sz="800" b="0" i="0">
-                <a:solidFill>
-                  <a:srgbClr val="FFFFFF"/>
+              <a:rPr sz="1100" b="1" i="0">
+                <a:solidFill>
+                  <a:srgbClr val="164D71"/>
                 </a:solidFill>
                 <a:latin typeface="Arial"/>
               </a:rPr>
-              <a:t>AALTOAI HACKATHON 2026</a:t>
-            </a:r>
-          </a:p>
-        </p:txBody>
-      </p:sp>
-      <p:sp>
-        <p:nvSpPr>
-          <p:cNvPr id="65" name="TextBox 64"/>
+              <a:t>BUILD AUDITOR</a:t>
+            </a:r>
+          </a:p>
+        </p:txBody>
+      </p:sp>
+      <p:sp>
+        <p:nvSpPr>
+          <p:cNvPr id="81" name="TextBox 80"/>
           <p:cNvSpPr txBox="1"/>
           <p:nvPr/>
         </p:nvSpPr>
         <p:spPr>
           <a:xfrm>
-            <a:off x="4709160" y="6446520"/>
-            <a:ext cx="2834640" cy="182880"/>
+            <a:off x="2423160" y="3977639"/>
+            <a:ext cx="1911096" cy="658367"/>
           </a:xfrm>
           <a:prstGeom prst="rect">
             <a:avLst/>
@@ -21448,11 +22150,582 @@
           <a:noFill/>
         </p:spPr>
         <p:txBody>
+          <a:bodyPr wrap="square" lIns="9144" rIns="9144" tIns="9144" bIns="9144" anchor="ctr">
+            <a:spAutoFit/>
+          </a:bodyPr>
+          <a:lstStyle/>
+          <a:p>
+            <a:pPr algn="l"/>
+            <a:r>
+              <a:rPr sz="1100" b="0" i="0">
+                <a:solidFill>
+                  <a:srgbClr val="121A22"/>
+                </a:solidFill>
+                <a:latin typeface="Arial"/>
+              </a:rPr>
+              <a:t>Cases, risk engine,
+Skeptic, reconciliation.</a:t>
+            </a:r>
+          </a:p>
+        </p:txBody>
+      </p:sp>
+      <p:sp>
+        <p:nvSpPr>
+          <p:cNvPr id="82" name="Rounded Rectangle 81"/>
+          <p:cNvSpPr/>
+          <p:nvPr/>
+        </p:nvSpPr>
+        <p:spPr>
+          <a:xfrm>
+            <a:off x="4983480" y="3456432"/>
+            <a:ext cx="2240280" cy="1280160"/>
+          </a:xfrm>
+          <a:prstGeom prst="roundRect">
+            <a:avLst/>
+          </a:prstGeom>
+          <a:solidFill>
+            <a:srgbClr val="FFFFFF"/>
+          </a:solidFill>
+          <a:ln>
+            <a:solidFill>
+              <a:srgbClr val="FFFFFF"/>
+            </a:solidFill>
+          </a:ln>
+        </p:spPr>
+        <p:style>
+          <a:lnRef idx="1">
+            <a:schemeClr val="accent1"/>
+          </a:lnRef>
+          <a:fillRef idx="3">
+            <a:schemeClr val="accent1"/>
+          </a:fillRef>
+          <a:effectRef idx="2">
+            <a:schemeClr val="accent1"/>
+          </a:effectRef>
+          <a:fontRef idx="minor">
+            <a:schemeClr val="lt1"/>
+          </a:fontRef>
+        </p:style>
+        <p:txBody>
+          <a:bodyPr rtlCol="0" anchor="ctr"/>
+          <a:lstStyle/>
+          <a:p>
+            <a:pPr algn="ctr"/>
+          </a:p>
+        </p:txBody>
+      </p:sp>
+      <p:sp>
+        <p:nvSpPr>
+          <p:cNvPr id="83" name="Rectangle 82"/>
+          <p:cNvSpPr/>
+          <p:nvPr/>
+        </p:nvSpPr>
+        <p:spPr>
+          <a:xfrm>
+            <a:off x="4983480" y="3456432"/>
+            <a:ext cx="2240280" cy="73152"/>
+          </a:xfrm>
+          <a:prstGeom prst="rect">
+            <a:avLst/>
+          </a:prstGeom>
+          <a:solidFill>
+            <a:srgbClr val="0995A9"/>
+          </a:solidFill>
+          <a:ln>
+            <a:solidFill>
+              <a:srgbClr val="0995A9"/>
+            </a:solidFill>
+          </a:ln>
+        </p:spPr>
+        <p:style>
+          <a:lnRef idx="1">
+            <a:schemeClr val="accent1"/>
+          </a:lnRef>
+          <a:fillRef idx="3">
+            <a:schemeClr val="accent1"/>
+          </a:fillRef>
+          <a:effectRef idx="2">
+            <a:schemeClr val="accent1"/>
+          </a:effectRef>
+          <a:fontRef idx="minor">
+            <a:schemeClr val="lt1"/>
+          </a:fontRef>
+        </p:style>
+        <p:txBody>
+          <a:bodyPr rtlCol="0" anchor="ctr"/>
+          <a:lstStyle/>
+          <a:p>
+            <a:pPr algn="ctr"/>
+          </a:p>
+        </p:txBody>
+      </p:sp>
+      <p:sp>
+        <p:nvSpPr>
+          <p:cNvPr id="84" name="Oval 83"/>
+          <p:cNvSpPr/>
+          <p:nvPr/>
+        </p:nvSpPr>
+        <p:spPr>
+          <a:xfrm>
+            <a:off x="5120640" y="3602736"/>
+            <a:ext cx="283464" cy="283464"/>
+          </a:xfrm>
+          <a:prstGeom prst="ellipse">
+            <a:avLst/>
+          </a:prstGeom>
+          <a:solidFill>
+            <a:srgbClr val="0995A9"/>
+          </a:solidFill>
+          <a:ln>
+            <a:solidFill>
+              <a:srgbClr val="0995A9"/>
+            </a:solidFill>
+          </a:ln>
+        </p:spPr>
+        <p:style>
+          <a:lnRef idx="1">
+            <a:schemeClr val="accent1"/>
+          </a:lnRef>
+          <a:fillRef idx="3">
+            <a:schemeClr val="accent1"/>
+          </a:fillRef>
+          <a:effectRef idx="2">
+            <a:schemeClr val="accent1"/>
+          </a:effectRef>
+          <a:fontRef idx="minor">
+            <a:schemeClr val="lt1"/>
+          </a:fontRef>
+        </p:style>
+        <p:txBody>
+          <a:bodyPr rtlCol="0" anchor="ctr"/>
+          <a:lstStyle/>
+          <a:p>
+            <a:pPr algn="ctr"/>
+            <a:r>
+              <a:rPr sz="1000" b="1">
+                <a:solidFill>
+                  <a:srgbClr val="FFFFFF"/>
+                </a:solidFill>
+                <a:latin typeface="Arial"/>
+              </a:rPr>
+              <a:t>6</a:t>
+            </a:r>
+          </a:p>
+        </p:txBody>
+      </p:sp>
+      <p:sp>
+        <p:nvSpPr>
+          <p:cNvPr id="85" name="TextBox 84"/>
+          <p:cNvSpPr txBox="1"/>
+          <p:nvPr/>
+        </p:nvSpPr>
+        <p:spPr>
+          <a:xfrm>
+            <a:off x="5486400" y="3584448"/>
+            <a:ext cx="1618488" cy="256032"/>
+          </a:xfrm>
+          <a:prstGeom prst="rect">
+            <a:avLst/>
+          </a:prstGeom>
+          <a:noFill/>
+        </p:spPr>
+        <p:txBody>
           <a:bodyPr wrap="square" lIns="18288" rIns="18288" tIns="18288" bIns="18288" anchor="t">
             <a:spAutoFit/>
           </a:bodyPr>
           <a:lstStyle/>
           <a:p>
+            <a:pPr algn="l"/>
+            <a:r>
+              <a:rPr sz="1100" b="1" i="0">
+                <a:solidFill>
+                  <a:srgbClr val="164D71"/>
+                </a:solidFill>
+                <a:latin typeface="Arial"/>
+              </a:rPr>
+              <a:t>SHOW CHANGE</a:t>
+            </a:r>
+          </a:p>
+        </p:txBody>
+      </p:sp>
+      <p:sp>
+        <p:nvSpPr>
+          <p:cNvPr id="86" name="TextBox 85"/>
+          <p:cNvSpPr txBox="1"/>
+          <p:nvPr/>
+        </p:nvSpPr>
+        <p:spPr>
+          <a:xfrm>
+            <a:off x="5148072" y="3977639"/>
+            <a:ext cx="1911096" cy="658367"/>
+          </a:xfrm>
+          <a:prstGeom prst="rect">
+            <a:avLst/>
+          </a:prstGeom>
+          <a:noFill/>
+        </p:spPr>
+        <p:txBody>
+          <a:bodyPr wrap="square" lIns="9144" rIns="9144" tIns="9144" bIns="9144" anchor="ctr">
+            <a:spAutoFit/>
+          </a:bodyPr>
+          <a:lstStyle/>
+          <a:p>
+            <a:pPr algn="l"/>
+            <a:r>
+              <a:rPr sz="1100" b="0" i="0">
+                <a:solidFill>
+                  <a:srgbClr val="121A22"/>
+                </a:solidFill>
+                <a:latin typeface="Arial"/>
+              </a:rPr>
+              <a:t>Decision Evolution +
+Reconsideration Radar.</a:t>
+            </a:r>
+          </a:p>
+        </p:txBody>
+      </p:sp>
+      <p:sp>
+        <p:nvSpPr>
+          <p:cNvPr id="87" name="Rounded Rectangle 86"/>
+          <p:cNvSpPr/>
+          <p:nvPr/>
+        </p:nvSpPr>
+        <p:spPr>
+          <a:xfrm>
+            <a:off x="7708392" y="3456432"/>
+            <a:ext cx="2240280" cy="1280160"/>
+          </a:xfrm>
+          <a:prstGeom prst="roundRect">
+            <a:avLst/>
+          </a:prstGeom>
+          <a:solidFill>
+            <a:srgbClr val="FFFFFF"/>
+          </a:solidFill>
+          <a:ln>
+            <a:solidFill>
+              <a:srgbClr val="FFFFFF"/>
+            </a:solidFill>
+          </a:ln>
+        </p:spPr>
+        <p:style>
+          <a:lnRef idx="1">
+            <a:schemeClr val="accent1"/>
+          </a:lnRef>
+          <a:fillRef idx="3">
+            <a:schemeClr val="accent1"/>
+          </a:fillRef>
+          <a:effectRef idx="2">
+            <a:schemeClr val="accent1"/>
+          </a:effectRef>
+          <a:fontRef idx="minor">
+            <a:schemeClr val="lt1"/>
+          </a:fontRef>
+        </p:style>
+        <p:txBody>
+          <a:bodyPr rtlCol="0" anchor="ctr"/>
+          <a:lstStyle/>
+          <a:p>
+            <a:pPr algn="ctr"/>
+          </a:p>
+        </p:txBody>
+      </p:sp>
+      <p:sp>
+        <p:nvSpPr>
+          <p:cNvPr id="88" name="Rectangle 87"/>
+          <p:cNvSpPr/>
+          <p:nvPr/>
+        </p:nvSpPr>
+        <p:spPr>
+          <a:xfrm>
+            <a:off x="7708392" y="3456432"/>
+            <a:ext cx="2240280" cy="73152"/>
+          </a:xfrm>
+          <a:prstGeom prst="rect">
+            <a:avLst/>
+          </a:prstGeom>
+          <a:solidFill>
+            <a:srgbClr val="0995A9"/>
+          </a:solidFill>
+          <a:ln>
+            <a:solidFill>
+              <a:srgbClr val="0995A9"/>
+            </a:solidFill>
+          </a:ln>
+        </p:spPr>
+        <p:style>
+          <a:lnRef idx="1">
+            <a:schemeClr val="accent1"/>
+          </a:lnRef>
+          <a:fillRef idx="3">
+            <a:schemeClr val="accent1"/>
+          </a:fillRef>
+          <a:effectRef idx="2">
+            <a:schemeClr val="accent1"/>
+          </a:effectRef>
+          <a:fontRef idx="minor">
+            <a:schemeClr val="lt1"/>
+          </a:fontRef>
+        </p:style>
+        <p:txBody>
+          <a:bodyPr rtlCol="0" anchor="ctr"/>
+          <a:lstStyle/>
+          <a:p>
+            <a:pPr algn="ctr"/>
+          </a:p>
+        </p:txBody>
+      </p:sp>
+      <p:sp>
+        <p:nvSpPr>
+          <p:cNvPr id="89" name="Oval 88"/>
+          <p:cNvSpPr/>
+          <p:nvPr/>
+        </p:nvSpPr>
+        <p:spPr>
+          <a:xfrm>
+            <a:off x="7845552" y="3602736"/>
+            <a:ext cx="283464" cy="283464"/>
+          </a:xfrm>
+          <a:prstGeom prst="ellipse">
+            <a:avLst/>
+          </a:prstGeom>
+          <a:solidFill>
+            <a:srgbClr val="0995A9"/>
+          </a:solidFill>
+          <a:ln>
+            <a:solidFill>
+              <a:srgbClr val="0995A9"/>
+            </a:solidFill>
+          </a:ln>
+        </p:spPr>
+        <p:style>
+          <a:lnRef idx="1">
+            <a:schemeClr val="accent1"/>
+          </a:lnRef>
+          <a:fillRef idx="3">
+            <a:schemeClr val="accent1"/>
+          </a:fillRef>
+          <a:effectRef idx="2">
+            <a:schemeClr val="accent1"/>
+          </a:effectRef>
+          <a:fontRef idx="minor">
+            <a:schemeClr val="lt1"/>
+          </a:fontRef>
+        </p:style>
+        <p:txBody>
+          <a:bodyPr rtlCol="0" anchor="ctr"/>
+          <a:lstStyle/>
+          <a:p>
+            <a:pPr algn="ctr"/>
+            <a:r>
+              <a:rPr sz="1000" b="1">
+                <a:solidFill>
+                  <a:srgbClr val="FFFFFF"/>
+                </a:solidFill>
+                <a:latin typeface="Arial"/>
+              </a:rPr>
+              <a:t>7</a:t>
+            </a:r>
+          </a:p>
+        </p:txBody>
+      </p:sp>
+      <p:sp>
+        <p:nvSpPr>
+          <p:cNvPr id="90" name="TextBox 89"/>
+          <p:cNvSpPr txBox="1"/>
+          <p:nvPr/>
+        </p:nvSpPr>
+        <p:spPr>
+          <a:xfrm>
+            <a:off x="8211312" y="3584448"/>
+            <a:ext cx="1618488" cy="256032"/>
+          </a:xfrm>
+          <a:prstGeom prst="rect">
+            <a:avLst/>
+          </a:prstGeom>
+          <a:noFill/>
+        </p:spPr>
+        <p:txBody>
+          <a:bodyPr wrap="square" lIns="18288" rIns="18288" tIns="18288" bIns="18288" anchor="t">
+            <a:spAutoFit/>
+          </a:bodyPr>
+          <a:lstStyle/>
+          <a:p>
+            <a:pPr algn="l"/>
+            <a:r>
+              <a:rPr sz="1100" b="1" i="0">
+                <a:solidFill>
+                  <a:srgbClr val="164D71"/>
+                </a:solidFill>
+                <a:latin typeface="Arial"/>
+              </a:rPr>
+              <a:t>PROVE EDGES</a:t>
+            </a:r>
+          </a:p>
+        </p:txBody>
+      </p:sp>
+      <p:sp>
+        <p:nvSpPr>
+          <p:cNvPr id="91" name="TextBox 90"/>
+          <p:cNvSpPr txBox="1"/>
+          <p:nvPr/>
+        </p:nvSpPr>
+        <p:spPr>
+          <a:xfrm>
+            <a:off x="7872983" y="3977639"/>
+            <a:ext cx="1911096" cy="658367"/>
+          </a:xfrm>
+          <a:prstGeom prst="rect">
+            <a:avLst/>
+          </a:prstGeom>
+          <a:noFill/>
+        </p:spPr>
+        <p:txBody>
+          <a:bodyPr wrap="square" lIns="9144" rIns="9144" tIns="9144" bIns="9144" anchor="ctr">
+            <a:spAutoFit/>
+          </a:bodyPr>
+          <a:lstStyle/>
+          <a:p>
+            <a:pPr algn="l"/>
+            <a:r>
+              <a:rPr sz="1100" b="0" i="0">
+                <a:solidFill>
+                  <a:srgbClr val="121A22"/>
+                </a:solidFill>
+                <a:latin typeface="Arial"/>
+              </a:rPr>
+              <a:t>Pseudonymization, reversal,
+tests and demo.</a:t>
+            </a:r>
+          </a:p>
+        </p:txBody>
+      </p:sp>
+      <p:sp>
+        <p:nvSpPr>
+          <p:cNvPr id="92" name="TextBox 91"/>
+          <p:cNvSpPr txBox="1"/>
+          <p:nvPr/>
+        </p:nvSpPr>
+        <p:spPr>
+          <a:xfrm>
+            <a:off x="1783080" y="5138928"/>
+            <a:ext cx="8686800" cy="310896"/>
+          </a:xfrm>
+          <a:prstGeom prst="rect">
+            <a:avLst/>
+          </a:prstGeom>
+          <a:noFill/>
+        </p:spPr>
+        <p:txBody>
+          <a:bodyPr wrap="square" lIns="18288" rIns="18288" tIns="18288" bIns="18288" anchor="t">
+            <a:spAutoFit/>
+          </a:bodyPr>
+          <a:lstStyle/>
+          <a:p>
+            <a:pPr algn="ctr"/>
+            <a:r>
+              <a:rPr sz="1600" b="1" i="0">
+                <a:solidFill>
+                  <a:srgbClr val="FFFFFF"/>
+                </a:solidFill>
+                <a:latin typeface="Arial"/>
+              </a:rPr>
+              <a:t>PLAN  →  BUILD  →  PROVE  →  DEMO</a:t>
+            </a:r>
+          </a:p>
+        </p:txBody>
+      </p:sp>
+      <p:sp>
+        <p:nvSpPr>
+          <p:cNvPr id="93" name="TextBox 92"/>
+          <p:cNvSpPr txBox="1"/>
+          <p:nvPr/>
+        </p:nvSpPr>
+        <p:spPr>
+          <a:xfrm>
+            <a:off x="1600200" y="5513832"/>
+            <a:ext cx="8961120" cy="256032"/>
+          </a:xfrm>
+          <a:prstGeom prst="rect">
+            <a:avLst/>
+          </a:prstGeom>
+          <a:noFill/>
+        </p:spPr>
+        <p:txBody>
+          <a:bodyPr wrap="square" lIns="18288" rIns="18288" tIns="18288" bIns="18288" anchor="t">
+            <a:spAutoFit/>
+          </a:bodyPr>
+          <a:lstStyle/>
+          <a:p>
+            <a:pPr algn="ctr"/>
+            <a:r>
+              <a:rPr sz="1300" b="0" i="1">
+                <a:solidFill>
+                  <a:srgbClr val="FFFFFF"/>
+                </a:solidFill>
+                <a:latin typeface="Arial"/>
+              </a:rPr>
+              <a:t>One coherent product, from raw archive to an auditable decision.</a:t>
+            </a:r>
+          </a:p>
+        </p:txBody>
+      </p:sp>
+      <p:sp>
+        <p:nvSpPr>
+          <p:cNvPr id="94" name="TextBox 93"/>
+          <p:cNvSpPr txBox="1"/>
+          <p:nvPr/>
+        </p:nvSpPr>
+        <p:spPr>
+          <a:xfrm>
+            <a:off x="868680" y="6446520"/>
+            <a:ext cx="2377440" cy="182880"/>
+          </a:xfrm>
+          <a:prstGeom prst="rect">
+            <a:avLst/>
+          </a:prstGeom>
+          <a:noFill/>
+        </p:spPr>
+        <p:txBody>
+          <a:bodyPr wrap="square" lIns="18288" rIns="18288" tIns="18288" bIns="18288" anchor="t">
+            <a:spAutoFit/>
+          </a:bodyPr>
+          <a:lstStyle/>
+          <a:p>
+            <a:pPr algn="l"/>
+            <a:r>
+              <a:rPr sz="800" b="0" i="0">
+                <a:solidFill>
+                  <a:srgbClr val="FFFFFF"/>
+                </a:solidFill>
+                <a:latin typeface="Arial"/>
+              </a:rPr>
+              <a:t>AALTOAI HACKATHON 2026</a:t>
+            </a:r>
+          </a:p>
+        </p:txBody>
+      </p:sp>
+      <p:sp>
+        <p:nvSpPr>
+          <p:cNvPr id="95" name="TextBox 94"/>
+          <p:cNvSpPr txBox="1"/>
+          <p:nvPr/>
+        </p:nvSpPr>
+        <p:spPr>
+          <a:xfrm>
+            <a:off x="4709160" y="6446520"/>
+            <a:ext cx="2834640" cy="182880"/>
+          </a:xfrm>
+          <a:prstGeom prst="rect">
+            <a:avLst/>
+          </a:prstGeom>
+          <a:noFill/>
+        </p:spPr>
+        <p:txBody>
+          <a:bodyPr wrap="square" lIns="18288" rIns="18288" tIns="18288" bIns="18288" anchor="t">
+            <a:spAutoFit/>
+          </a:bodyPr>
+          <a:lstStyle/>
+          <a:p>
             <a:pPr algn="ctr"/>
             <a:r>
               <a:rPr sz="800" b="0" i="0">
@@ -21468,7 +22741,7 @@
       </p:sp>
       <p:sp>
         <p:nvSpPr>
-          <p:cNvPr id="66" name="TextBox 65"/>
+          <p:cNvPr id="96" name="TextBox 95"/>
           <p:cNvSpPr txBox="1"/>
           <p:nvPr/>
         </p:nvSpPr>
@@ -22142,7 +23415,7 @@
           <a:p>
             <a:pPr algn="l"/>
             <a:r>
-              <a:rPr sz="2800" b="1" i="0">
+              <a:rPr sz="3000" b="1" i="0">
                 <a:solidFill>
                   <a:srgbClr val="000000"/>
                 </a:solidFill>
@@ -26098,7 +27371,7 @@
           <a:p>
             <a:pPr algn="l"/>
             <a:r>
-              <a:rPr sz="3100" b="1" i="0">
+              <a:rPr sz="3000" b="1" i="0">
                 <a:solidFill>
                   <a:srgbClr val="000000"/>
                 </a:solidFill>
@@ -27402,7 +28675,7 @@
           <a:p>
             <a:pPr algn="l"/>
             <a:r>
-              <a:rPr sz="3200" b="1" i="0">
+              <a:rPr sz="3000" b="1" i="0">
                 <a:solidFill>
                   <a:srgbClr val="FFFFFF"/>
                 </a:solidFill>
@@ -27476,7 +28749,7 @@
               </a:spcAft>
             </a:pPr>
             <a:r>
-              <a:rPr sz="1700" b="1">
+              <a:rPr sz="1600" b="1">
                 <a:solidFill>
                   <a:srgbClr val="164D71"/>
                 </a:solidFill>
@@ -27508,7 +28781,7 @@
               </a:spcAft>
             </a:pPr>
             <a:r>
-              <a:rPr sz="1700" b="1">
+              <a:rPr sz="1600" b="1">
                 <a:solidFill>
                   <a:srgbClr val="164D71"/>
                 </a:solidFill>
@@ -27563,7 +28836,7 @@
               </a:spcAft>
             </a:pPr>
             <a:r>
-              <a:rPr sz="1700" b="1">
+              <a:rPr sz="1600" b="1">
                 <a:solidFill>
                   <a:srgbClr val="164D71"/>
                 </a:solidFill>
@@ -27595,7 +28868,7 @@
               </a:spcAft>
             </a:pPr>
             <a:r>
-              <a:rPr sz="1700" b="1">
+              <a:rPr sz="1600" b="1">
                 <a:solidFill>
                   <a:srgbClr val="164D71"/>
                 </a:solidFill>
@@ -27895,13 +29168,13 @@
           <a:p>
             <a:pPr algn="l"/>
             <a:r>
-              <a:rPr sz="2200" b="1" i="0">
+              <a:rPr sz="3000" b="1" i="0">
                 <a:solidFill>
                   <a:srgbClr val="000000"/>
                 </a:solidFill>
                 <a:latin typeface="Arial"/>
               </a:rPr>
-              <a:t>THE ANSWER IS A CASE — NOT A CHAT</a:t>
+              <a:t>A CASE, NOT A CHAT</a:t>
             </a:r>
           </a:p>
         </p:txBody>

</xml_diff>